<commit_message>
modify classificatino pptx, not finished
</commit_message>
<xml_diff>
--- a/20243/Part 3-Classification/classification_logistic_regression_diabetes.pptx
+++ b/20243/Part 3-Classification/classification_logistic_regression_diabetes.pptx
@@ -16,10 +16,6 @@
     <p:sldId id="465" r:id="rId13"/>
     <p:sldId id="464" r:id="rId14"/>
     <p:sldId id="461" r:id="rId15"/>
-    <p:sldId id="466" r:id="rId16"/>
-    <p:sldId id="467" r:id="rId17"/>
-    <p:sldId id="468" r:id="rId18"/>
-    <p:sldId id="469" r:id="rId19"/>
   </p:sldIdLst>
   <p:sldSz cx="12192000" cy="6858000"/>
   <p:notesSz cx="6858000" cy="9144000"/>
@@ -126,19 +122,287 @@
 </p:presentation>
 </file>
 
-<file path=ppt/revisionInfo.xml><?xml version="1.0" encoding="utf-8"?>
-<p1510:revInfo xmlns:a="http://schemas.openxmlformats.org/drawingml/2006/main" xmlns:r="http://schemas.openxmlformats.org/officeDocument/2006/relationships" xmlns:p1510="http://schemas.microsoft.com/office/powerpoint/2015/10/main">
-  <p1510:revLst>
-    <p1510:client id="{161A7FAA-B398-4429-9FC2-656B0895AF0F}" v="51" dt="2025-07-16T08:30:59.062"/>
-    <p1510:client id="{183AE7D0-0422-8839-EC6E-29E0859D7097}" v="67" dt="2025-07-16T14:35:10.276"/>
-    <p1510:client id="{B004DB22-B418-47BE-85DF-64F58F0EEE29}" v="60" dt="2025-07-17T05:28:48.640"/>
-    <p1510:client id="{F585A28F-34F7-4D28-B641-78252DAB29E0}" v="1" dt="2025-07-16T09:16:07.771"/>
-  </p1510:revLst>
-</p1510:revInfo>
-</file>
-
 <file path=ppt/changesInfos/changesInfo1.xml><?xml version="1.0" encoding="utf-8"?>
 <pc:chgInfo xmlns:a="http://schemas.openxmlformats.org/drawingml/2006/main" xmlns:r="http://schemas.openxmlformats.org/officeDocument/2006/relationships" xmlns:ac="http://schemas.microsoft.com/office/drawing/2013/main/command" xmlns:pc="http://schemas.microsoft.com/office/powerpoint/2013/main/command">
+  <pc:docChgLst>
+    <pc:chgData name="Mohammed Fasha" userId="cc64f42d-a1a6-4f08-b97b-0c37f877119f" providerId="ADAL" clId="{30B40AC3-5669-44FB-A9B9-80E8E88C9E32}"/>
+    <pc:docChg chg="undo custSel addSld delSld modSld">
+      <pc:chgData name="Mohammed Fasha" userId="cc64f42d-a1a6-4f08-b97b-0c37f877119f" providerId="ADAL" clId="{30B40AC3-5669-44FB-A9B9-80E8E88C9E32}" dt="2024-10-21T08:00:22.594" v="429" actId="207"/>
+      <pc:docMkLst>
+        <pc:docMk/>
+      </pc:docMkLst>
+      <pc:sldChg chg="modSp">
+        <pc:chgData name="Mohammed Fasha" userId="cc64f42d-a1a6-4f08-b97b-0c37f877119f" providerId="ADAL" clId="{30B40AC3-5669-44FB-A9B9-80E8E88C9E32}" dt="2024-10-21T07:01:55.743" v="0" actId="207"/>
+        <pc:sldMkLst>
+          <pc:docMk/>
+          <pc:sldMk cId="4051642265" sldId="268"/>
+        </pc:sldMkLst>
+      </pc:sldChg>
+      <pc:sldChg chg="modSp">
+        <pc:chgData name="Mohammed Fasha" userId="cc64f42d-a1a6-4f08-b97b-0c37f877119f" providerId="ADAL" clId="{30B40AC3-5669-44FB-A9B9-80E8E88C9E32}" dt="2024-10-21T07:23:44.619" v="11"/>
+        <pc:sldMkLst>
+          <pc:docMk/>
+          <pc:sldMk cId="1260131707" sldId="277"/>
+        </pc:sldMkLst>
+      </pc:sldChg>
+      <pc:sldChg chg="addSp delSp modSp add del">
+        <pc:chgData name="Mohammed Fasha" userId="cc64f42d-a1a6-4f08-b97b-0c37f877119f" providerId="ADAL" clId="{30B40AC3-5669-44FB-A9B9-80E8E88C9E32}" dt="2024-10-21T07:42:04.586" v="230" actId="2696"/>
+        <pc:sldMkLst>
+          <pc:docMk/>
+          <pc:sldMk cId="3743348053" sldId="456"/>
+        </pc:sldMkLst>
+      </pc:sldChg>
+      <pc:sldChg chg="addSp delSp modSp add del">
+        <pc:chgData name="Mohammed Fasha" userId="cc64f42d-a1a6-4f08-b97b-0c37f877119f" providerId="ADAL" clId="{30B40AC3-5669-44FB-A9B9-80E8E88C9E32}" dt="2024-10-21T07:43:37.674" v="248" actId="2696"/>
+        <pc:sldMkLst>
+          <pc:docMk/>
+          <pc:sldMk cId="1914310957" sldId="457"/>
+        </pc:sldMkLst>
+      </pc:sldChg>
+      <pc:sldChg chg="addSp delSp modSp add del">
+        <pc:chgData name="Mohammed Fasha" userId="cc64f42d-a1a6-4f08-b97b-0c37f877119f" providerId="ADAL" clId="{30B40AC3-5669-44FB-A9B9-80E8E88C9E32}" dt="2024-10-21T07:43:44.968" v="251" actId="2696"/>
+        <pc:sldMkLst>
+          <pc:docMk/>
+          <pc:sldMk cId="1563484610" sldId="458"/>
+        </pc:sldMkLst>
+      </pc:sldChg>
+      <pc:sldChg chg="addSp delSp modSp add del">
+        <pc:chgData name="Mohammed Fasha" userId="cc64f42d-a1a6-4f08-b97b-0c37f877119f" providerId="ADAL" clId="{30B40AC3-5669-44FB-A9B9-80E8E88C9E32}" dt="2024-10-21T07:43:48.926" v="253" actId="2696"/>
+        <pc:sldMkLst>
+          <pc:docMk/>
+          <pc:sldMk cId="3782395966" sldId="459"/>
+        </pc:sldMkLst>
+      </pc:sldChg>
+      <pc:sldChg chg="addSp delSp modSp add">
+        <pc:chgData name="Mohammed Fasha" userId="cc64f42d-a1a6-4f08-b97b-0c37f877119f" providerId="ADAL" clId="{30B40AC3-5669-44FB-A9B9-80E8E88C9E32}" dt="2024-10-21T07:58:46.456" v="410" actId="207"/>
+        <pc:sldMkLst>
+          <pc:docMk/>
+          <pc:sldMk cId="713799975" sldId="460"/>
+        </pc:sldMkLst>
+      </pc:sldChg>
+      <pc:sldChg chg="addSp delSp modSp add">
+        <pc:chgData name="Mohammed Fasha" userId="cc64f42d-a1a6-4f08-b97b-0c37f877119f" providerId="ADAL" clId="{30B40AC3-5669-44FB-A9B9-80E8E88C9E32}" dt="2024-10-21T08:00:22.594" v="429" actId="207"/>
+        <pc:sldMkLst>
+          <pc:docMk/>
+          <pc:sldMk cId="1559487564" sldId="461"/>
+        </pc:sldMkLst>
+      </pc:sldChg>
+      <pc:sldChg chg="addSp delSp modSp add">
+        <pc:chgData name="Mohammed Fasha" userId="cc64f42d-a1a6-4f08-b97b-0c37f877119f" providerId="ADAL" clId="{30B40AC3-5669-44FB-A9B9-80E8E88C9E32}" dt="2024-10-21T07:54:42.825" v="379" actId="207"/>
+        <pc:sldMkLst>
+          <pc:docMk/>
+          <pc:sldMk cId="3087456825" sldId="462"/>
+        </pc:sldMkLst>
+      </pc:sldChg>
+      <pc:sldChg chg="addSp delSp modSp add">
+        <pc:chgData name="Mohammed Fasha" userId="cc64f42d-a1a6-4f08-b97b-0c37f877119f" providerId="ADAL" clId="{30B40AC3-5669-44FB-A9B9-80E8E88C9E32}" dt="2024-10-21T07:56:10.314" v="392" actId="14100"/>
+        <pc:sldMkLst>
+          <pc:docMk/>
+          <pc:sldMk cId="1869085755" sldId="463"/>
+        </pc:sldMkLst>
+      </pc:sldChg>
+      <pc:sldChg chg="addSp modSp add">
+        <pc:chgData name="Mohammed Fasha" userId="cc64f42d-a1a6-4f08-b97b-0c37f877119f" providerId="ADAL" clId="{30B40AC3-5669-44FB-A9B9-80E8E88C9E32}" dt="2024-10-21T07:56:43.392" v="396" actId="5793"/>
+        <pc:sldMkLst>
+          <pc:docMk/>
+          <pc:sldMk cId="4139560" sldId="464"/>
+        </pc:sldMkLst>
+      </pc:sldChg>
+      <pc:sldChg chg="addSp modSp add">
+        <pc:chgData name="Mohammed Fasha" userId="cc64f42d-a1a6-4f08-b97b-0c37f877119f" providerId="ADAL" clId="{30B40AC3-5669-44FB-A9B9-80E8E88C9E32}" dt="2024-10-21T07:57:39.264" v="404" actId="207"/>
+        <pc:sldMkLst>
+          <pc:docMk/>
+          <pc:sldMk cId="277181267" sldId="465"/>
+        </pc:sldMkLst>
+      </pc:sldChg>
+    </pc:docChg>
+  </pc:docChgLst>
+  <pc:docChgLst>
+    <pc:chgData name="Mohammed Fasha" userId="cc64f42d-a1a6-4f08-b97b-0c37f877119f" providerId="ADAL" clId="{D1859E10-E91F-4CD4-B9AD-657F2116AC8C}"/>
+    <pc:docChg chg="custSel modMainMaster">
+      <pc:chgData name="Mohammed Fasha" userId="cc64f42d-a1a6-4f08-b97b-0c37f877119f" providerId="ADAL" clId="{D1859E10-E91F-4CD4-B9AD-657F2116AC8C}" dt="2024-11-09T05:23:14.444" v="3" actId="1076"/>
+      <pc:docMkLst>
+        <pc:docMk/>
+      </pc:docMkLst>
+      <pc:sldMasterChg chg="addSp delSp modSp mod">
+        <pc:chgData name="Mohammed Fasha" userId="cc64f42d-a1a6-4f08-b97b-0c37f877119f" providerId="ADAL" clId="{D1859E10-E91F-4CD4-B9AD-657F2116AC8C}" dt="2024-11-09T05:23:14.444" v="3" actId="1076"/>
+        <pc:sldMasterMkLst>
+          <pc:docMk/>
+          <pc:sldMasterMk cId="2573801746" sldId="2147483648"/>
+        </pc:sldMasterMkLst>
+      </pc:sldMasterChg>
+    </pc:docChg>
+  </pc:docChgLst>
+  <pc:docChgLst>
+    <pc:chgData name="Mohammed Fasha" userId="cc64f42d-a1a6-4f08-b97b-0c37f877119f" providerId="ADAL" clId="{985CD171-9E4A-4264-B045-872AAA800AE3}"/>
+    <pc:docChg chg="undo custSel addSld delSld modSld sldOrd">
+      <pc:chgData name="Mohammed Fasha" userId="cc64f42d-a1a6-4f08-b97b-0c37f877119f" providerId="ADAL" clId="{985CD171-9E4A-4264-B045-872AAA800AE3}" dt="2024-10-16T08:02:59.311" v="633" actId="404"/>
+      <pc:docMkLst>
+        <pc:docMk/>
+      </pc:docMkLst>
+      <pc:sldChg chg="modSp">
+        <pc:chgData name="Mohammed Fasha" userId="cc64f42d-a1a6-4f08-b97b-0c37f877119f" providerId="ADAL" clId="{985CD171-9E4A-4264-B045-872AAA800AE3}" dt="2024-10-16T07:15:21.970" v="481" actId="27636"/>
+        <pc:sldMkLst>
+          <pc:docMk/>
+          <pc:sldMk cId="1162554463" sldId="257"/>
+        </pc:sldMkLst>
+      </pc:sldChg>
+      <pc:sldChg chg="addSp modSp">
+        <pc:chgData name="Mohammed Fasha" userId="cc64f42d-a1a6-4f08-b97b-0c37f877119f" providerId="ADAL" clId="{985CD171-9E4A-4264-B045-872AAA800AE3}" dt="2024-10-16T07:06:03.884" v="437" actId="1076"/>
+        <pc:sldMkLst>
+          <pc:docMk/>
+          <pc:sldMk cId="706735111" sldId="258"/>
+        </pc:sldMkLst>
+      </pc:sldChg>
+      <pc:sldChg chg="addSp delSp modSp ord">
+        <pc:chgData name="Mohammed Fasha" userId="cc64f42d-a1a6-4f08-b97b-0c37f877119f" providerId="ADAL" clId="{985CD171-9E4A-4264-B045-872AAA800AE3}" dt="2024-10-16T07:00:38.831" v="349" actId="207"/>
+        <pc:sldMkLst>
+          <pc:docMk/>
+          <pc:sldMk cId="4289469650" sldId="261"/>
+        </pc:sldMkLst>
+      </pc:sldChg>
+      <pc:sldChg chg="addSp delSp modSp ord">
+        <pc:chgData name="Mohammed Fasha" userId="cc64f42d-a1a6-4f08-b97b-0c37f877119f" providerId="ADAL" clId="{985CD171-9E4A-4264-B045-872AAA800AE3}" dt="2024-10-16T06:46:39.846" v="191" actId="14100"/>
+        <pc:sldMkLst>
+          <pc:docMk/>
+          <pc:sldMk cId="4130133658" sldId="262"/>
+        </pc:sldMkLst>
+      </pc:sldChg>
+      <pc:sldChg chg="addSp modSp ord">
+        <pc:chgData name="Mohammed Fasha" userId="cc64f42d-a1a6-4f08-b97b-0c37f877119f" providerId="ADAL" clId="{985CD171-9E4A-4264-B045-872AAA800AE3}" dt="2024-10-16T07:55:18.576" v="615" actId="207"/>
+        <pc:sldMkLst>
+          <pc:docMk/>
+          <pc:sldMk cId="4074862586" sldId="263"/>
+        </pc:sldMkLst>
+      </pc:sldChg>
+      <pc:sldChg chg="addSp delSp modSp add">
+        <pc:chgData name="Mohammed Fasha" userId="cc64f42d-a1a6-4f08-b97b-0c37f877119f" providerId="ADAL" clId="{985CD171-9E4A-4264-B045-872AAA800AE3}" dt="2024-10-16T07:54:33.790" v="610"/>
+        <pc:sldMkLst>
+          <pc:docMk/>
+          <pc:sldMk cId="2611575643" sldId="264"/>
+        </pc:sldMkLst>
+      </pc:sldChg>
+      <pc:sldChg chg="addSp modSp add ord">
+        <pc:chgData name="Mohammed Fasha" userId="cc64f42d-a1a6-4f08-b97b-0c37f877119f" providerId="ADAL" clId="{985CD171-9E4A-4264-B045-872AAA800AE3}" dt="2024-10-16T07:08:38.092" v="475" actId="27636"/>
+        <pc:sldMkLst>
+          <pc:docMk/>
+          <pc:sldMk cId="335199774" sldId="265"/>
+        </pc:sldMkLst>
+      </pc:sldChg>
+      <pc:sldChg chg="addSp delSp modSp add">
+        <pc:chgData name="Mohammed Fasha" userId="cc64f42d-a1a6-4f08-b97b-0c37f877119f" providerId="ADAL" clId="{985CD171-9E4A-4264-B045-872AAA800AE3}" dt="2024-10-16T07:02:57.901" v="385" actId="27636"/>
+        <pc:sldMkLst>
+          <pc:docMk/>
+          <pc:sldMk cId="2810357117" sldId="266"/>
+        </pc:sldMkLst>
+      </pc:sldChg>
+      <pc:sldChg chg="addSp modSp add">
+        <pc:chgData name="Mohammed Fasha" userId="cc64f42d-a1a6-4f08-b97b-0c37f877119f" providerId="ADAL" clId="{985CD171-9E4A-4264-B045-872AAA800AE3}" dt="2024-10-16T07:03:19.455" v="397" actId="27636"/>
+        <pc:sldMkLst>
+          <pc:docMk/>
+          <pc:sldMk cId="2433706687" sldId="267"/>
+        </pc:sldMkLst>
+      </pc:sldChg>
+      <pc:sldChg chg="addSp modSp add">
+        <pc:chgData name="Mohammed Fasha" userId="cc64f42d-a1a6-4f08-b97b-0c37f877119f" providerId="ADAL" clId="{985CD171-9E4A-4264-B045-872AAA800AE3}" dt="2024-10-16T08:00:33.047" v="616" actId="14100"/>
+        <pc:sldMkLst>
+          <pc:docMk/>
+          <pc:sldMk cId="4051642265" sldId="268"/>
+        </pc:sldMkLst>
+      </pc:sldChg>
+      <pc:sldChg chg="addSp modSp add">
+        <pc:chgData name="Mohammed Fasha" userId="cc64f42d-a1a6-4f08-b97b-0c37f877119f" providerId="ADAL" clId="{985CD171-9E4A-4264-B045-872AAA800AE3}" dt="2024-10-16T07:04:05.205" v="412" actId="14100"/>
+        <pc:sldMkLst>
+          <pc:docMk/>
+          <pc:sldMk cId="87410777" sldId="269"/>
+        </pc:sldMkLst>
+      </pc:sldChg>
+      <pc:sldChg chg="addSp modSp add">
+        <pc:chgData name="Mohammed Fasha" userId="cc64f42d-a1a6-4f08-b97b-0c37f877119f" providerId="ADAL" clId="{985CD171-9E4A-4264-B045-872AAA800AE3}" dt="2024-10-16T07:04:34.185" v="419" actId="14100"/>
+        <pc:sldMkLst>
+          <pc:docMk/>
+          <pc:sldMk cId="595502031" sldId="270"/>
+        </pc:sldMkLst>
+      </pc:sldChg>
+      <pc:sldChg chg="addSp modSp add ord">
+        <pc:chgData name="Mohammed Fasha" userId="cc64f42d-a1a6-4f08-b97b-0c37f877119f" providerId="ADAL" clId="{985CD171-9E4A-4264-B045-872AAA800AE3}" dt="2024-10-16T07:03:52.480" v="404" actId="27636"/>
+        <pc:sldMkLst>
+          <pc:docMk/>
+          <pc:sldMk cId="3925652072" sldId="271"/>
+        </pc:sldMkLst>
+      </pc:sldChg>
+      <pc:sldChg chg="addSp modSp add">
+        <pc:chgData name="Mohammed Fasha" userId="cc64f42d-a1a6-4f08-b97b-0c37f877119f" providerId="ADAL" clId="{985CD171-9E4A-4264-B045-872AAA800AE3}" dt="2024-10-16T07:04:42.805" v="424" actId="1076"/>
+        <pc:sldMkLst>
+          <pc:docMk/>
+          <pc:sldMk cId="463115072" sldId="272"/>
+        </pc:sldMkLst>
+      </pc:sldChg>
+      <pc:sldChg chg="addSp modSp add">
+        <pc:chgData name="Mohammed Fasha" userId="cc64f42d-a1a6-4f08-b97b-0c37f877119f" providerId="ADAL" clId="{985CD171-9E4A-4264-B045-872AAA800AE3}" dt="2024-10-16T07:06:32.789" v="441" actId="14100"/>
+        <pc:sldMkLst>
+          <pc:docMk/>
+          <pc:sldMk cId="3668955903" sldId="273"/>
+        </pc:sldMkLst>
+      </pc:sldChg>
+      <pc:sldChg chg="addSp delSp modSp add">
+        <pc:chgData name="Mohammed Fasha" userId="cc64f42d-a1a6-4f08-b97b-0c37f877119f" providerId="ADAL" clId="{985CD171-9E4A-4264-B045-872AAA800AE3}" dt="2024-10-16T07:06:45.628" v="449" actId="27636"/>
+        <pc:sldMkLst>
+          <pc:docMk/>
+          <pc:sldMk cId="3192380798" sldId="274"/>
+        </pc:sldMkLst>
+      </pc:sldChg>
+      <pc:sldChg chg="addSp modSp add">
+        <pc:chgData name="Mohammed Fasha" userId="cc64f42d-a1a6-4f08-b97b-0c37f877119f" providerId="ADAL" clId="{985CD171-9E4A-4264-B045-872AAA800AE3}" dt="2024-10-16T07:07:23.747" v="460" actId="20577"/>
+        <pc:sldMkLst>
+          <pc:docMk/>
+          <pc:sldMk cId="3898002179" sldId="275"/>
+        </pc:sldMkLst>
+      </pc:sldChg>
+      <pc:sldChg chg="addSp modSp add">
+        <pc:chgData name="Mohammed Fasha" userId="cc64f42d-a1a6-4f08-b97b-0c37f877119f" providerId="ADAL" clId="{985CD171-9E4A-4264-B045-872AAA800AE3}" dt="2024-10-16T07:07:35.379" v="465" actId="27636"/>
+        <pc:sldMkLst>
+          <pc:docMk/>
+          <pc:sldMk cId="1503352162" sldId="276"/>
+        </pc:sldMkLst>
+      </pc:sldChg>
+      <pc:sldChg chg="addSp delSp modSp add">
+        <pc:chgData name="Mohammed Fasha" userId="cc64f42d-a1a6-4f08-b97b-0c37f877119f" providerId="ADAL" clId="{985CD171-9E4A-4264-B045-872AAA800AE3}" dt="2024-10-16T07:28:38.184" v="537" actId="948"/>
+        <pc:sldMkLst>
+          <pc:docMk/>
+          <pc:sldMk cId="1260131707" sldId="277"/>
+        </pc:sldMkLst>
+      </pc:sldChg>
+      <pc:sldChg chg="addSp modSp add ord">
+        <pc:chgData name="Mohammed Fasha" userId="cc64f42d-a1a6-4f08-b97b-0c37f877119f" providerId="ADAL" clId="{985CD171-9E4A-4264-B045-872AAA800AE3}" dt="2024-10-16T07:16:54.093" v="501" actId="27636"/>
+        <pc:sldMkLst>
+          <pc:docMk/>
+          <pc:sldMk cId="1324937023" sldId="280"/>
+        </pc:sldMkLst>
+      </pc:sldChg>
+      <pc:sldChg chg="addSp delSp modSp add">
+        <pc:chgData name="Mohammed Fasha" userId="cc64f42d-a1a6-4f08-b97b-0c37f877119f" providerId="ADAL" clId="{985CD171-9E4A-4264-B045-872AAA800AE3}" dt="2024-10-16T07:44:30.797" v="606" actId="5793"/>
+        <pc:sldMkLst>
+          <pc:docMk/>
+          <pc:sldMk cId="4085727926" sldId="281"/>
+        </pc:sldMkLst>
+      </pc:sldChg>
+      <pc:sldChg chg="addSp modSp add">
+        <pc:chgData name="Mohammed Fasha" userId="cc64f42d-a1a6-4f08-b97b-0c37f877119f" providerId="ADAL" clId="{985CD171-9E4A-4264-B045-872AAA800AE3}" dt="2024-10-16T08:01:33.772" v="621" actId="403"/>
+        <pc:sldMkLst>
+          <pc:docMk/>
+          <pc:sldMk cId="156012141" sldId="282"/>
+        </pc:sldMkLst>
+      </pc:sldChg>
+      <pc:sldChg chg="addSp modSp add">
+        <pc:chgData name="Mohammed Fasha" userId="cc64f42d-a1a6-4f08-b97b-0c37f877119f" providerId="ADAL" clId="{985CD171-9E4A-4264-B045-872AAA800AE3}" dt="2024-10-16T08:02:59.311" v="633" actId="404"/>
+        <pc:sldMkLst>
+          <pc:docMk/>
+          <pc:sldMk cId="248623450" sldId="284"/>
+        </pc:sldMkLst>
+      </pc:sldChg>
+    </pc:docChg>
+  </pc:docChgLst>
   <pc:docChgLst>
     <pc:chgData name="Mohammed Fasha" userId="cc64f42d-a1a6-4f08-b97b-0c37f877119f" providerId="ADAL" clId="{6B515210-E3E2-4B4B-BC10-968DB84AFC83}"/>
     <pc:docChg chg="undo custSel addSld delSld modSld sldOrd modMainMaster">
@@ -637,6 +901,382 @@
           </pc:sldLayoutMkLst>
         </pc:sldLayoutChg>
       </pc:sldMasterChg>
+    </pc:docChg>
+  </pc:docChgLst>
+  <pc:docChgLst>
+    <pc:chgData name="Mohammed Fasha" userId="cc64f42d-a1a6-4f08-b97b-0c37f877119f" providerId="ADAL" clId="{D3520BFC-89CF-4CB5-8BC6-02854ED6C636}"/>
+    <pc:docChg chg="undo custSel addSld delSld modSld modMainMaster">
+      <pc:chgData name="Mohammed Fasha" userId="cc64f42d-a1a6-4f08-b97b-0c37f877119f" providerId="ADAL" clId="{D3520BFC-89CF-4CB5-8BC6-02854ED6C636}" dt="2024-10-16T09:49:25.572" v="384"/>
+      <pc:docMkLst>
+        <pc:docMk/>
+      </pc:docMkLst>
+      <pc:sldChg chg="modSp">
+        <pc:chgData name="Mohammed Fasha" userId="cc64f42d-a1a6-4f08-b97b-0c37f877119f" providerId="ADAL" clId="{D3520BFC-89CF-4CB5-8BC6-02854ED6C636}" dt="2024-10-16T09:27:15.806" v="128" actId="1076"/>
+        <pc:sldMkLst>
+          <pc:docMk/>
+          <pc:sldMk cId="706735111" sldId="258"/>
+        </pc:sldMkLst>
+      </pc:sldChg>
+      <pc:sldChg chg="modSp mod">
+        <pc:chgData name="Mohammed Fasha" userId="cc64f42d-a1a6-4f08-b97b-0c37f877119f" providerId="ADAL" clId="{D3520BFC-89CF-4CB5-8BC6-02854ED6C636}" dt="2024-10-16T09:44:32.790" v="325" actId="27636"/>
+        <pc:sldMkLst>
+          <pc:docMk/>
+          <pc:sldMk cId="4289469650" sldId="261"/>
+        </pc:sldMkLst>
+      </pc:sldChg>
+      <pc:sldChg chg="addSp delSp modSp mod">
+        <pc:chgData name="Mohammed Fasha" userId="cc64f42d-a1a6-4f08-b97b-0c37f877119f" providerId="ADAL" clId="{D3520BFC-89CF-4CB5-8BC6-02854ED6C636}" dt="2024-10-16T09:28:12.841" v="142" actId="1076"/>
+        <pc:sldMkLst>
+          <pc:docMk/>
+          <pc:sldMk cId="4130133658" sldId="262"/>
+        </pc:sldMkLst>
+      </pc:sldChg>
+      <pc:sldChg chg="addSp delSp modSp mod chgLayout">
+        <pc:chgData name="Mohammed Fasha" userId="cc64f42d-a1a6-4f08-b97b-0c37f877119f" providerId="ADAL" clId="{D3520BFC-89CF-4CB5-8BC6-02854ED6C636}" dt="2024-10-16T09:43:01.102" v="281" actId="14100"/>
+        <pc:sldMkLst>
+          <pc:docMk/>
+          <pc:sldMk cId="2611575643" sldId="264"/>
+        </pc:sldMkLst>
+      </pc:sldChg>
+      <pc:sldChg chg="modSp mod">
+        <pc:chgData name="Mohammed Fasha" userId="cc64f42d-a1a6-4f08-b97b-0c37f877119f" providerId="ADAL" clId="{D3520BFC-89CF-4CB5-8BC6-02854ED6C636}" dt="2024-10-16T09:24:41.861" v="53" actId="14100"/>
+        <pc:sldMkLst>
+          <pc:docMk/>
+          <pc:sldMk cId="3898002179" sldId="275"/>
+        </pc:sldMkLst>
+      </pc:sldChg>
+      <pc:sldChg chg="addSp delSp modSp mod">
+        <pc:chgData name="Mohammed Fasha" userId="cc64f42d-a1a6-4f08-b97b-0c37f877119f" providerId="ADAL" clId="{D3520BFC-89CF-4CB5-8BC6-02854ED6C636}" dt="2024-10-16T09:24:38.381" v="52" actId="27636"/>
+        <pc:sldMkLst>
+          <pc:docMk/>
+          <pc:sldMk cId="1503352162" sldId="276"/>
+        </pc:sldMkLst>
+      </pc:sldChg>
+      <pc:sldChg chg="modSp mod">
+        <pc:chgData name="Mohammed Fasha" userId="cc64f42d-a1a6-4f08-b97b-0c37f877119f" providerId="ADAL" clId="{D3520BFC-89CF-4CB5-8BC6-02854ED6C636}" dt="2024-10-16T09:48:50.906" v="382"/>
+        <pc:sldMkLst>
+          <pc:docMk/>
+          <pc:sldMk cId="1260131707" sldId="277"/>
+        </pc:sldMkLst>
+      </pc:sldChg>
+      <pc:sldChg chg="modSp mod">
+        <pc:chgData name="Mohammed Fasha" userId="cc64f42d-a1a6-4f08-b97b-0c37f877119f" providerId="ADAL" clId="{D3520BFC-89CF-4CB5-8BC6-02854ED6C636}" dt="2024-10-16T09:47:08.623" v="367" actId="179"/>
+        <pc:sldMkLst>
+          <pc:docMk/>
+          <pc:sldMk cId="1324937023" sldId="280"/>
+        </pc:sldMkLst>
+      </pc:sldChg>
+      <pc:sldChg chg="modSp mod">
+        <pc:chgData name="Mohammed Fasha" userId="cc64f42d-a1a6-4f08-b97b-0c37f877119f" providerId="ADAL" clId="{D3520BFC-89CF-4CB5-8BC6-02854ED6C636}" dt="2024-10-16T09:44:54.951" v="335" actId="6549"/>
+        <pc:sldMkLst>
+          <pc:docMk/>
+          <pc:sldMk cId="4085727926" sldId="281"/>
+        </pc:sldMkLst>
+      </pc:sldChg>
+      <pc:sldChg chg="modSp mod">
+        <pc:chgData name="Mohammed Fasha" userId="cc64f42d-a1a6-4f08-b97b-0c37f877119f" providerId="ADAL" clId="{D3520BFC-89CF-4CB5-8BC6-02854ED6C636}" dt="2024-10-16T09:49:20.342" v="383"/>
+        <pc:sldMkLst>
+          <pc:docMk/>
+          <pc:sldMk cId="156012141" sldId="282"/>
+        </pc:sldMkLst>
+      </pc:sldChg>
+      <pc:sldChg chg="delSp modSp mod">
+        <pc:chgData name="Mohammed Fasha" userId="cc64f42d-a1a6-4f08-b97b-0c37f877119f" providerId="ADAL" clId="{D3520BFC-89CF-4CB5-8BC6-02854ED6C636}" dt="2024-10-16T09:49:25.572" v="384"/>
+        <pc:sldMkLst>
+          <pc:docMk/>
+          <pc:sldMk cId="248623450" sldId="284"/>
+        </pc:sldMkLst>
+      </pc:sldChg>
+      <pc:sldChg chg="addSp modSp add mod">
+        <pc:chgData name="Mohammed Fasha" userId="cc64f42d-a1a6-4f08-b97b-0c37f877119f" providerId="ADAL" clId="{D3520BFC-89CF-4CB5-8BC6-02854ED6C636}" dt="2024-10-16T09:31:53.226" v="265" actId="20577"/>
+        <pc:sldMkLst>
+          <pc:docMk/>
+          <pc:sldMk cId="1489447582" sldId="455"/>
+        </pc:sldMkLst>
+      </pc:sldChg>
+      <pc:sldMasterChg chg="addSp modSp modSldLayout">
+        <pc:chgData name="Mohammed Fasha" userId="cc64f42d-a1a6-4f08-b97b-0c37f877119f" providerId="ADAL" clId="{D3520BFC-89CF-4CB5-8BC6-02854ED6C636}" dt="2024-10-16T09:31:03.810" v="239" actId="14100"/>
+        <pc:sldMasterMkLst>
+          <pc:docMk/>
+          <pc:sldMasterMk cId="2573801746" sldId="2147483648"/>
+        </pc:sldMasterMkLst>
+        <pc:sldLayoutChg chg="addSp modSp">
+          <pc:chgData name="Mohammed Fasha" userId="cc64f42d-a1a6-4f08-b97b-0c37f877119f" providerId="ADAL" clId="{D3520BFC-89CF-4CB5-8BC6-02854ED6C636}" dt="2024-10-16T09:26:29.266" v="116"/>
+          <pc:sldLayoutMkLst>
+            <pc:docMk/>
+            <pc:sldMasterMk cId="2573801746" sldId="2147483648"/>
+            <pc:sldLayoutMk cId="1871815692" sldId="2147483649"/>
+          </pc:sldLayoutMkLst>
+        </pc:sldLayoutChg>
+        <pc:sldLayoutChg chg="modSp mod">
+          <pc:chgData name="Mohammed Fasha" userId="cc64f42d-a1a6-4f08-b97b-0c37f877119f" providerId="ADAL" clId="{D3520BFC-89CF-4CB5-8BC6-02854ED6C636}" dt="2024-10-16T09:31:03.810" v="239" actId="14100"/>
+          <pc:sldLayoutMkLst>
+            <pc:docMk/>
+            <pc:sldMasterMk cId="2573801746" sldId="2147483648"/>
+            <pc:sldLayoutMk cId="3033015503" sldId="2147483650"/>
+          </pc:sldLayoutMkLst>
+        </pc:sldLayoutChg>
+      </pc:sldMasterChg>
+    </pc:docChg>
+  </pc:docChgLst>
+  <pc:docChgLst>
+    <pc:chgData name="Mohammed Fasha" userId="S::mohammed.fasha@uop.edu.jo::cc64f42d-a1a6-4f08-b97b-0c37f877119f" providerId="AD" clId="Web-{183AE7D0-0422-8839-EC6E-29E0859D7097}"/>
+    <pc:docChg chg="addSld delSld modSld">
+      <pc:chgData name="Mohammed Fasha" userId="S::mohammed.fasha@uop.edu.jo::cc64f42d-a1a6-4f08-b97b-0c37f877119f" providerId="AD" clId="Web-{183AE7D0-0422-8839-EC6E-29E0859D7097}" dt="2025-07-16T14:35:10.276" v="63" actId="20577"/>
+      <pc:docMkLst>
+        <pc:docMk/>
+      </pc:docMkLst>
+      <pc:sldChg chg="del">
+        <pc:chgData name="Mohammed Fasha" userId="S::mohammed.fasha@uop.edu.jo::cc64f42d-a1a6-4f08-b97b-0c37f877119f" providerId="AD" clId="Web-{183AE7D0-0422-8839-EC6E-29E0859D7097}" dt="2025-07-16T14:30:46.940" v="18"/>
+        <pc:sldMkLst>
+          <pc:docMk/>
+          <pc:sldMk cId="1162554463" sldId="257"/>
+        </pc:sldMkLst>
+      </pc:sldChg>
+      <pc:sldChg chg="modSp">
+        <pc:chgData name="Mohammed Fasha" userId="S::mohammed.fasha@uop.edu.jo::cc64f42d-a1a6-4f08-b97b-0c37f877119f" providerId="AD" clId="Web-{183AE7D0-0422-8839-EC6E-29E0859D7097}" dt="2025-07-16T14:30:58.893" v="25" actId="20577"/>
+        <pc:sldMkLst>
+          <pc:docMk/>
+          <pc:sldMk cId="1489447582" sldId="455"/>
+        </pc:sldMkLst>
+        <pc:spChg chg="mod">
+          <ac:chgData name="Mohammed Fasha" userId="S::mohammed.fasha@uop.edu.jo::cc64f42d-a1a6-4f08-b97b-0c37f877119f" providerId="AD" clId="Web-{183AE7D0-0422-8839-EC6E-29E0859D7097}" dt="2025-07-16T14:30:58.893" v="25" actId="20577"/>
+          <ac:spMkLst>
+            <pc:docMk/>
+            <pc:sldMk cId="1489447582" sldId="455"/>
+            <ac:spMk id="9" creationId="{F599965F-D781-62F6-30A4-33D89AC89080}"/>
+          </ac:spMkLst>
+        </pc:spChg>
+      </pc:sldChg>
+      <pc:sldChg chg="addSp delSp modSp new">
+        <pc:chgData name="Mohammed Fasha" userId="S::mohammed.fasha@uop.edu.jo::cc64f42d-a1a6-4f08-b97b-0c37f877119f" providerId="AD" clId="Web-{183AE7D0-0422-8839-EC6E-29E0859D7097}" dt="2025-07-16T14:34:44.681" v="61" actId="1076"/>
+        <pc:sldMkLst>
+          <pc:docMk/>
+          <pc:sldMk cId="2145144810" sldId="456"/>
+        </pc:sldMkLst>
+        <pc:spChg chg="mod">
+          <ac:chgData name="Mohammed Fasha" userId="S::mohammed.fasha@uop.edu.jo::cc64f42d-a1a6-4f08-b97b-0c37f877119f" providerId="AD" clId="Web-{183AE7D0-0422-8839-EC6E-29E0859D7097}" dt="2025-07-16T14:34:05.243" v="54" actId="14100"/>
+          <ac:spMkLst>
+            <pc:docMk/>
+            <pc:sldMk cId="2145144810" sldId="456"/>
+            <ac:spMk id="2" creationId="{A67F3E90-0FEA-4491-CD3B-54061E231F3E}"/>
+          </ac:spMkLst>
+        </pc:spChg>
+        <pc:spChg chg="mod">
+          <ac:chgData name="Mohammed Fasha" userId="S::mohammed.fasha@uop.edu.jo::cc64f42d-a1a6-4f08-b97b-0c37f877119f" providerId="AD" clId="Web-{183AE7D0-0422-8839-EC6E-29E0859D7097}" dt="2025-07-16T14:31:52.473" v="35" actId="20577"/>
+          <ac:spMkLst>
+            <pc:docMk/>
+            <pc:sldMk cId="2145144810" sldId="456"/>
+            <ac:spMk id="3" creationId="{E3173229-46D2-444C-C512-9405F10F26F7}"/>
+          </ac:spMkLst>
+        </pc:spChg>
+        <pc:picChg chg="add mod">
+          <ac:chgData name="Mohammed Fasha" userId="S::mohammed.fasha@uop.edu.jo::cc64f42d-a1a6-4f08-b97b-0c37f877119f" providerId="AD" clId="Web-{183AE7D0-0422-8839-EC6E-29E0859D7097}" dt="2025-07-16T14:34:44.681" v="61" actId="1076"/>
+          <ac:picMkLst>
+            <pc:docMk/>
+            <pc:sldMk cId="2145144810" sldId="456"/>
+            <ac:picMk id="6" creationId="{C0C178FF-668E-3159-DDA2-ED1B4CB3BD07}"/>
+          </ac:picMkLst>
+        </pc:picChg>
+      </pc:sldChg>
+      <pc:sldChg chg="del">
+        <pc:chgData name="Mohammed Fasha" userId="S::mohammed.fasha@uop.edu.jo::cc64f42d-a1a6-4f08-b97b-0c37f877119f" providerId="AD" clId="Web-{183AE7D0-0422-8839-EC6E-29E0859D7097}" dt="2025-07-16T14:30:46.909" v="0"/>
+        <pc:sldMkLst>
+          <pc:docMk/>
+          <pc:sldMk cId="3910887702" sldId="456"/>
+        </pc:sldMkLst>
+      </pc:sldChg>
+      <pc:sldChg chg="new del">
+        <pc:chgData name="Mohammed Fasha" userId="S::mohammed.fasha@uop.edu.jo::cc64f42d-a1a6-4f08-b97b-0c37f877119f" providerId="AD" clId="Web-{183AE7D0-0422-8839-EC6E-29E0859D7097}" dt="2025-07-16T14:31:01.972" v="26"/>
+        <pc:sldMkLst>
+          <pc:docMk/>
+          <pc:sldMk cId="4030929307" sldId="456"/>
+        </pc:sldMkLst>
+      </pc:sldChg>
+      <pc:sldChg chg="modSp add replId">
+        <pc:chgData name="Mohammed Fasha" userId="S::mohammed.fasha@uop.edu.jo::cc64f42d-a1a6-4f08-b97b-0c37f877119f" providerId="AD" clId="Web-{183AE7D0-0422-8839-EC6E-29E0859D7097}" dt="2025-07-16T14:35:10.276" v="63" actId="20577"/>
+        <pc:sldMkLst>
+          <pc:docMk/>
+          <pc:sldMk cId="3415756226" sldId="457"/>
+        </pc:sldMkLst>
+      </pc:sldChg>
+      <pc:sldChg chg="del">
+        <pc:chgData name="Mohammed Fasha" userId="S::mohammed.fasha@uop.edu.jo::cc64f42d-a1a6-4f08-b97b-0c37f877119f" providerId="AD" clId="Web-{183AE7D0-0422-8839-EC6E-29E0859D7097}" dt="2025-07-16T14:30:46.940" v="16"/>
+        <pc:sldMkLst>
+          <pc:docMk/>
+          <pc:sldMk cId="3639736080" sldId="457"/>
+        </pc:sldMkLst>
+      </pc:sldChg>
+      <pc:sldChg chg="del">
+        <pc:chgData name="Mohammed Fasha" userId="S::mohammed.fasha@uop.edu.jo::cc64f42d-a1a6-4f08-b97b-0c37f877119f" providerId="AD" clId="Web-{183AE7D0-0422-8839-EC6E-29E0859D7097}" dt="2025-07-16T14:30:46.924" v="15"/>
+        <pc:sldMkLst>
+          <pc:docMk/>
+          <pc:sldMk cId="2042404279" sldId="458"/>
+        </pc:sldMkLst>
+      </pc:sldChg>
+      <pc:sldChg chg="add replId">
+        <pc:chgData name="Mohammed Fasha" userId="S::mohammed.fasha@uop.edu.jo::cc64f42d-a1a6-4f08-b97b-0c37f877119f" providerId="AD" clId="Web-{183AE7D0-0422-8839-EC6E-29E0859D7097}" dt="2025-07-16T14:31:08.612" v="29"/>
+        <pc:sldMkLst>
+          <pc:docMk/>
+          <pc:sldMk cId="3207878978" sldId="458"/>
+        </pc:sldMkLst>
+      </pc:sldChg>
+      <pc:sldChg chg="del">
+        <pc:chgData name="Mohammed Fasha" userId="S::mohammed.fasha@uop.edu.jo::cc64f42d-a1a6-4f08-b97b-0c37f877119f" providerId="AD" clId="Web-{183AE7D0-0422-8839-EC6E-29E0859D7097}" dt="2025-07-16T14:30:46.924" v="14"/>
+        <pc:sldMkLst>
+          <pc:docMk/>
+          <pc:sldMk cId="2881282849" sldId="459"/>
+        </pc:sldMkLst>
+      </pc:sldChg>
+      <pc:sldChg chg="del">
+        <pc:chgData name="Mohammed Fasha" userId="S::mohammed.fasha@uop.edu.jo::cc64f42d-a1a6-4f08-b97b-0c37f877119f" providerId="AD" clId="Web-{183AE7D0-0422-8839-EC6E-29E0859D7097}" dt="2025-07-16T14:30:46.924" v="9"/>
+        <pc:sldMkLst>
+          <pc:docMk/>
+          <pc:sldMk cId="2248227231" sldId="461"/>
+        </pc:sldMkLst>
+      </pc:sldChg>
+      <pc:sldChg chg="del">
+        <pc:chgData name="Mohammed Fasha" userId="S::mohammed.fasha@uop.edu.jo::cc64f42d-a1a6-4f08-b97b-0c37f877119f" providerId="AD" clId="Web-{183AE7D0-0422-8839-EC6E-29E0859D7097}" dt="2025-07-16T14:30:46.924" v="8"/>
+        <pc:sldMkLst>
+          <pc:docMk/>
+          <pc:sldMk cId="1427723282" sldId="462"/>
+        </pc:sldMkLst>
+      </pc:sldChg>
+      <pc:sldChg chg="del">
+        <pc:chgData name="Mohammed Fasha" userId="S::mohammed.fasha@uop.edu.jo::cc64f42d-a1a6-4f08-b97b-0c37f877119f" providerId="AD" clId="Web-{183AE7D0-0422-8839-EC6E-29E0859D7097}" dt="2025-07-16T14:30:46.909" v="5"/>
+        <pc:sldMkLst>
+          <pc:docMk/>
+          <pc:sldMk cId="538252582" sldId="463"/>
+        </pc:sldMkLst>
+      </pc:sldChg>
+      <pc:sldChg chg="del">
+        <pc:chgData name="Mohammed Fasha" userId="S::mohammed.fasha@uop.edu.jo::cc64f42d-a1a6-4f08-b97b-0c37f877119f" providerId="AD" clId="Web-{183AE7D0-0422-8839-EC6E-29E0859D7097}" dt="2025-07-16T14:30:46.909" v="3"/>
+        <pc:sldMkLst>
+          <pc:docMk/>
+          <pc:sldMk cId="1559017199" sldId="464"/>
+        </pc:sldMkLst>
+      </pc:sldChg>
+      <pc:sldChg chg="del">
+        <pc:chgData name="Mohammed Fasha" userId="S::mohammed.fasha@uop.edu.jo::cc64f42d-a1a6-4f08-b97b-0c37f877119f" providerId="AD" clId="Web-{183AE7D0-0422-8839-EC6E-29E0859D7097}" dt="2025-07-16T14:30:46.909" v="4"/>
+        <pc:sldMkLst>
+          <pc:docMk/>
+          <pc:sldMk cId="2067025602" sldId="465"/>
+        </pc:sldMkLst>
+      </pc:sldChg>
+      <pc:sldChg chg="del">
+        <pc:chgData name="Mohammed Fasha" userId="S::mohammed.fasha@uop.edu.jo::cc64f42d-a1a6-4f08-b97b-0c37f877119f" providerId="AD" clId="Web-{183AE7D0-0422-8839-EC6E-29E0859D7097}" dt="2025-07-16T14:30:46.909" v="2"/>
+        <pc:sldMkLst>
+          <pc:docMk/>
+          <pc:sldMk cId="2575217795" sldId="466"/>
+        </pc:sldMkLst>
+      </pc:sldChg>
+      <pc:sldChg chg="del">
+        <pc:chgData name="Mohammed Fasha" userId="S::mohammed.fasha@uop.edu.jo::cc64f42d-a1a6-4f08-b97b-0c37f877119f" providerId="AD" clId="Web-{183AE7D0-0422-8839-EC6E-29E0859D7097}" dt="2025-07-16T14:30:46.909" v="1"/>
+        <pc:sldMkLst>
+          <pc:docMk/>
+          <pc:sldMk cId="1558611893" sldId="476"/>
+        </pc:sldMkLst>
+      </pc:sldChg>
+      <pc:sldChg chg="del">
+        <pc:chgData name="Mohammed Fasha" userId="S::mohammed.fasha@uop.edu.jo::cc64f42d-a1a6-4f08-b97b-0c37f877119f" providerId="AD" clId="Web-{183AE7D0-0422-8839-EC6E-29E0859D7097}" dt="2025-07-16T14:30:46.940" v="17"/>
+        <pc:sldMkLst>
+          <pc:docMk/>
+          <pc:sldMk cId="2300765676" sldId="477"/>
+        </pc:sldMkLst>
+      </pc:sldChg>
+      <pc:sldChg chg="del">
+        <pc:chgData name="Mohammed Fasha" userId="S::mohammed.fasha@uop.edu.jo::cc64f42d-a1a6-4f08-b97b-0c37f877119f" providerId="AD" clId="Web-{183AE7D0-0422-8839-EC6E-29E0859D7097}" dt="2025-07-16T14:30:46.940" v="19"/>
+        <pc:sldMkLst>
+          <pc:docMk/>
+          <pc:sldMk cId="2145969539" sldId="478"/>
+        </pc:sldMkLst>
+      </pc:sldChg>
+      <pc:sldChg chg="del">
+        <pc:chgData name="Mohammed Fasha" userId="S::mohammed.fasha@uop.edu.jo::cc64f42d-a1a6-4f08-b97b-0c37f877119f" providerId="AD" clId="Web-{183AE7D0-0422-8839-EC6E-29E0859D7097}" dt="2025-07-16T14:30:46.924" v="13"/>
+        <pc:sldMkLst>
+          <pc:docMk/>
+          <pc:sldMk cId="1427132372" sldId="479"/>
+        </pc:sldMkLst>
+      </pc:sldChg>
+      <pc:sldChg chg="del">
+        <pc:chgData name="Mohammed Fasha" userId="S::mohammed.fasha@uop.edu.jo::cc64f42d-a1a6-4f08-b97b-0c37f877119f" providerId="AD" clId="Web-{183AE7D0-0422-8839-EC6E-29E0859D7097}" dt="2025-07-16T14:30:46.924" v="12"/>
+        <pc:sldMkLst>
+          <pc:docMk/>
+          <pc:sldMk cId="3075052158" sldId="480"/>
+        </pc:sldMkLst>
+      </pc:sldChg>
+      <pc:sldChg chg="del">
+        <pc:chgData name="Mohammed Fasha" userId="S::mohammed.fasha@uop.edu.jo::cc64f42d-a1a6-4f08-b97b-0c37f877119f" providerId="AD" clId="Web-{183AE7D0-0422-8839-EC6E-29E0859D7097}" dt="2025-07-16T14:30:46.924" v="10"/>
+        <pc:sldMkLst>
+          <pc:docMk/>
+          <pc:sldMk cId="3717947773" sldId="481"/>
+        </pc:sldMkLst>
+      </pc:sldChg>
+      <pc:sldChg chg="del">
+        <pc:chgData name="Mohammed Fasha" userId="S::mohammed.fasha@uop.edu.jo::cc64f42d-a1a6-4f08-b97b-0c37f877119f" providerId="AD" clId="Web-{183AE7D0-0422-8839-EC6E-29E0859D7097}" dt="2025-07-16T14:30:46.924" v="7"/>
+        <pc:sldMkLst>
+          <pc:docMk/>
+          <pc:sldMk cId="3941017664" sldId="482"/>
+        </pc:sldMkLst>
+      </pc:sldChg>
+      <pc:sldChg chg="del">
+        <pc:chgData name="Mohammed Fasha" userId="S::mohammed.fasha@uop.edu.jo::cc64f42d-a1a6-4f08-b97b-0c37f877119f" providerId="AD" clId="Web-{183AE7D0-0422-8839-EC6E-29E0859D7097}" dt="2025-07-16T14:30:46.924" v="6"/>
+        <pc:sldMkLst>
+          <pc:docMk/>
+          <pc:sldMk cId="1291192180" sldId="483"/>
+        </pc:sldMkLst>
+      </pc:sldChg>
+      <pc:sldChg chg="del">
+        <pc:chgData name="Mohammed Fasha" userId="S::mohammed.fasha@uop.edu.jo::cc64f42d-a1a6-4f08-b97b-0c37f877119f" providerId="AD" clId="Web-{183AE7D0-0422-8839-EC6E-29E0859D7097}" dt="2025-07-16T14:30:46.924" v="11"/>
+        <pc:sldMkLst>
+          <pc:docMk/>
+          <pc:sldMk cId="1949621639" sldId="484"/>
+        </pc:sldMkLst>
+      </pc:sldChg>
+    </pc:docChg>
+  </pc:docChgLst>
+  <pc:docChgLst>
+    <pc:chgData name="Mohammed Fasha" userId="cc64f42d-a1a6-4f08-b97b-0c37f877119f" providerId="ADAL" clId="{30DD28B9-8B97-487C-83EE-EC2EB54F3F9E}"/>
+    <pc:docChg chg="undo custSel modSld">
+      <pc:chgData name="Mohammed Fasha" userId="cc64f42d-a1a6-4f08-b97b-0c37f877119f" providerId="ADAL" clId="{30DD28B9-8B97-487C-83EE-EC2EB54F3F9E}" dt="2024-10-17T03:04:01.750" v="11" actId="1076"/>
+      <pc:docMkLst>
+        <pc:docMk/>
+      </pc:docMkLst>
+      <pc:sldChg chg="modSp mod">
+        <pc:chgData name="Mohammed Fasha" userId="cc64f42d-a1a6-4f08-b97b-0c37f877119f" providerId="ADAL" clId="{30DD28B9-8B97-487C-83EE-EC2EB54F3F9E}" dt="2024-10-16T20:03:44.325" v="2" actId="20577"/>
+        <pc:sldMkLst>
+          <pc:docMk/>
+          <pc:sldMk cId="1162554463" sldId="257"/>
+        </pc:sldMkLst>
+      </pc:sldChg>
+      <pc:sldChg chg="modSp mod">
+        <pc:chgData name="Mohammed Fasha" userId="cc64f42d-a1a6-4f08-b97b-0c37f877119f" providerId="ADAL" clId="{30DD28B9-8B97-487C-83EE-EC2EB54F3F9E}" dt="2024-10-16T20:03:53.393" v="4" actId="113"/>
+        <pc:sldMkLst>
+          <pc:docMk/>
+          <pc:sldMk cId="706735111" sldId="258"/>
+        </pc:sldMkLst>
+      </pc:sldChg>
+      <pc:sldChg chg="addSp delSp modSp mod">
+        <pc:chgData name="Mohammed Fasha" userId="cc64f42d-a1a6-4f08-b97b-0c37f877119f" providerId="ADAL" clId="{30DD28B9-8B97-487C-83EE-EC2EB54F3F9E}" dt="2024-10-16T20:04:08.776" v="6"/>
+        <pc:sldMkLst>
+          <pc:docMk/>
+          <pc:sldMk cId="2433706687" sldId="267"/>
+        </pc:sldMkLst>
+      </pc:sldChg>
+      <pc:sldChg chg="addSp delSp modSp mod">
+        <pc:chgData name="Mohammed Fasha" userId="cc64f42d-a1a6-4f08-b97b-0c37f877119f" providerId="ADAL" clId="{30DD28B9-8B97-487C-83EE-EC2EB54F3F9E}" dt="2024-10-16T20:04:23.488" v="10" actId="27636"/>
+        <pc:sldMkLst>
+          <pc:docMk/>
+          <pc:sldMk cId="3925652072" sldId="271"/>
+        </pc:sldMkLst>
+      </pc:sldChg>
+      <pc:sldChg chg="modSp mod">
+        <pc:chgData name="Mohammed Fasha" userId="cc64f42d-a1a6-4f08-b97b-0c37f877119f" providerId="ADAL" clId="{30DD28B9-8B97-487C-83EE-EC2EB54F3F9E}" dt="2024-10-17T03:04:01.750" v="11" actId="1076"/>
+        <pc:sldMkLst>
+          <pc:docMk/>
+          <pc:sldMk cId="1489447582" sldId="455"/>
+        </pc:sldMkLst>
+      </pc:sldChg>
     </pc:docChg>
   </pc:docChgLst>
   <pc:docChgLst>
@@ -683,14 +1323,6 @@
           <pc:docMk/>
           <pc:sldMk cId="3415756226" sldId="457"/>
         </pc:sldMkLst>
-        <pc:spChg chg="del">
-          <ac:chgData name="Mohammed Fasha" userId="cc64f42d-a1a6-4f08-b97b-0c37f877119f" providerId="ADAL" clId="{B004DB22-B418-47BE-85DF-64F58F0EEE29}" dt="2025-07-17T04:49:56.712" v="8"/>
-          <ac:spMkLst>
-            <pc:docMk/>
-            <pc:sldMk cId="3415756226" sldId="457"/>
-            <ac:spMk id="2" creationId="{3F759ABC-7E4B-2A1B-D908-FABEB2278C30}"/>
-          </ac:spMkLst>
-        </pc:spChg>
         <pc:spChg chg="mod">
           <ac:chgData name="Mohammed Fasha" userId="cc64f42d-a1a6-4f08-b97b-0c37f877119f" providerId="ADAL" clId="{B004DB22-B418-47BE-85DF-64F58F0EEE29}" dt="2025-07-17T04:50:08.195" v="11"/>
           <ac:spMkLst>
@@ -730,14 +1362,6 @@
             <ac:spMk id="3" creationId="{26AC9734-F991-7DBA-2CE7-808DE91A025C}"/>
           </ac:spMkLst>
         </pc:spChg>
-        <pc:picChg chg="add del mod">
-          <ac:chgData name="Mohammed Fasha" userId="cc64f42d-a1a6-4f08-b97b-0c37f877119f" providerId="ADAL" clId="{B004DB22-B418-47BE-85DF-64F58F0EEE29}" dt="2025-07-17T05:00:30.904" v="65" actId="478"/>
-          <ac:picMkLst>
-            <pc:docMk/>
-            <pc:sldMk cId="3207878978" sldId="458"/>
-            <ac:picMk id="5" creationId="{82DDD2CB-B2C1-8593-9A74-B799ECB4FEA0}"/>
-          </ac:picMkLst>
-        </pc:picChg>
         <pc:picChg chg="add mod">
           <ac:chgData name="Mohammed Fasha" userId="cc64f42d-a1a6-4f08-b97b-0c37f877119f" providerId="ADAL" clId="{B004DB22-B418-47BE-85DF-64F58F0EEE29}" dt="2025-07-17T05:00:42.048" v="70" actId="14100"/>
           <ac:picMkLst>
@@ -831,38 +1455,6 @@
             <ac:spMk id="3" creationId="{94BD4596-B9A1-B460-0BEF-45C6EFBF5881}"/>
           </ac:spMkLst>
         </pc:spChg>
-        <pc:spChg chg="add">
-          <ac:chgData name="Mohammed Fasha" userId="cc64f42d-a1a6-4f08-b97b-0c37f877119f" providerId="ADAL" clId="{B004DB22-B418-47BE-85DF-64F58F0EEE29}" dt="2025-07-17T05:03:43.588" v="94"/>
-          <ac:spMkLst>
-            <pc:docMk/>
-            <pc:sldMk cId="2379583142" sldId="461"/>
-            <ac:spMk id="5" creationId="{00344E1B-AE58-33BB-D3B7-C4FFEC4C04E0}"/>
-          </ac:spMkLst>
-        </pc:spChg>
-        <pc:spChg chg="add del">
-          <ac:chgData name="Mohammed Fasha" userId="cc64f42d-a1a6-4f08-b97b-0c37f877119f" providerId="ADAL" clId="{B004DB22-B418-47BE-85DF-64F58F0EEE29}" dt="2025-07-17T05:07:23.993" v="135" actId="21"/>
-          <ac:spMkLst>
-            <pc:docMk/>
-            <pc:sldMk cId="2379583142" sldId="461"/>
-            <ac:spMk id="7" creationId="{192678DA-EE37-61F5-B492-FB7542561348}"/>
-          </ac:spMkLst>
-        </pc:spChg>
-        <pc:spChg chg="add mod">
-          <ac:chgData name="Mohammed Fasha" userId="cc64f42d-a1a6-4f08-b97b-0c37f877119f" providerId="ADAL" clId="{B004DB22-B418-47BE-85DF-64F58F0EEE29}" dt="2025-07-17T05:07:29.618" v="137"/>
-          <ac:spMkLst>
-            <pc:docMk/>
-            <pc:sldMk cId="2379583142" sldId="461"/>
-            <ac:spMk id="8" creationId="{95AE08E7-8A39-A64F-2477-8F311111C22F}"/>
-          </ac:spMkLst>
-        </pc:spChg>
-        <pc:spChg chg="add mod">
-          <ac:chgData name="Mohammed Fasha" userId="cc64f42d-a1a6-4f08-b97b-0c37f877119f" providerId="ADAL" clId="{B004DB22-B418-47BE-85DF-64F58F0EEE29}" dt="2025-07-17T05:07:32.047" v="139"/>
-          <ac:spMkLst>
-            <pc:docMk/>
-            <pc:sldMk cId="2379583142" sldId="461"/>
-            <ac:spMk id="9" creationId="{DA967FE4-63DB-8A45-A0BE-D1404B8DC94B}"/>
-          </ac:spMkLst>
-        </pc:spChg>
         <pc:spChg chg="add mod">
           <ac:chgData name="Mohammed Fasha" userId="cc64f42d-a1a6-4f08-b97b-0c37f877119f" providerId="ADAL" clId="{B004DB22-B418-47BE-85DF-64F58F0EEE29}" dt="2025-07-17T05:08:51.407" v="188" actId="20577"/>
           <ac:spMkLst>
@@ -871,14 +1463,6 @@
             <ac:spMk id="10" creationId="{2275BCB7-2A19-8AB8-2680-32718E88D9DD}"/>
           </ac:spMkLst>
         </pc:spChg>
-        <pc:graphicFrameChg chg="add mod">
-          <ac:chgData name="Mohammed Fasha" userId="cc64f42d-a1a6-4f08-b97b-0c37f877119f" providerId="ADAL" clId="{B004DB22-B418-47BE-85DF-64F58F0EEE29}" dt="2025-07-17T05:03:44.361" v="95"/>
-          <ac:graphicFrameMkLst>
-            <pc:docMk/>
-            <pc:sldMk cId="2379583142" sldId="461"/>
-            <ac:graphicFrameMk id="4" creationId="{17F3CB6E-F745-8D6B-71F7-749AA423AFBE}"/>
-          </ac:graphicFrameMkLst>
-        </pc:graphicFrameChg>
         <pc:graphicFrameChg chg="add mod modGraphic">
           <ac:chgData name="Mohammed Fasha" userId="cc64f42d-a1a6-4f08-b97b-0c37f877119f" providerId="ADAL" clId="{B004DB22-B418-47BE-85DF-64F58F0EEE29}" dt="2025-07-17T05:28:15.855" v="277" actId="1076"/>
           <ac:graphicFrameMkLst>
@@ -964,44 +1548,12 @@
             <ac:spMk id="2" creationId="{72CCFD12-F425-AC53-BAE4-0789C679F3A2}"/>
           </ac:spMkLst>
         </pc:spChg>
-        <pc:spChg chg="add del">
-          <ac:chgData name="Mohammed Fasha" userId="cc64f42d-a1a6-4f08-b97b-0c37f877119f" providerId="ADAL" clId="{B004DB22-B418-47BE-85DF-64F58F0EEE29}" dt="2025-07-17T05:09:44.985" v="195" actId="22"/>
-          <ac:spMkLst>
-            <pc:docMk/>
-            <pc:sldMk cId="3023150924" sldId="464"/>
-            <ac:spMk id="5" creationId="{F0D40607-2D55-C6A1-0E24-4A02C3ED4A41}"/>
-          </ac:spMkLst>
-        </pc:spChg>
         <pc:spChg chg="add mod">
           <ac:chgData name="Mohammed Fasha" userId="cc64f42d-a1a6-4f08-b97b-0c37f877119f" providerId="ADAL" clId="{B004DB22-B418-47BE-85DF-64F58F0EEE29}" dt="2025-07-17T05:10:30.819" v="210" actId="5793"/>
           <ac:spMkLst>
             <pc:docMk/>
             <pc:sldMk cId="3023150924" sldId="464"/>
             <ac:spMk id="6" creationId="{662085E8-4729-ABEA-CF3B-6D6A07B7AFBC}"/>
-          </ac:spMkLst>
-        </pc:spChg>
-        <pc:spChg chg="add del mod">
-          <ac:chgData name="Mohammed Fasha" userId="cc64f42d-a1a6-4f08-b97b-0c37f877119f" providerId="ADAL" clId="{B004DB22-B418-47BE-85DF-64F58F0EEE29}" dt="2025-07-17T05:22:08.368" v="239" actId="478"/>
-          <ac:spMkLst>
-            <pc:docMk/>
-            <pc:sldMk cId="3023150924" sldId="464"/>
-            <ac:spMk id="8" creationId="{70E338E7-3DD0-F66B-5817-8F9A085397E6}"/>
-          </ac:spMkLst>
-        </pc:spChg>
-        <pc:spChg chg="add del">
-          <ac:chgData name="Mohammed Fasha" userId="cc64f42d-a1a6-4f08-b97b-0c37f877119f" providerId="ADAL" clId="{B004DB22-B418-47BE-85DF-64F58F0EEE29}" dt="2025-07-17T05:22:12.966" v="241" actId="22"/>
-          <ac:spMkLst>
-            <pc:docMk/>
-            <pc:sldMk cId="3023150924" sldId="464"/>
-            <ac:spMk id="10" creationId="{A45F4C6A-9FD8-6F37-0449-60E83EBC2306}"/>
-          </ac:spMkLst>
-        </pc:spChg>
-        <pc:spChg chg="add del">
-          <ac:chgData name="Mohammed Fasha" userId="cc64f42d-a1a6-4f08-b97b-0c37f877119f" providerId="ADAL" clId="{B004DB22-B418-47BE-85DF-64F58F0EEE29}" dt="2025-07-17T05:22:27.271" v="243" actId="22"/>
-          <ac:spMkLst>
-            <pc:docMk/>
-            <pc:sldMk cId="3023150924" sldId="464"/>
-            <ac:spMk id="12" creationId="{4DEAA091-9D91-CB20-9874-0BF3712F1288}"/>
           </ac:spMkLst>
         </pc:spChg>
         <pc:spChg chg="add mod">
@@ -1019,14 +1571,6 @@
           <pc:docMk/>
           <pc:sldMk cId="3447719930" sldId="465"/>
         </pc:sldMkLst>
-        <pc:spChg chg="del mod">
-          <ac:chgData name="Mohammed Fasha" userId="cc64f42d-a1a6-4f08-b97b-0c37f877119f" providerId="ADAL" clId="{B004DB22-B418-47BE-85DF-64F58F0EEE29}" dt="2025-07-17T05:20:56.467" v="230" actId="478"/>
-          <ac:spMkLst>
-            <pc:docMk/>
-            <pc:sldMk cId="3447719930" sldId="465"/>
-            <ac:spMk id="2" creationId="{16C0C57F-A859-2A86-EBA0-1033E87018CB}"/>
-          </ac:spMkLst>
-        </pc:spChg>
         <pc:spChg chg="mod">
           <ac:chgData name="Mohammed Fasha" userId="cc64f42d-a1a6-4f08-b97b-0c37f877119f" providerId="ADAL" clId="{B004DB22-B418-47BE-85DF-64F58F0EEE29}" dt="2025-07-17T05:21:19.592" v="235" actId="6549"/>
           <ac:spMkLst>
@@ -1057,22 +1601,6 @@
           <pc:docMk/>
           <pc:sldMk cId="1618074923" sldId="466"/>
         </pc:sldMkLst>
-        <pc:spChg chg="del">
-          <ac:chgData name="Mohammed Fasha" userId="cc64f42d-a1a6-4f08-b97b-0c37f877119f" providerId="ADAL" clId="{B004DB22-B418-47BE-85DF-64F58F0EEE29}" dt="2025-07-17T05:26:28.247" v="251"/>
-          <ac:spMkLst>
-            <pc:docMk/>
-            <pc:sldMk cId="1618074923" sldId="466"/>
-            <ac:spMk id="2" creationId="{790792BA-8F6F-B327-220B-845A9E24ACC5}"/>
-          </ac:spMkLst>
-        </pc:spChg>
-        <pc:graphicFrameChg chg="add mod modGraphic">
-          <ac:chgData name="Mohammed Fasha" userId="cc64f42d-a1a6-4f08-b97b-0c37f877119f" providerId="ADAL" clId="{B004DB22-B418-47BE-85DF-64F58F0EEE29}" dt="2025-07-17T05:26:40.722" v="259" actId="403"/>
-          <ac:graphicFrameMkLst>
-            <pc:docMk/>
-            <pc:sldMk cId="1618074923" sldId="466"/>
-            <ac:graphicFrameMk id="4" creationId="{0C5B9765-4636-1AA5-1DEC-DA781BC556E8}"/>
-          </ac:graphicFrameMkLst>
-        </pc:graphicFrameChg>
       </pc:sldChg>
       <pc:sldChg chg="add">
         <pc:chgData name="Mohammed Fasha" userId="cc64f42d-a1a6-4f08-b97b-0c37f877119f" providerId="ADAL" clId="{B004DB22-B418-47BE-85DF-64F58F0EEE29}" dt="2025-07-17T05:28:48.235" v="279"/>
@@ -1098,584 +1626,162 @@
     </pc:docChg>
   </pc:docChgLst>
   <pc:docChgLst>
-    <pc:chgData name="Mohammed Fasha" userId="cc64f42d-a1a6-4f08-b97b-0c37f877119f" providerId="ADAL" clId="{985CD171-9E4A-4264-B045-872AAA800AE3}"/>
-    <pc:docChg chg="undo custSel addSld delSld modSld sldOrd">
-      <pc:chgData name="Mohammed Fasha" userId="cc64f42d-a1a6-4f08-b97b-0c37f877119f" providerId="ADAL" clId="{985CD171-9E4A-4264-B045-872AAA800AE3}" dt="2024-10-16T08:02:59.311" v="633" actId="404"/>
-      <pc:docMkLst>
-        <pc:docMk/>
-      </pc:docMkLst>
-      <pc:sldChg chg="modSp">
-        <pc:chgData name="Mohammed Fasha" userId="cc64f42d-a1a6-4f08-b97b-0c37f877119f" providerId="ADAL" clId="{985CD171-9E4A-4264-B045-872AAA800AE3}" dt="2024-10-16T07:15:21.970" v="481" actId="27636"/>
-        <pc:sldMkLst>
-          <pc:docMk/>
-          <pc:sldMk cId="1162554463" sldId="257"/>
-        </pc:sldMkLst>
-      </pc:sldChg>
-      <pc:sldChg chg="addSp modSp">
-        <pc:chgData name="Mohammed Fasha" userId="cc64f42d-a1a6-4f08-b97b-0c37f877119f" providerId="ADAL" clId="{985CD171-9E4A-4264-B045-872AAA800AE3}" dt="2024-10-16T07:06:03.884" v="437" actId="1076"/>
-        <pc:sldMkLst>
-          <pc:docMk/>
-          <pc:sldMk cId="706735111" sldId="258"/>
-        </pc:sldMkLst>
-      </pc:sldChg>
-      <pc:sldChg chg="addSp delSp modSp ord">
-        <pc:chgData name="Mohammed Fasha" userId="cc64f42d-a1a6-4f08-b97b-0c37f877119f" providerId="ADAL" clId="{985CD171-9E4A-4264-B045-872AAA800AE3}" dt="2024-10-16T07:00:38.831" v="349" actId="207"/>
-        <pc:sldMkLst>
-          <pc:docMk/>
-          <pc:sldMk cId="4289469650" sldId="261"/>
-        </pc:sldMkLst>
-      </pc:sldChg>
-      <pc:sldChg chg="addSp delSp modSp ord">
-        <pc:chgData name="Mohammed Fasha" userId="cc64f42d-a1a6-4f08-b97b-0c37f877119f" providerId="ADAL" clId="{985CD171-9E4A-4264-B045-872AAA800AE3}" dt="2024-10-16T06:46:39.846" v="191" actId="14100"/>
-        <pc:sldMkLst>
-          <pc:docMk/>
-          <pc:sldMk cId="4130133658" sldId="262"/>
-        </pc:sldMkLst>
-      </pc:sldChg>
-      <pc:sldChg chg="addSp modSp ord">
-        <pc:chgData name="Mohammed Fasha" userId="cc64f42d-a1a6-4f08-b97b-0c37f877119f" providerId="ADAL" clId="{985CD171-9E4A-4264-B045-872AAA800AE3}" dt="2024-10-16T07:55:18.576" v="615" actId="207"/>
-        <pc:sldMkLst>
-          <pc:docMk/>
-          <pc:sldMk cId="4074862586" sldId="263"/>
-        </pc:sldMkLst>
-      </pc:sldChg>
-      <pc:sldChg chg="addSp delSp modSp add">
-        <pc:chgData name="Mohammed Fasha" userId="cc64f42d-a1a6-4f08-b97b-0c37f877119f" providerId="ADAL" clId="{985CD171-9E4A-4264-B045-872AAA800AE3}" dt="2024-10-16T07:54:33.790" v="610"/>
-        <pc:sldMkLst>
-          <pc:docMk/>
-          <pc:sldMk cId="2611575643" sldId="264"/>
-        </pc:sldMkLst>
-      </pc:sldChg>
-      <pc:sldChg chg="addSp modSp add ord">
-        <pc:chgData name="Mohammed Fasha" userId="cc64f42d-a1a6-4f08-b97b-0c37f877119f" providerId="ADAL" clId="{985CD171-9E4A-4264-B045-872AAA800AE3}" dt="2024-10-16T07:08:38.092" v="475" actId="27636"/>
-        <pc:sldMkLst>
-          <pc:docMk/>
-          <pc:sldMk cId="335199774" sldId="265"/>
-        </pc:sldMkLst>
-      </pc:sldChg>
-      <pc:sldChg chg="addSp delSp modSp add">
-        <pc:chgData name="Mohammed Fasha" userId="cc64f42d-a1a6-4f08-b97b-0c37f877119f" providerId="ADAL" clId="{985CD171-9E4A-4264-B045-872AAA800AE3}" dt="2024-10-16T07:02:57.901" v="385" actId="27636"/>
-        <pc:sldMkLst>
-          <pc:docMk/>
-          <pc:sldMk cId="2810357117" sldId="266"/>
-        </pc:sldMkLst>
-      </pc:sldChg>
-      <pc:sldChg chg="addSp modSp add">
-        <pc:chgData name="Mohammed Fasha" userId="cc64f42d-a1a6-4f08-b97b-0c37f877119f" providerId="ADAL" clId="{985CD171-9E4A-4264-B045-872AAA800AE3}" dt="2024-10-16T07:03:19.455" v="397" actId="27636"/>
-        <pc:sldMkLst>
-          <pc:docMk/>
-          <pc:sldMk cId="2433706687" sldId="267"/>
-        </pc:sldMkLst>
-      </pc:sldChg>
-      <pc:sldChg chg="addSp modSp add">
-        <pc:chgData name="Mohammed Fasha" userId="cc64f42d-a1a6-4f08-b97b-0c37f877119f" providerId="ADAL" clId="{985CD171-9E4A-4264-B045-872AAA800AE3}" dt="2024-10-16T08:00:33.047" v="616" actId="14100"/>
-        <pc:sldMkLst>
-          <pc:docMk/>
-          <pc:sldMk cId="4051642265" sldId="268"/>
-        </pc:sldMkLst>
-      </pc:sldChg>
-      <pc:sldChg chg="addSp modSp add">
-        <pc:chgData name="Mohammed Fasha" userId="cc64f42d-a1a6-4f08-b97b-0c37f877119f" providerId="ADAL" clId="{985CD171-9E4A-4264-B045-872AAA800AE3}" dt="2024-10-16T07:04:05.205" v="412" actId="14100"/>
-        <pc:sldMkLst>
-          <pc:docMk/>
-          <pc:sldMk cId="87410777" sldId="269"/>
-        </pc:sldMkLst>
-      </pc:sldChg>
-      <pc:sldChg chg="addSp modSp add">
-        <pc:chgData name="Mohammed Fasha" userId="cc64f42d-a1a6-4f08-b97b-0c37f877119f" providerId="ADAL" clId="{985CD171-9E4A-4264-B045-872AAA800AE3}" dt="2024-10-16T07:04:34.185" v="419" actId="14100"/>
-        <pc:sldMkLst>
-          <pc:docMk/>
-          <pc:sldMk cId="595502031" sldId="270"/>
-        </pc:sldMkLst>
-      </pc:sldChg>
-      <pc:sldChg chg="addSp modSp add ord">
-        <pc:chgData name="Mohammed Fasha" userId="cc64f42d-a1a6-4f08-b97b-0c37f877119f" providerId="ADAL" clId="{985CD171-9E4A-4264-B045-872AAA800AE3}" dt="2024-10-16T07:03:52.480" v="404" actId="27636"/>
-        <pc:sldMkLst>
-          <pc:docMk/>
-          <pc:sldMk cId="3925652072" sldId="271"/>
-        </pc:sldMkLst>
-      </pc:sldChg>
-      <pc:sldChg chg="addSp modSp add">
-        <pc:chgData name="Mohammed Fasha" userId="cc64f42d-a1a6-4f08-b97b-0c37f877119f" providerId="ADAL" clId="{985CD171-9E4A-4264-B045-872AAA800AE3}" dt="2024-10-16T07:04:42.805" v="424" actId="1076"/>
-        <pc:sldMkLst>
-          <pc:docMk/>
-          <pc:sldMk cId="463115072" sldId="272"/>
-        </pc:sldMkLst>
-      </pc:sldChg>
-      <pc:sldChg chg="addSp modSp add">
-        <pc:chgData name="Mohammed Fasha" userId="cc64f42d-a1a6-4f08-b97b-0c37f877119f" providerId="ADAL" clId="{985CD171-9E4A-4264-B045-872AAA800AE3}" dt="2024-10-16T07:06:32.789" v="441" actId="14100"/>
-        <pc:sldMkLst>
-          <pc:docMk/>
-          <pc:sldMk cId="3668955903" sldId="273"/>
-        </pc:sldMkLst>
-      </pc:sldChg>
-      <pc:sldChg chg="addSp delSp modSp add">
-        <pc:chgData name="Mohammed Fasha" userId="cc64f42d-a1a6-4f08-b97b-0c37f877119f" providerId="ADAL" clId="{985CD171-9E4A-4264-B045-872AAA800AE3}" dt="2024-10-16T07:06:45.628" v="449" actId="27636"/>
-        <pc:sldMkLst>
-          <pc:docMk/>
-          <pc:sldMk cId="3192380798" sldId="274"/>
-        </pc:sldMkLst>
-      </pc:sldChg>
-      <pc:sldChg chg="addSp modSp add">
-        <pc:chgData name="Mohammed Fasha" userId="cc64f42d-a1a6-4f08-b97b-0c37f877119f" providerId="ADAL" clId="{985CD171-9E4A-4264-B045-872AAA800AE3}" dt="2024-10-16T07:07:23.747" v="460" actId="20577"/>
-        <pc:sldMkLst>
-          <pc:docMk/>
-          <pc:sldMk cId="3898002179" sldId="275"/>
-        </pc:sldMkLst>
-      </pc:sldChg>
-      <pc:sldChg chg="addSp modSp add">
-        <pc:chgData name="Mohammed Fasha" userId="cc64f42d-a1a6-4f08-b97b-0c37f877119f" providerId="ADAL" clId="{985CD171-9E4A-4264-B045-872AAA800AE3}" dt="2024-10-16T07:07:35.379" v="465" actId="27636"/>
-        <pc:sldMkLst>
-          <pc:docMk/>
-          <pc:sldMk cId="1503352162" sldId="276"/>
-        </pc:sldMkLst>
-      </pc:sldChg>
-      <pc:sldChg chg="addSp delSp modSp add">
-        <pc:chgData name="Mohammed Fasha" userId="cc64f42d-a1a6-4f08-b97b-0c37f877119f" providerId="ADAL" clId="{985CD171-9E4A-4264-B045-872AAA800AE3}" dt="2024-10-16T07:28:38.184" v="537" actId="948"/>
-        <pc:sldMkLst>
-          <pc:docMk/>
-          <pc:sldMk cId="1260131707" sldId="277"/>
-        </pc:sldMkLst>
-      </pc:sldChg>
-      <pc:sldChg chg="addSp modSp add ord">
-        <pc:chgData name="Mohammed Fasha" userId="cc64f42d-a1a6-4f08-b97b-0c37f877119f" providerId="ADAL" clId="{985CD171-9E4A-4264-B045-872AAA800AE3}" dt="2024-10-16T07:16:54.093" v="501" actId="27636"/>
-        <pc:sldMkLst>
-          <pc:docMk/>
-          <pc:sldMk cId="1324937023" sldId="280"/>
-        </pc:sldMkLst>
-      </pc:sldChg>
-      <pc:sldChg chg="addSp delSp modSp add">
-        <pc:chgData name="Mohammed Fasha" userId="cc64f42d-a1a6-4f08-b97b-0c37f877119f" providerId="ADAL" clId="{985CD171-9E4A-4264-B045-872AAA800AE3}" dt="2024-10-16T07:44:30.797" v="606" actId="5793"/>
-        <pc:sldMkLst>
-          <pc:docMk/>
-          <pc:sldMk cId="4085727926" sldId="281"/>
-        </pc:sldMkLst>
-      </pc:sldChg>
-      <pc:sldChg chg="addSp modSp add">
-        <pc:chgData name="Mohammed Fasha" userId="cc64f42d-a1a6-4f08-b97b-0c37f877119f" providerId="ADAL" clId="{985CD171-9E4A-4264-B045-872AAA800AE3}" dt="2024-10-16T08:01:33.772" v="621" actId="403"/>
-        <pc:sldMkLst>
-          <pc:docMk/>
-          <pc:sldMk cId="156012141" sldId="282"/>
-        </pc:sldMkLst>
-      </pc:sldChg>
-      <pc:sldChg chg="addSp modSp add">
-        <pc:chgData name="Mohammed Fasha" userId="cc64f42d-a1a6-4f08-b97b-0c37f877119f" providerId="ADAL" clId="{985CD171-9E4A-4264-B045-872AAA800AE3}" dt="2024-10-16T08:02:59.311" v="633" actId="404"/>
-        <pc:sldMkLst>
-          <pc:docMk/>
-          <pc:sldMk cId="248623450" sldId="284"/>
-        </pc:sldMkLst>
-      </pc:sldChg>
-    </pc:docChg>
-  </pc:docChgLst>
-  <pc:docChgLst>
-    <pc:chgData name="Mohammed Fasha" userId="cc64f42d-a1a6-4f08-b97b-0c37f877119f" providerId="ADAL" clId="{30DD28B9-8B97-487C-83EE-EC2EB54F3F9E}"/>
-    <pc:docChg chg="undo custSel modSld">
-      <pc:chgData name="Mohammed Fasha" userId="cc64f42d-a1a6-4f08-b97b-0c37f877119f" providerId="ADAL" clId="{30DD28B9-8B97-487C-83EE-EC2EB54F3F9E}" dt="2024-10-17T03:04:01.750" v="11" actId="1076"/>
+    <pc:chgData name="Mohammed Fasha" userId="cc64f42d-a1a6-4f08-b97b-0c37f877119f" providerId="ADAL" clId="{D331B2BD-EE59-4AEA-B1BA-D31F2104078E}"/>
+    <pc:docChg chg="undo custSel delSld modSld">
+      <pc:chgData name="Mohammed Fasha" userId="cc64f42d-a1a6-4f08-b97b-0c37f877119f" providerId="ADAL" clId="{D331B2BD-EE59-4AEA-B1BA-D31F2104078E}" dt="2025-07-26T19:56:58.473" v="16" actId="2696"/>
       <pc:docMkLst>
         <pc:docMk/>
       </pc:docMkLst>
       <pc:sldChg chg="modSp mod">
-        <pc:chgData name="Mohammed Fasha" userId="cc64f42d-a1a6-4f08-b97b-0c37f877119f" providerId="ADAL" clId="{30DD28B9-8B97-487C-83EE-EC2EB54F3F9E}" dt="2024-10-16T20:03:44.325" v="2" actId="20577"/>
-        <pc:sldMkLst>
-          <pc:docMk/>
-          <pc:sldMk cId="1162554463" sldId="257"/>
-        </pc:sldMkLst>
+        <pc:chgData name="Mohammed Fasha" userId="cc64f42d-a1a6-4f08-b97b-0c37f877119f" providerId="ADAL" clId="{D331B2BD-EE59-4AEA-B1BA-D31F2104078E}" dt="2025-07-26T19:56:50.260" v="15" actId="404"/>
+        <pc:sldMkLst>
+          <pc:docMk/>
+          <pc:sldMk cId="2379583142" sldId="461"/>
+        </pc:sldMkLst>
+        <pc:spChg chg="mod">
+          <ac:chgData name="Mohammed Fasha" userId="cc64f42d-a1a6-4f08-b97b-0c37f877119f" providerId="ADAL" clId="{D331B2BD-EE59-4AEA-B1BA-D31F2104078E}" dt="2025-07-26T19:56:50.260" v="15" actId="404"/>
+          <ac:spMkLst>
+            <pc:docMk/>
+            <pc:sldMk cId="2379583142" sldId="461"/>
+            <ac:spMk id="2" creationId="{E9432BF3-EBC3-84DA-6256-9DFBD39C3EF8}"/>
+          </ac:spMkLst>
+        </pc:spChg>
       </pc:sldChg>
       <pc:sldChg chg="modSp mod">
-        <pc:chgData name="Mohammed Fasha" userId="cc64f42d-a1a6-4f08-b97b-0c37f877119f" providerId="ADAL" clId="{30DD28B9-8B97-487C-83EE-EC2EB54F3F9E}" dt="2024-10-16T20:03:53.393" v="4" actId="113"/>
-        <pc:sldMkLst>
-          <pc:docMk/>
-          <pc:sldMk cId="706735111" sldId="258"/>
-        </pc:sldMkLst>
-      </pc:sldChg>
-      <pc:sldChg chg="addSp delSp modSp mod">
-        <pc:chgData name="Mohammed Fasha" userId="cc64f42d-a1a6-4f08-b97b-0c37f877119f" providerId="ADAL" clId="{30DD28B9-8B97-487C-83EE-EC2EB54F3F9E}" dt="2024-10-16T20:04:08.776" v="6"/>
-        <pc:sldMkLst>
-          <pc:docMk/>
-          <pc:sldMk cId="2433706687" sldId="267"/>
-        </pc:sldMkLst>
-      </pc:sldChg>
-      <pc:sldChg chg="addSp delSp modSp mod">
-        <pc:chgData name="Mohammed Fasha" userId="cc64f42d-a1a6-4f08-b97b-0c37f877119f" providerId="ADAL" clId="{30DD28B9-8B97-487C-83EE-EC2EB54F3F9E}" dt="2024-10-16T20:04:23.488" v="10" actId="27636"/>
-        <pc:sldMkLst>
-          <pc:docMk/>
-          <pc:sldMk cId="3925652072" sldId="271"/>
-        </pc:sldMkLst>
+        <pc:chgData name="Mohammed Fasha" userId="cc64f42d-a1a6-4f08-b97b-0c37f877119f" providerId="ADAL" clId="{D331B2BD-EE59-4AEA-B1BA-D31F2104078E}" dt="2025-07-26T19:56:40.144" v="13" actId="1076"/>
+        <pc:sldMkLst>
+          <pc:docMk/>
+          <pc:sldMk cId="3023150924" sldId="464"/>
+        </pc:sldMkLst>
+        <pc:spChg chg="mod">
+          <ac:chgData name="Mohammed Fasha" userId="cc64f42d-a1a6-4f08-b97b-0c37f877119f" providerId="ADAL" clId="{D331B2BD-EE59-4AEA-B1BA-D31F2104078E}" dt="2025-07-26T19:56:16.530" v="3" actId="404"/>
+          <ac:spMkLst>
+            <pc:docMk/>
+            <pc:sldMk cId="3023150924" sldId="464"/>
+            <ac:spMk id="2" creationId="{72CCFD12-F425-AC53-BAE4-0789C679F3A2}"/>
+          </ac:spMkLst>
+        </pc:spChg>
+        <pc:spChg chg="mod">
+          <ac:chgData name="Mohammed Fasha" userId="cc64f42d-a1a6-4f08-b97b-0c37f877119f" providerId="ADAL" clId="{D331B2BD-EE59-4AEA-B1BA-D31F2104078E}" dt="2025-07-26T19:56:32.132" v="11" actId="20577"/>
+          <ac:spMkLst>
+            <pc:docMk/>
+            <pc:sldMk cId="3023150924" sldId="464"/>
+            <ac:spMk id="3" creationId="{26890392-F0BA-0E3C-CD57-49CE7E553F8A}"/>
+          </ac:spMkLst>
+        </pc:spChg>
+        <pc:spChg chg="mod">
+          <ac:chgData name="Mohammed Fasha" userId="cc64f42d-a1a6-4f08-b97b-0c37f877119f" providerId="ADAL" clId="{D331B2BD-EE59-4AEA-B1BA-D31F2104078E}" dt="2025-07-26T19:56:40.144" v="13" actId="1076"/>
+          <ac:spMkLst>
+            <pc:docMk/>
+            <pc:sldMk cId="3023150924" sldId="464"/>
+            <ac:spMk id="6" creationId="{662085E8-4729-ABEA-CF3B-6D6A07B7AFBC}"/>
+          </ac:spMkLst>
+        </pc:spChg>
+        <pc:spChg chg="mod">
+          <ac:chgData name="Mohammed Fasha" userId="cc64f42d-a1a6-4f08-b97b-0c37f877119f" providerId="ADAL" clId="{D331B2BD-EE59-4AEA-B1BA-D31F2104078E}" dt="2025-07-26T19:56:36.461" v="12" actId="1076"/>
+          <ac:spMkLst>
+            <pc:docMk/>
+            <pc:sldMk cId="3023150924" sldId="464"/>
+            <ac:spMk id="14" creationId="{C1A4FAFC-84E3-834F-0083-768B251E93B2}"/>
+          </ac:spMkLst>
+        </pc:spChg>
       </pc:sldChg>
       <pc:sldChg chg="modSp mod">
-        <pc:chgData name="Mohammed Fasha" userId="cc64f42d-a1a6-4f08-b97b-0c37f877119f" providerId="ADAL" clId="{30DD28B9-8B97-487C-83EE-EC2EB54F3F9E}" dt="2024-10-17T03:04:01.750" v="11" actId="1076"/>
-        <pc:sldMkLst>
-          <pc:docMk/>
-          <pc:sldMk cId="1489447582" sldId="455"/>
+        <pc:chgData name="Mohammed Fasha" userId="cc64f42d-a1a6-4f08-b97b-0c37f877119f" providerId="ADAL" clId="{D331B2BD-EE59-4AEA-B1BA-D31F2104078E}" dt="2025-07-26T19:56:08.364" v="1" actId="404"/>
+        <pc:sldMkLst>
+          <pc:docMk/>
+          <pc:sldMk cId="3447719930" sldId="465"/>
+        </pc:sldMkLst>
+        <pc:spChg chg="mod">
+          <ac:chgData name="Mohammed Fasha" userId="cc64f42d-a1a6-4f08-b97b-0c37f877119f" providerId="ADAL" clId="{D331B2BD-EE59-4AEA-B1BA-D31F2104078E}" dt="2025-07-26T19:56:08.364" v="1" actId="404"/>
+          <ac:spMkLst>
+            <pc:docMk/>
+            <pc:sldMk cId="3447719930" sldId="465"/>
+            <ac:spMk id="5" creationId="{1964B083-4476-5095-5711-CEF1D791A9AB}"/>
+          </ac:spMkLst>
+        </pc:spChg>
+      </pc:sldChg>
+      <pc:sldChg chg="del">
+        <pc:chgData name="Mohammed Fasha" userId="cc64f42d-a1a6-4f08-b97b-0c37f877119f" providerId="ADAL" clId="{D331B2BD-EE59-4AEA-B1BA-D31F2104078E}" dt="2025-07-26T19:56:58.473" v="16" actId="2696"/>
+        <pc:sldMkLst>
+          <pc:docMk/>
+          <pc:sldMk cId="732047524" sldId="466"/>
+        </pc:sldMkLst>
+      </pc:sldChg>
+      <pc:sldChg chg="del">
+        <pc:chgData name="Mohammed Fasha" userId="cc64f42d-a1a6-4f08-b97b-0c37f877119f" providerId="ADAL" clId="{D331B2BD-EE59-4AEA-B1BA-D31F2104078E}" dt="2025-07-26T19:56:58.473" v="16" actId="2696"/>
+        <pc:sldMkLst>
+          <pc:docMk/>
+          <pc:sldMk cId="1671393962" sldId="467"/>
+        </pc:sldMkLst>
+      </pc:sldChg>
+      <pc:sldChg chg="del">
+        <pc:chgData name="Mohammed Fasha" userId="cc64f42d-a1a6-4f08-b97b-0c37f877119f" providerId="ADAL" clId="{D331B2BD-EE59-4AEA-B1BA-D31F2104078E}" dt="2025-07-26T19:56:58.473" v="16" actId="2696"/>
+        <pc:sldMkLst>
+          <pc:docMk/>
+          <pc:sldMk cId="934545252" sldId="468"/>
+        </pc:sldMkLst>
+      </pc:sldChg>
+      <pc:sldChg chg="del">
+        <pc:chgData name="Mohammed Fasha" userId="cc64f42d-a1a6-4f08-b97b-0c37f877119f" providerId="ADAL" clId="{D331B2BD-EE59-4AEA-B1BA-D31F2104078E}" dt="2025-07-26T19:56:58.473" v="16" actId="2696"/>
+        <pc:sldMkLst>
+          <pc:docMk/>
+          <pc:sldMk cId="2026905861" sldId="469"/>
         </pc:sldMkLst>
       </pc:sldChg>
     </pc:docChg>
   </pc:docChgLst>
   <pc:docChgLst>
-    <pc:chgData name="Mohammed Fasha" userId="cc64f42d-a1a6-4f08-b97b-0c37f877119f" providerId="ADAL" clId="{D3520BFC-89CF-4CB5-8BC6-02854ED6C636}"/>
-    <pc:docChg chg="undo custSel addSld delSld modSld modMainMaster">
-      <pc:chgData name="Mohammed Fasha" userId="cc64f42d-a1a6-4f08-b97b-0c37f877119f" providerId="ADAL" clId="{D3520BFC-89CF-4CB5-8BC6-02854ED6C636}" dt="2024-10-16T09:49:25.572" v="384"/>
+    <pc:chgData name="Mohammed Fasha" userId="cc64f42d-a1a6-4f08-b97b-0c37f877119f" providerId="ADAL" clId="{F585A28F-34F7-4D28-B641-78252DAB29E0}"/>
+    <pc:docChg chg="undo custSel modSld sldOrd">
+      <pc:chgData name="Mohammed Fasha" userId="cc64f42d-a1a6-4f08-b97b-0c37f877119f" providerId="ADAL" clId="{F585A28F-34F7-4D28-B641-78252DAB29E0}" dt="2025-07-16T09:17:57.509" v="81" actId="114"/>
       <pc:docMkLst>
         <pc:docMk/>
       </pc:docMkLst>
-      <pc:sldChg chg="modSp">
-        <pc:chgData name="Mohammed Fasha" userId="cc64f42d-a1a6-4f08-b97b-0c37f877119f" providerId="ADAL" clId="{D3520BFC-89CF-4CB5-8BC6-02854ED6C636}" dt="2024-10-16T09:27:15.806" v="128" actId="1076"/>
-        <pc:sldMkLst>
-          <pc:docMk/>
-          <pc:sldMk cId="706735111" sldId="258"/>
-        </pc:sldMkLst>
-      </pc:sldChg>
       <pc:sldChg chg="modSp mod">
-        <pc:chgData name="Mohammed Fasha" userId="cc64f42d-a1a6-4f08-b97b-0c37f877119f" providerId="ADAL" clId="{D3520BFC-89CF-4CB5-8BC6-02854ED6C636}" dt="2024-10-16T09:44:32.790" v="325" actId="27636"/>
-        <pc:sldMkLst>
-          <pc:docMk/>
-          <pc:sldMk cId="4289469650" sldId="261"/>
-        </pc:sldMkLst>
-      </pc:sldChg>
-      <pc:sldChg chg="addSp delSp modSp mod">
-        <pc:chgData name="Mohammed Fasha" userId="cc64f42d-a1a6-4f08-b97b-0c37f877119f" providerId="ADAL" clId="{D3520BFC-89CF-4CB5-8BC6-02854ED6C636}" dt="2024-10-16T09:28:12.841" v="142" actId="1076"/>
-        <pc:sldMkLst>
-          <pc:docMk/>
-          <pc:sldMk cId="4130133658" sldId="262"/>
-        </pc:sldMkLst>
-      </pc:sldChg>
-      <pc:sldChg chg="addSp delSp modSp mod chgLayout">
-        <pc:chgData name="Mohammed Fasha" userId="cc64f42d-a1a6-4f08-b97b-0c37f877119f" providerId="ADAL" clId="{D3520BFC-89CF-4CB5-8BC6-02854ED6C636}" dt="2024-10-16T09:43:01.102" v="281" actId="14100"/>
-        <pc:sldMkLst>
-          <pc:docMk/>
-          <pc:sldMk cId="2611575643" sldId="264"/>
+        <pc:chgData name="Mohammed Fasha" userId="cc64f42d-a1a6-4f08-b97b-0c37f877119f" providerId="ADAL" clId="{F585A28F-34F7-4D28-B641-78252DAB29E0}" dt="2025-07-16T09:14:06.583" v="24" actId="27636"/>
+        <pc:sldMkLst>
+          <pc:docMk/>
+          <pc:sldMk cId="1162554463" sldId="257"/>
         </pc:sldMkLst>
       </pc:sldChg>
       <pc:sldChg chg="modSp mod">
-        <pc:chgData name="Mohammed Fasha" userId="cc64f42d-a1a6-4f08-b97b-0c37f877119f" providerId="ADAL" clId="{D3520BFC-89CF-4CB5-8BC6-02854ED6C636}" dt="2024-10-16T09:24:41.861" v="53" actId="14100"/>
-        <pc:sldMkLst>
-          <pc:docMk/>
-          <pc:sldMk cId="3898002179" sldId="275"/>
-        </pc:sldMkLst>
-      </pc:sldChg>
-      <pc:sldChg chg="addSp delSp modSp mod">
-        <pc:chgData name="Mohammed Fasha" userId="cc64f42d-a1a6-4f08-b97b-0c37f877119f" providerId="ADAL" clId="{D3520BFC-89CF-4CB5-8BC6-02854ED6C636}" dt="2024-10-16T09:24:38.381" v="52" actId="27636"/>
-        <pc:sldMkLst>
-          <pc:docMk/>
-          <pc:sldMk cId="1503352162" sldId="276"/>
+        <pc:chgData name="Mohammed Fasha" userId="cc64f42d-a1a6-4f08-b97b-0c37f877119f" providerId="ADAL" clId="{F585A28F-34F7-4D28-B641-78252DAB29E0}" dt="2025-07-16T09:14:22.611" v="25" actId="20577"/>
+        <pc:sldMkLst>
+          <pc:docMk/>
+          <pc:sldMk cId="2881282849" sldId="459"/>
+        </pc:sldMkLst>
+      </pc:sldChg>
+      <pc:sldChg chg="modSp mod ord">
+        <pc:chgData name="Mohammed Fasha" userId="cc64f42d-a1a6-4f08-b97b-0c37f877119f" providerId="ADAL" clId="{F585A28F-34F7-4D28-B641-78252DAB29E0}" dt="2025-07-16T09:17:57.509" v="81" actId="114"/>
+        <pc:sldMkLst>
+          <pc:docMk/>
+          <pc:sldMk cId="1427723282" sldId="462"/>
         </pc:sldMkLst>
       </pc:sldChg>
       <pc:sldChg chg="modSp mod">
-        <pc:chgData name="Mohammed Fasha" userId="cc64f42d-a1a6-4f08-b97b-0c37f877119f" providerId="ADAL" clId="{D3520BFC-89CF-4CB5-8BC6-02854ED6C636}" dt="2024-10-16T09:48:50.906" v="382"/>
-        <pc:sldMkLst>
-          <pc:docMk/>
-          <pc:sldMk cId="1260131707" sldId="277"/>
+        <pc:chgData name="Mohammed Fasha" userId="cc64f42d-a1a6-4f08-b97b-0c37f877119f" providerId="ADAL" clId="{F585A28F-34F7-4D28-B641-78252DAB29E0}" dt="2025-07-16T09:12:22.563" v="0" actId="404"/>
+        <pc:sldMkLst>
+          <pc:docMk/>
+          <pc:sldMk cId="2145969539" sldId="478"/>
         </pc:sldMkLst>
       </pc:sldChg>
       <pc:sldChg chg="modSp mod">
-        <pc:chgData name="Mohammed Fasha" userId="cc64f42d-a1a6-4f08-b97b-0c37f877119f" providerId="ADAL" clId="{D3520BFC-89CF-4CB5-8BC6-02854ED6C636}" dt="2024-10-16T09:47:08.623" v="367" actId="179"/>
-        <pc:sldMkLst>
-          <pc:docMk/>
-          <pc:sldMk cId="1324937023" sldId="280"/>
+        <pc:chgData name="Mohammed Fasha" userId="cc64f42d-a1a6-4f08-b97b-0c37f877119f" providerId="ADAL" clId="{F585A28F-34F7-4D28-B641-78252DAB29E0}" dt="2025-07-16T09:14:47.069" v="29" actId="255"/>
+        <pc:sldMkLst>
+          <pc:docMk/>
+          <pc:sldMk cId="1427132372" sldId="479"/>
         </pc:sldMkLst>
       </pc:sldChg>
       <pc:sldChg chg="modSp mod">
-        <pc:chgData name="Mohammed Fasha" userId="cc64f42d-a1a6-4f08-b97b-0c37f877119f" providerId="ADAL" clId="{D3520BFC-89CF-4CB5-8BC6-02854ED6C636}" dt="2024-10-16T09:44:54.951" v="335" actId="6549"/>
-        <pc:sldMkLst>
-          <pc:docMk/>
-          <pc:sldMk cId="4085727926" sldId="281"/>
+        <pc:chgData name="Mohammed Fasha" userId="cc64f42d-a1a6-4f08-b97b-0c37f877119f" providerId="ADAL" clId="{F585A28F-34F7-4D28-B641-78252DAB29E0}" dt="2025-07-16T09:16:07.771" v="68" actId="1076"/>
+        <pc:sldMkLst>
+          <pc:docMk/>
+          <pc:sldMk cId="3075052158" sldId="480"/>
         </pc:sldMkLst>
       </pc:sldChg>
       <pc:sldChg chg="modSp mod">
-        <pc:chgData name="Mohammed Fasha" userId="cc64f42d-a1a6-4f08-b97b-0c37f877119f" providerId="ADAL" clId="{D3520BFC-89CF-4CB5-8BC6-02854ED6C636}" dt="2024-10-16T09:49:20.342" v="383"/>
-        <pc:sldMkLst>
-          <pc:docMk/>
-          <pc:sldMk cId="156012141" sldId="282"/>
-        </pc:sldMkLst>
-      </pc:sldChg>
-      <pc:sldChg chg="delSp modSp mod">
-        <pc:chgData name="Mohammed Fasha" userId="cc64f42d-a1a6-4f08-b97b-0c37f877119f" providerId="ADAL" clId="{D3520BFC-89CF-4CB5-8BC6-02854ED6C636}" dt="2024-10-16T09:49:25.572" v="384"/>
-        <pc:sldMkLst>
-          <pc:docMk/>
-          <pc:sldMk cId="248623450" sldId="284"/>
-        </pc:sldMkLst>
-      </pc:sldChg>
-      <pc:sldChg chg="addSp modSp add mod">
-        <pc:chgData name="Mohammed Fasha" userId="cc64f42d-a1a6-4f08-b97b-0c37f877119f" providerId="ADAL" clId="{D3520BFC-89CF-4CB5-8BC6-02854ED6C636}" dt="2024-10-16T09:31:53.226" v="265" actId="20577"/>
-        <pc:sldMkLst>
-          <pc:docMk/>
-          <pc:sldMk cId="1489447582" sldId="455"/>
-        </pc:sldMkLst>
-      </pc:sldChg>
-      <pc:sldMasterChg chg="addSp modSp modSldLayout">
-        <pc:chgData name="Mohammed Fasha" userId="cc64f42d-a1a6-4f08-b97b-0c37f877119f" providerId="ADAL" clId="{D3520BFC-89CF-4CB5-8BC6-02854ED6C636}" dt="2024-10-16T09:31:03.810" v="239" actId="14100"/>
-        <pc:sldMasterMkLst>
-          <pc:docMk/>
-          <pc:sldMasterMk cId="2573801746" sldId="2147483648"/>
-        </pc:sldMasterMkLst>
-        <pc:sldLayoutChg chg="addSp modSp">
-          <pc:chgData name="Mohammed Fasha" userId="cc64f42d-a1a6-4f08-b97b-0c37f877119f" providerId="ADAL" clId="{D3520BFC-89CF-4CB5-8BC6-02854ED6C636}" dt="2024-10-16T09:26:29.266" v="116"/>
-          <pc:sldLayoutMkLst>
-            <pc:docMk/>
-            <pc:sldMasterMk cId="2573801746" sldId="2147483648"/>
-            <pc:sldLayoutMk cId="1871815692" sldId="2147483649"/>
-          </pc:sldLayoutMkLst>
-        </pc:sldLayoutChg>
-        <pc:sldLayoutChg chg="modSp mod">
-          <pc:chgData name="Mohammed Fasha" userId="cc64f42d-a1a6-4f08-b97b-0c37f877119f" providerId="ADAL" clId="{D3520BFC-89CF-4CB5-8BC6-02854ED6C636}" dt="2024-10-16T09:31:03.810" v="239" actId="14100"/>
-          <pc:sldLayoutMkLst>
-            <pc:docMk/>
-            <pc:sldMasterMk cId="2573801746" sldId="2147483648"/>
-            <pc:sldLayoutMk cId="3033015503" sldId="2147483650"/>
-          </pc:sldLayoutMkLst>
-        </pc:sldLayoutChg>
-      </pc:sldMasterChg>
-    </pc:docChg>
-  </pc:docChgLst>
-  <pc:docChgLst>
-    <pc:chgData name="Mohammed Fasha" userId="cc64f42d-a1a6-4f08-b97b-0c37f877119f" providerId="ADAL" clId="{D1859E10-E91F-4CD4-B9AD-657F2116AC8C}"/>
-    <pc:docChg chg="custSel modMainMaster">
-      <pc:chgData name="Mohammed Fasha" userId="cc64f42d-a1a6-4f08-b97b-0c37f877119f" providerId="ADAL" clId="{D1859E10-E91F-4CD4-B9AD-657F2116AC8C}" dt="2024-11-09T05:23:14.444" v="3" actId="1076"/>
-      <pc:docMkLst>
-        <pc:docMk/>
-      </pc:docMkLst>
-      <pc:sldMasterChg chg="addSp delSp modSp mod">
-        <pc:chgData name="Mohammed Fasha" userId="cc64f42d-a1a6-4f08-b97b-0c37f877119f" providerId="ADAL" clId="{D1859E10-E91F-4CD4-B9AD-657F2116AC8C}" dt="2024-11-09T05:23:14.444" v="3" actId="1076"/>
-        <pc:sldMasterMkLst>
-          <pc:docMk/>
-          <pc:sldMasterMk cId="2573801746" sldId="2147483648"/>
-        </pc:sldMasterMkLst>
-      </pc:sldMasterChg>
-    </pc:docChg>
-  </pc:docChgLst>
-  <pc:docChgLst>
-    <pc:chgData name="Mohammed Fasha" userId="S::mohammed.fasha@uop.edu.jo::cc64f42d-a1a6-4f08-b97b-0c37f877119f" providerId="AD" clId="Web-{183AE7D0-0422-8839-EC6E-29E0859D7097}"/>
-    <pc:docChg chg="addSld delSld modSld">
-      <pc:chgData name="Mohammed Fasha" userId="S::mohammed.fasha@uop.edu.jo::cc64f42d-a1a6-4f08-b97b-0c37f877119f" providerId="AD" clId="Web-{183AE7D0-0422-8839-EC6E-29E0859D7097}" dt="2025-07-16T14:35:10.276" v="63" actId="20577"/>
-      <pc:docMkLst>
-        <pc:docMk/>
-      </pc:docMkLst>
-      <pc:sldChg chg="del">
-        <pc:chgData name="Mohammed Fasha" userId="S::mohammed.fasha@uop.edu.jo::cc64f42d-a1a6-4f08-b97b-0c37f877119f" providerId="AD" clId="Web-{183AE7D0-0422-8839-EC6E-29E0859D7097}" dt="2025-07-16T14:30:46.940" v="18"/>
-        <pc:sldMkLst>
-          <pc:docMk/>
-          <pc:sldMk cId="1162554463" sldId="257"/>
-        </pc:sldMkLst>
-      </pc:sldChg>
-      <pc:sldChg chg="modSp">
-        <pc:chgData name="Mohammed Fasha" userId="S::mohammed.fasha@uop.edu.jo::cc64f42d-a1a6-4f08-b97b-0c37f877119f" providerId="AD" clId="Web-{183AE7D0-0422-8839-EC6E-29E0859D7097}" dt="2025-07-16T14:30:58.893" v="25" actId="20577"/>
-        <pc:sldMkLst>
-          <pc:docMk/>
-          <pc:sldMk cId="1489447582" sldId="455"/>
-        </pc:sldMkLst>
-        <pc:spChg chg="mod">
-          <ac:chgData name="Mohammed Fasha" userId="S::mohammed.fasha@uop.edu.jo::cc64f42d-a1a6-4f08-b97b-0c37f877119f" providerId="AD" clId="Web-{183AE7D0-0422-8839-EC6E-29E0859D7097}" dt="2025-07-16T14:30:58.893" v="25" actId="20577"/>
-          <ac:spMkLst>
-            <pc:docMk/>
-            <pc:sldMk cId="1489447582" sldId="455"/>
-            <ac:spMk id="9" creationId="{F599965F-D781-62F6-30A4-33D89AC89080}"/>
-          </ac:spMkLst>
-        </pc:spChg>
-      </pc:sldChg>
-      <pc:sldChg chg="addSp delSp modSp new">
-        <pc:chgData name="Mohammed Fasha" userId="S::mohammed.fasha@uop.edu.jo::cc64f42d-a1a6-4f08-b97b-0c37f877119f" providerId="AD" clId="Web-{183AE7D0-0422-8839-EC6E-29E0859D7097}" dt="2025-07-16T14:34:44.681" v="61" actId="1076"/>
-        <pc:sldMkLst>
-          <pc:docMk/>
-          <pc:sldMk cId="2145144810" sldId="456"/>
-        </pc:sldMkLst>
-        <pc:spChg chg="mod">
-          <ac:chgData name="Mohammed Fasha" userId="S::mohammed.fasha@uop.edu.jo::cc64f42d-a1a6-4f08-b97b-0c37f877119f" providerId="AD" clId="Web-{183AE7D0-0422-8839-EC6E-29E0859D7097}" dt="2025-07-16T14:34:05.243" v="54" actId="14100"/>
-          <ac:spMkLst>
-            <pc:docMk/>
-            <pc:sldMk cId="2145144810" sldId="456"/>
-            <ac:spMk id="2" creationId="{A67F3E90-0FEA-4491-CD3B-54061E231F3E}"/>
-          </ac:spMkLst>
-        </pc:spChg>
-        <pc:spChg chg="mod">
-          <ac:chgData name="Mohammed Fasha" userId="S::mohammed.fasha@uop.edu.jo::cc64f42d-a1a6-4f08-b97b-0c37f877119f" providerId="AD" clId="Web-{183AE7D0-0422-8839-EC6E-29E0859D7097}" dt="2025-07-16T14:31:52.473" v="35" actId="20577"/>
-          <ac:spMkLst>
-            <pc:docMk/>
-            <pc:sldMk cId="2145144810" sldId="456"/>
-            <ac:spMk id="3" creationId="{E3173229-46D2-444C-C512-9405F10F26F7}"/>
-          </ac:spMkLst>
-        </pc:spChg>
-        <pc:picChg chg="add del mod">
-          <ac:chgData name="Mohammed Fasha" userId="S::mohammed.fasha@uop.edu.jo::cc64f42d-a1a6-4f08-b97b-0c37f877119f" providerId="AD" clId="Web-{183AE7D0-0422-8839-EC6E-29E0859D7097}" dt="2025-07-16T14:33:34.414" v="41"/>
-          <ac:picMkLst>
-            <pc:docMk/>
-            <pc:sldMk cId="2145144810" sldId="456"/>
-            <ac:picMk id="4" creationId="{BA278F11-B70C-27A1-0E59-D5270863018F}"/>
-          </ac:picMkLst>
-        </pc:picChg>
-        <pc:picChg chg="add del mod">
-          <ac:chgData name="Mohammed Fasha" userId="S::mohammed.fasha@uop.edu.jo::cc64f42d-a1a6-4f08-b97b-0c37f877119f" providerId="AD" clId="Web-{183AE7D0-0422-8839-EC6E-29E0859D7097}" dt="2025-07-16T14:34:22.103" v="55"/>
-          <ac:picMkLst>
-            <pc:docMk/>
-            <pc:sldMk cId="2145144810" sldId="456"/>
-            <ac:picMk id="5" creationId="{0C056EA8-D252-41C8-4ADC-C056279E7D68}"/>
-          </ac:picMkLst>
-        </pc:picChg>
-        <pc:picChg chg="add mod">
-          <ac:chgData name="Mohammed Fasha" userId="S::mohammed.fasha@uop.edu.jo::cc64f42d-a1a6-4f08-b97b-0c37f877119f" providerId="AD" clId="Web-{183AE7D0-0422-8839-EC6E-29E0859D7097}" dt="2025-07-16T14:34:44.681" v="61" actId="1076"/>
-          <ac:picMkLst>
-            <pc:docMk/>
-            <pc:sldMk cId="2145144810" sldId="456"/>
-            <ac:picMk id="6" creationId="{C0C178FF-668E-3159-DDA2-ED1B4CB3BD07}"/>
-          </ac:picMkLst>
-        </pc:picChg>
-      </pc:sldChg>
-      <pc:sldChg chg="del">
-        <pc:chgData name="Mohammed Fasha" userId="S::mohammed.fasha@uop.edu.jo::cc64f42d-a1a6-4f08-b97b-0c37f877119f" providerId="AD" clId="Web-{183AE7D0-0422-8839-EC6E-29E0859D7097}" dt="2025-07-16T14:30:46.909" v="0"/>
-        <pc:sldMkLst>
-          <pc:docMk/>
-          <pc:sldMk cId="3910887702" sldId="456"/>
-        </pc:sldMkLst>
-      </pc:sldChg>
-      <pc:sldChg chg="new del">
-        <pc:chgData name="Mohammed Fasha" userId="S::mohammed.fasha@uop.edu.jo::cc64f42d-a1a6-4f08-b97b-0c37f877119f" providerId="AD" clId="Web-{183AE7D0-0422-8839-EC6E-29E0859D7097}" dt="2025-07-16T14:31:01.972" v="26"/>
-        <pc:sldMkLst>
-          <pc:docMk/>
-          <pc:sldMk cId="4030929307" sldId="456"/>
-        </pc:sldMkLst>
-      </pc:sldChg>
-      <pc:sldChg chg="modSp add replId">
-        <pc:chgData name="Mohammed Fasha" userId="S::mohammed.fasha@uop.edu.jo::cc64f42d-a1a6-4f08-b97b-0c37f877119f" providerId="AD" clId="Web-{183AE7D0-0422-8839-EC6E-29E0859D7097}" dt="2025-07-16T14:35:10.276" v="63" actId="20577"/>
-        <pc:sldMkLst>
-          <pc:docMk/>
-          <pc:sldMk cId="3415756226" sldId="457"/>
-        </pc:sldMkLst>
-        <pc:spChg chg="mod">
-          <ac:chgData name="Mohammed Fasha" userId="S::mohammed.fasha@uop.edu.jo::cc64f42d-a1a6-4f08-b97b-0c37f877119f" providerId="AD" clId="Web-{183AE7D0-0422-8839-EC6E-29E0859D7097}" dt="2025-07-16T14:35:10.276" v="63" actId="20577"/>
-          <ac:spMkLst>
-            <pc:docMk/>
-            <pc:sldMk cId="3415756226" sldId="457"/>
-            <ac:spMk id="2" creationId="{3F759ABC-7E4B-2A1B-D908-FABEB2278C30}"/>
-          </ac:spMkLst>
-        </pc:spChg>
-      </pc:sldChg>
-      <pc:sldChg chg="del">
-        <pc:chgData name="Mohammed Fasha" userId="S::mohammed.fasha@uop.edu.jo::cc64f42d-a1a6-4f08-b97b-0c37f877119f" providerId="AD" clId="Web-{183AE7D0-0422-8839-EC6E-29E0859D7097}" dt="2025-07-16T14:30:46.940" v="16"/>
-        <pc:sldMkLst>
-          <pc:docMk/>
-          <pc:sldMk cId="3639736080" sldId="457"/>
-        </pc:sldMkLst>
-      </pc:sldChg>
-      <pc:sldChg chg="del">
-        <pc:chgData name="Mohammed Fasha" userId="S::mohammed.fasha@uop.edu.jo::cc64f42d-a1a6-4f08-b97b-0c37f877119f" providerId="AD" clId="Web-{183AE7D0-0422-8839-EC6E-29E0859D7097}" dt="2025-07-16T14:30:46.924" v="15"/>
-        <pc:sldMkLst>
-          <pc:docMk/>
-          <pc:sldMk cId="2042404279" sldId="458"/>
-        </pc:sldMkLst>
-      </pc:sldChg>
-      <pc:sldChg chg="add replId">
-        <pc:chgData name="Mohammed Fasha" userId="S::mohammed.fasha@uop.edu.jo::cc64f42d-a1a6-4f08-b97b-0c37f877119f" providerId="AD" clId="Web-{183AE7D0-0422-8839-EC6E-29E0859D7097}" dt="2025-07-16T14:31:08.612" v="29"/>
-        <pc:sldMkLst>
-          <pc:docMk/>
-          <pc:sldMk cId="3207878978" sldId="458"/>
-        </pc:sldMkLst>
-      </pc:sldChg>
-      <pc:sldChg chg="del">
-        <pc:chgData name="Mohammed Fasha" userId="S::mohammed.fasha@uop.edu.jo::cc64f42d-a1a6-4f08-b97b-0c37f877119f" providerId="AD" clId="Web-{183AE7D0-0422-8839-EC6E-29E0859D7097}" dt="2025-07-16T14:30:46.924" v="14"/>
-        <pc:sldMkLst>
-          <pc:docMk/>
-          <pc:sldMk cId="2881282849" sldId="459"/>
-        </pc:sldMkLst>
-      </pc:sldChg>
-      <pc:sldChg chg="del">
-        <pc:chgData name="Mohammed Fasha" userId="S::mohammed.fasha@uop.edu.jo::cc64f42d-a1a6-4f08-b97b-0c37f877119f" providerId="AD" clId="Web-{183AE7D0-0422-8839-EC6E-29E0859D7097}" dt="2025-07-16T14:30:46.924" v="9"/>
-        <pc:sldMkLst>
-          <pc:docMk/>
-          <pc:sldMk cId="2248227231" sldId="461"/>
-        </pc:sldMkLst>
-      </pc:sldChg>
-      <pc:sldChg chg="del">
-        <pc:chgData name="Mohammed Fasha" userId="S::mohammed.fasha@uop.edu.jo::cc64f42d-a1a6-4f08-b97b-0c37f877119f" providerId="AD" clId="Web-{183AE7D0-0422-8839-EC6E-29E0859D7097}" dt="2025-07-16T14:30:46.924" v="8"/>
-        <pc:sldMkLst>
-          <pc:docMk/>
-          <pc:sldMk cId="1427723282" sldId="462"/>
-        </pc:sldMkLst>
-      </pc:sldChg>
-      <pc:sldChg chg="del">
-        <pc:chgData name="Mohammed Fasha" userId="S::mohammed.fasha@uop.edu.jo::cc64f42d-a1a6-4f08-b97b-0c37f877119f" providerId="AD" clId="Web-{183AE7D0-0422-8839-EC6E-29E0859D7097}" dt="2025-07-16T14:30:46.909" v="5"/>
-        <pc:sldMkLst>
-          <pc:docMk/>
-          <pc:sldMk cId="538252582" sldId="463"/>
-        </pc:sldMkLst>
-      </pc:sldChg>
-      <pc:sldChg chg="del">
-        <pc:chgData name="Mohammed Fasha" userId="S::mohammed.fasha@uop.edu.jo::cc64f42d-a1a6-4f08-b97b-0c37f877119f" providerId="AD" clId="Web-{183AE7D0-0422-8839-EC6E-29E0859D7097}" dt="2025-07-16T14:30:46.909" v="3"/>
-        <pc:sldMkLst>
-          <pc:docMk/>
-          <pc:sldMk cId="1559017199" sldId="464"/>
-        </pc:sldMkLst>
-      </pc:sldChg>
-      <pc:sldChg chg="del">
-        <pc:chgData name="Mohammed Fasha" userId="S::mohammed.fasha@uop.edu.jo::cc64f42d-a1a6-4f08-b97b-0c37f877119f" providerId="AD" clId="Web-{183AE7D0-0422-8839-EC6E-29E0859D7097}" dt="2025-07-16T14:30:46.909" v="4"/>
-        <pc:sldMkLst>
-          <pc:docMk/>
-          <pc:sldMk cId="2067025602" sldId="465"/>
-        </pc:sldMkLst>
-      </pc:sldChg>
-      <pc:sldChg chg="del">
-        <pc:chgData name="Mohammed Fasha" userId="S::mohammed.fasha@uop.edu.jo::cc64f42d-a1a6-4f08-b97b-0c37f877119f" providerId="AD" clId="Web-{183AE7D0-0422-8839-EC6E-29E0859D7097}" dt="2025-07-16T14:30:46.909" v="2"/>
-        <pc:sldMkLst>
-          <pc:docMk/>
-          <pc:sldMk cId="2575217795" sldId="466"/>
-        </pc:sldMkLst>
-      </pc:sldChg>
-      <pc:sldChg chg="del">
-        <pc:chgData name="Mohammed Fasha" userId="S::mohammed.fasha@uop.edu.jo::cc64f42d-a1a6-4f08-b97b-0c37f877119f" providerId="AD" clId="Web-{183AE7D0-0422-8839-EC6E-29E0859D7097}" dt="2025-07-16T14:30:46.909" v="1"/>
-        <pc:sldMkLst>
-          <pc:docMk/>
-          <pc:sldMk cId="1558611893" sldId="476"/>
-        </pc:sldMkLst>
-      </pc:sldChg>
-      <pc:sldChg chg="del">
-        <pc:chgData name="Mohammed Fasha" userId="S::mohammed.fasha@uop.edu.jo::cc64f42d-a1a6-4f08-b97b-0c37f877119f" providerId="AD" clId="Web-{183AE7D0-0422-8839-EC6E-29E0859D7097}" dt="2025-07-16T14:30:46.940" v="17"/>
-        <pc:sldMkLst>
-          <pc:docMk/>
-          <pc:sldMk cId="2300765676" sldId="477"/>
-        </pc:sldMkLst>
-      </pc:sldChg>
-      <pc:sldChg chg="del">
-        <pc:chgData name="Mohammed Fasha" userId="S::mohammed.fasha@uop.edu.jo::cc64f42d-a1a6-4f08-b97b-0c37f877119f" providerId="AD" clId="Web-{183AE7D0-0422-8839-EC6E-29E0859D7097}" dt="2025-07-16T14:30:46.940" v="19"/>
-        <pc:sldMkLst>
-          <pc:docMk/>
-          <pc:sldMk cId="2145969539" sldId="478"/>
-        </pc:sldMkLst>
-      </pc:sldChg>
-      <pc:sldChg chg="del">
-        <pc:chgData name="Mohammed Fasha" userId="S::mohammed.fasha@uop.edu.jo::cc64f42d-a1a6-4f08-b97b-0c37f877119f" providerId="AD" clId="Web-{183AE7D0-0422-8839-EC6E-29E0859D7097}" dt="2025-07-16T14:30:46.924" v="13"/>
-        <pc:sldMkLst>
-          <pc:docMk/>
-          <pc:sldMk cId="1427132372" sldId="479"/>
-        </pc:sldMkLst>
-      </pc:sldChg>
-      <pc:sldChg chg="del">
-        <pc:chgData name="Mohammed Fasha" userId="S::mohammed.fasha@uop.edu.jo::cc64f42d-a1a6-4f08-b97b-0c37f877119f" providerId="AD" clId="Web-{183AE7D0-0422-8839-EC6E-29E0859D7097}" dt="2025-07-16T14:30:46.924" v="12"/>
-        <pc:sldMkLst>
-          <pc:docMk/>
-          <pc:sldMk cId="3075052158" sldId="480"/>
-        </pc:sldMkLst>
-      </pc:sldChg>
-      <pc:sldChg chg="del">
-        <pc:chgData name="Mohammed Fasha" userId="S::mohammed.fasha@uop.edu.jo::cc64f42d-a1a6-4f08-b97b-0c37f877119f" providerId="AD" clId="Web-{183AE7D0-0422-8839-EC6E-29E0859D7097}" dt="2025-07-16T14:30:46.924" v="10"/>
-        <pc:sldMkLst>
-          <pc:docMk/>
-          <pc:sldMk cId="3717947773" sldId="481"/>
-        </pc:sldMkLst>
-      </pc:sldChg>
-      <pc:sldChg chg="del">
-        <pc:chgData name="Mohammed Fasha" userId="S::mohammed.fasha@uop.edu.jo::cc64f42d-a1a6-4f08-b97b-0c37f877119f" providerId="AD" clId="Web-{183AE7D0-0422-8839-EC6E-29E0859D7097}" dt="2025-07-16T14:30:46.924" v="7"/>
-        <pc:sldMkLst>
-          <pc:docMk/>
-          <pc:sldMk cId="3941017664" sldId="482"/>
-        </pc:sldMkLst>
-      </pc:sldChg>
-      <pc:sldChg chg="del">
-        <pc:chgData name="Mohammed Fasha" userId="S::mohammed.fasha@uop.edu.jo::cc64f42d-a1a6-4f08-b97b-0c37f877119f" providerId="AD" clId="Web-{183AE7D0-0422-8839-EC6E-29E0859D7097}" dt="2025-07-16T14:30:46.924" v="6"/>
-        <pc:sldMkLst>
-          <pc:docMk/>
-          <pc:sldMk cId="1291192180" sldId="483"/>
-        </pc:sldMkLst>
-      </pc:sldChg>
-      <pc:sldChg chg="del">
-        <pc:chgData name="Mohammed Fasha" userId="S::mohammed.fasha@uop.edu.jo::cc64f42d-a1a6-4f08-b97b-0c37f877119f" providerId="AD" clId="Web-{183AE7D0-0422-8839-EC6E-29E0859D7097}" dt="2025-07-16T14:30:46.924" v="11"/>
+        <pc:chgData name="Mohammed Fasha" userId="cc64f42d-a1a6-4f08-b97b-0c37f877119f" providerId="ADAL" clId="{F585A28F-34F7-4D28-B641-78252DAB29E0}" dt="2025-07-16T09:16:45.419" v="74" actId="1076"/>
         <pc:sldMkLst>
           <pc:docMk/>
           <pc:sldMk cId="1949621639" sldId="484"/>
@@ -1696,14 +1802,6 @@
           <pc:docMk/>
           <pc:sldMk cId="1162554463" sldId="257"/>
         </pc:sldMkLst>
-        <pc:spChg chg="mod">
-          <ac:chgData name="Mohammed Fasha" userId="cc64f42d-a1a6-4f08-b97b-0c37f877119f" providerId="ADAL" clId="{161A7FAA-B398-4429-9FC2-656B0895AF0F}" dt="2025-07-16T07:59:43.135" v="11" actId="113"/>
-          <ac:spMkLst>
-            <pc:docMk/>
-            <pc:sldMk cId="1162554463" sldId="257"/>
-            <ac:spMk id="2" creationId="{8BE518FD-B81F-466C-AD85-5DDC967653B4}"/>
-          </ac:spMkLst>
-        </pc:spChg>
       </pc:sldChg>
       <pc:sldChg chg="ord">
         <pc:chgData name="Mohammed Fasha" userId="cc64f42d-a1a6-4f08-b97b-0c37f877119f" providerId="ADAL" clId="{161A7FAA-B398-4429-9FC2-656B0895AF0F}" dt="2025-07-16T08:09:08.733" v="119"/>
@@ -1718,30 +1816,6 @@
           <pc:docMk/>
           <pc:sldMk cId="3639736080" sldId="457"/>
         </pc:sldMkLst>
-        <pc:spChg chg="mod">
-          <ac:chgData name="Mohammed Fasha" userId="cc64f42d-a1a6-4f08-b97b-0c37f877119f" providerId="ADAL" clId="{161A7FAA-B398-4429-9FC2-656B0895AF0F}" dt="2025-07-16T08:10:21.461" v="130" actId="113"/>
-          <ac:spMkLst>
-            <pc:docMk/>
-            <pc:sldMk cId="3639736080" sldId="457"/>
-            <ac:spMk id="2" creationId="{5A741632-F5AA-89F8-92B0-716C60C6B299}"/>
-          </ac:spMkLst>
-        </pc:spChg>
-        <pc:picChg chg="add mod">
-          <ac:chgData name="Mohammed Fasha" userId="cc64f42d-a1a6-4f08-b97b-0c37f877119f" providerId="ADAL" clId="{161A7FAA-B398-4429-9FC2-656B0895AF0F}" dt="2025-07-16T08:09:37.477" v="125"/>
-          <ac:picMkLst>
-            <pc:docMk/>
-            <pc:sldMk cId="3639736080" sldId="457"/>
-            <ac:picMk id="4" creationId="{DE2B1E32-0CA3-128D-CB32-2F690773BA5C}"/>
-          </ac:picMkLst>
-        </pc:picChg>
-        <pc:picChg chg="mod">
-          <ac:chgData name="Mohammed Fasha" userId="cc64f42d-a1a6-4f08-b97b-0c37f877119f" providerId="ADAL" clId="{161A7FAA-B398-4429-9FC2-656B0895AF0F}" dt="2025-07-16T08:09:54.987" v="129" actId="1076"/>
-          <ac:picMkLst>
-            <pc:docMk/>
-            <pc:sldMk cId="3639736080" sldId="457"/>
-            <ac:picMk id="7" creationId="{82D86F0E-0628-3880-4CDD-0284B92DC94E}"/>
-          </ac:picMkLst>
-        </pc:picChg>
       </pc:sldChg>
       <pc:sldChg chg="addSp modSp mod">
         <pc:chgData name="Mohammed Fasha" userId="cc64f42d-a1a6-4f08-b97b-0c37f877119f" providerId="ADAL" clId="{161A7FAA-B398-4429-9FC2-656B0895AF0F}" dt="2025-07-16T08:11:43.027" v="145" actId="14100"/>
@@ -1749,30 +1823,6 @@
           <pc:docMk/>
           <pc:sldMk cId="2042404279" sldId="458"/>
         </pc:sldMkLst>
-        <pc:spChg chg="mod">
-          <ac:chgData name="Mohammed Fasha" userId="cc64f42d-a1a6-4f08-b97b-0c37f877119f" providerId="ADAL" clId="{161A7FAA-B398-4429-9FC2-656B0895AF0F}" dt="2025-07-16T08:10:49.595" v="141" actId="27636"/>
-          <ac:spMkLst>
-            <pc:docMk/>
-            <pc:sldMk cId="2042404279" sldId="458"/>
-            <ac:spMk id="2" creationId="{AFD55279-926D-56F4-16C1-40E544073600}"/>
-          </ac:spMkLst>
-        </pc:spChg>
-        <pc:picChg chg="mod">
-          <ac:chgData name="Mohammed Fasha" userId="cc64f42d-a1a6-4f08-b97b-0c37f877119f" providerId="ADAL" clId="{161A7FAA-B398-4429-9FC2-656B0895AF0F}" dt="2025-07-16T08:10:47.228" v="139" actId="1076"/>
-          <ac:picMkLst>
-            <pc:docMk/>
-            <pc:sldMk cId="2042404279" sldId="458"/>
-            <ac:picMk id="5" creationId="{D78EEB53-EDB0-9883-EF22-7ECFE0832215}"/>
-          </ac:picMkLst>
-        </pc:picChg>
-        <pc:picChg chg="add mod">
-          <ac:chgData name="Mohammed Fasha" userId="cc64f42d-a1a6-4f08-b97b-0c37f877119f" providerId="ADAL" clId="{161A7FAA-B398-4429-9FC2-656B0895AF0F}" dt="2025-07-16T08:11:43.027" v="145" actId="14100"/>
-          <ac:picMkLst>
-            <pc:docMk/>
-            <pc:sldMk cId="2042404279" sldId="458"/>
-            <ac:picMk id="3074" creationId="{4DD72E80-9023-5209-B53A-ADEDF9507F30}"/>
-          </ac:picMkLst>
-        </pc:picChg>
       </pc:sldChg>
       <pc:sldChg chg="del">
         <pc:chgData name="Mohammed Fasha" userId="cc64f42d-a1a6-4f08-b97b-0c37f877119f" providerId="ADAL" clId="{161A7FAA-B398-4429-9FC2-656B0895AF0F}" dt="2025-07-16T08:18:53.045" v="232" actId="2696"/>
@@ -1787,22 +1837,6 @@
           <pc:docMk/>
           <pc:sldMk cId="1040197143" sldId="460"/>
         </pc:sldMkLst>
-        <pc:picChg chg="del">
-          <ac:chgData name="Mohammed Fasha" userId="cc64f42d-a1a6-4f08-b97b-0c37f877119f" providerId="ADAL" clId="{161A7FAA-B398-4429-9FC2-656B0895AF0F}" dt="2025-07-16T08:18:58.259" v="234" actId="21"/>
-          <ac:picMkLst>
-            <pc:docMk/>
-            <pc:sldMk cId="1040197143" sldId="460"/>
-            <ac:picMk id="12" creationId="{ED72E220-66E3-C895-AA2B-7821BAB0B80F}"/>
-          </ac:picMkLst>
-        </pc:picChg>
-        <pc:picChg chg="del">
-          <ac:chgData name="Mohammed Fasha" userId="cc64f42d-a1a6-4f08-b97b-0c37f877119f" providerId="ADAL" clId="{161A7FAA-B398-4429-9FC2-656B0895AF0F}" dt="2025-07-16T08:19:12.149" v="237" actId="21"/>
-          <ac:picMkLst>
-            <pc:docMk/>
-            <pc:sldMk cId="1040197143" sldId="460"/>
-            <ac:picMk id="13" creationId="{923AB4FC-8803-B130-E7FF-D6F9B65D8759}"/>
-          </ac:picMkLst>
-        </pc:picChg>
       </pc:sldChg>
       <pc:sldChg chg="modSp mod ord">
         <pc:chgData name="Mohammed Fasha" userId="cc64f42d-a1a6-4f08-b97b-0c37f877119f" providerId="ADAL" clId="{161A7FAA-B398-4429-9FC2-656B0895AF0F}" dt="2025-07-16T08:31:04.392" v="376" actId="5793"/>
@@ -1810,14 +1844,6 @@
           <pc:docMk/>
           <pc:sldMk cId="2248227231" sldId="461"/>
         </pc:sldMkLst>
-        <pc:spChg chg="mod">
-          <ac:chgData name="Mohammed Fasha" userId="cc64f42d-a1a6-4f08-b97b-0c37f877119f" providerId="ADAL" clId="{161A7FAA-B398-4429-9FC2-656B0895AF0F}" dt="2025-07-16T08:31:04.392" v="376" actId="5793"/>
-          <ac:spMkLst>
-            <pc:docMk/>
-            <pc:sldMk cId="2248227231" sldId="461"/>
-            <ac:spMk id="15" creationId="{16489CD5-E694-96CA-6EE8-2DA9D775D58C}"/>
-          </ac:spMkLst>
-        </pc:spChg>
       </pc:sldChg>
       <pc:sldChg chg="addSp delSp modSp new mod">
         <pc:chgData name="Mohammed Fasha" userId="cc64f42d-a1a6-4f08-b97b-0c37f877119f" providerId="ADAL" clId="{161A7FAA-B398-4429-9FC2-656B0895AF0F}" dt="2025-07-16T08:08:48.133" v="117" actId="1076"/>
@@ -1825,54 +1851,6 @@
           <pc:docMk/>
           <pc:sldMk cId="2300765676" sldId="477"/>
         </pc:sldMkLst>
-        <pc:spChg chg="mod">
-          <ac:chgData name="Mohammed Fasha" userId="cc64f42d-a1a6-4f08-b97b-0c37f877119f" providerId="ADAL" clId="{161A7FAA-B398-4429-9FC2-656B0895AF0F}" dt="2025-07-16T08:08:36.095" v="116" actId="27636"/>
-          <ac:spMkLst>
-            <pc:docMk/>
-            <pc:sldMk cId="2300765676" sldId="477"/>
-            <ac:spMk id="2" creationId="{B23B8AB6-5D16-5C93-D306-CA79D6F7715A}"/>
-          </ac:spMkLst>
-        </pc:spChg>
-        <pc:spChg chg="mod">
-          <ac:chgData name="Mohammed Fasha" userId="cc64f42d-a1a6-4f08-b97b-0c37f877119f" providerId="ADAL" clId="{161A7FAA-B398-4429-9FC2-656B0895AF0F}" dt="2025-07-16T08:06:36.346" v="104"/>
-          <ac:spMkLst>
-            <pc:docMk/>
-            <pc:sldMk cId="2300765676" sldId="477"/>
-            <ac:spMk id="3" creationId="{A955792E-C166-AD40-E023-9C9473F341EE}"/>
-          </ac:spMkLst>
-        </pc:spChg>
-        <pc:picChg chg="add del">
-          <ac:chgData name="Mohammed Fasha" userId="cc64f42d-a1a6-4f08-b97b-0c37f877119f" providerId="ADAL" clId="{161A7FAA-B398-4429-9FC2-656B0895AF0F}" dt="2025-07-16T08:05:48.658" v="91" actId="478"/>
-          <ac:picMkLst>
-            <pc:docMk/>
-            <pc:sldMk cId="2300765676" sldId="477"/>
-            <ac:picMk id="5" creationId="{45D6DA4C-2F0D-260B-8062-714BA9263593}"/>
-          </ac:picMkLst>
-        </pc:picChg>
-        <pc:picChg chg="add del mod">
-          <ac:chgData name="Mohammed Fasha" userId="cc64f42d-a1a6-4f08-b97b-0c37f877119f" providerId="ADAL" clId="{161A7FAA-B398-4429-9FC2-656B0895AF0F}" dt="2025-07-16T08:04:14.371" v="84" actId="478"/>
-          <ac:picMkLst>
-            <pc:docMk/>
-            <pc:sldMk cId="2300765676" sldId="477"/>
-            <ac:picMk id="1026" creationId="{F9570969-F598-6ACB-2DD4-CCA2812970C4}"/>
-          </ac:picMkLst>
-        </pc:picChg>
-        <pc:picChg chg="add del mod">
-          <ac:chgData name="Mohammed Fasha" userId="cc64f42d-a1a6-4f08-b97b-0c37f877119f" providerId="ADAL" clId="{161A7FAA-B398-4429-9FC2-656B0895AF0F}" dt="2025-07-16T08:05:11.635" v="89" actId="478"/>
-          <ac:picMkLst>
-            <pc:docMk/>
-            <pc:sldMk cId="2300765676" sldId="477"/>
-            <ac:picMk id="1028" creationId="{6CD59B2C-D8DA-FE8A-6FE6-FA28D990AF89}"/>
-          </ac:picMkLst>
-        </pc:picChg>
-        <pc:picChg chg="add mod">
-          <ac:chgData name="Mohammed Fasha" userId="cc64f42d-a1a6-4f08-b97b-0c37f877119f" providerId="ADAL" clId="{161A7FAA-B398-4429-9FC2-656B0895AF0F}" dt="2025-07-16T08:08:48.133" v="117" actId="1076"/>
-          <ac:picMkLst>
-            <pc:docMk/>
-            <pc:sldMk cId="2300765676" sldId="477"/>
-            <ac:picMk id="1030" creationId="{105D4075-60E9-9283-7A3C-A2F1DF21BE6F}"/>
-          </ac:picMkLst>
-        </pc:picChg>
       </pc:sldChg>
       <pc:sldChg chg="modSp new mod">
         <pc:chgData name="Mohammed Fasha" userId="cc64f42d-a1a6-4f08-b97b-0c37f877119f" providerId="ADAL" clId="{161A7FAA-B398-4429-9FC2-656B0895AF0F}" dt="2025-07-16T08:00:24.341" v="74" actId="20577"/>
@@ -1880,22 +1858,6 @@
           <pc:docMk/>
           <pc:sldMk cId="2145969539" sldId="478"/>
         </pc:sldMkLst>
-        <pc:spChg chg="mod">
-          <ac:chgData name="Mohammed Fasha" userId="cc64f42d-a1a6-4f08-b97b-0c37f877119f" providerId="ADAL" clId="{161A7FAA-B398-4429-9FC2-656B0895AF0F}" dt="2025-07-16T08:00:24.341" v="74" actId="20577"/>
-          <ac:spMkLst>
-            <pc:docMk/>
-            <pc:sldMk cId="2145969539" sldId="478"/>
-            <ac:spMk id="2" creationId="{595313C8-76FF-2F07-3ED5-814AD3EC72DC}"/>
-          </ac:spMkLst>
-        </pc:spChg>
-        <pc:spChg chg="mod">
-          <ac:chgData name="Mohammed Fasha" userId="cc64f42d-a1a6-4f08-b97b-0c37f877119f" providerId="ADAL" clId="{161A7FAA-B398-4429-9FC2-656B0895AF0F}" dt="2025-07-16T07:59:36.176" v="10" actId="113"/>
-          <ac:spMkLst>
-            <pc:docMk/>
-            <pc:sldMk cId="2145969539" sldId="478"/>
-            <ac:spMk id="3" creationId="{071A7914-96DB-51CC-53B0-AF8ED0AF6AEC}"/>
-          </ac:spMkLst>
-        </pc:spChg>
       </pc:sldChg>
       <pc:sldChg chg="addSp delSp modSp new del mod">
         <pc:chgData name="Mohammed Fasha" userId="cc64f42d-a1a6-4f08-b97b-0c37f877119f" providerId="ADAL" clId="{161A7FAA-B398-4429-9FC2-656B0895AF0F}" dt="2025-07-16T08:08:07.529" v="114" actId="47"/>
@@ -1903,22 +1865,6 @@
           <pc:docMk/>
           <pc:sldMk cId="575657110" sldId="479"/>
         </pc:sldMkLst>
-        <pc:spChg chg="add del mod">
-          <ac:chgData name="Mohammed Fasha" userId="cc64f42d-a1a6-4f08-b97b-0c37f877119f" providerId="ADAL" clId="{161A7FAA-B398-4429-9FC2-656B0895AF0F}" dt="2025-07-16T08:07:56.853" v="113" actId="404"/>
-          <ac:spMkLst>
-            <pc:docMk/>
-            <pc:sldMk cId="575657110" sldId="479"/>
-            <ac:spMk id="2" creationId="{4ADEBDBE-8C09-D3AD-763D-3410BE9FAF8D}"/>
-          </ac:spMkLst>
-        </pc:spChg>
-        <pc:spChg chg="add mod">
-          <ac:chgData name="Mohammed Fasha" userId="cc64f42d-a1a6-4f08-b97b-0c37f877119f" providerId="ADAL" clId="{161A7FAA-B398-4429-9FC2-656B0895AF0F}" dt="2025-07-16T08:07:02.451" v="107"/>
-          <ac:spMkLst>
-            <pc:docMk/>
-            <pc:sldMk cId="575657110" sldId="479"/>
-            <ac:spMk id="4" creationId="{61048862-B9F5-1154-77E8-4D0F5E449B7F}"/>
-          </ac:spMkLst>
-        </pc:spChg>
       </pc:sldChg>
       <pc:sldChg chg="modSp new mod">
         <pc:chgData name="Mohammed Fasha" userId="cc64f42d-a1a6-4f08-b97b-0c37f877119f" providerId="ADAL" clId="{161A7FAA-B398-4429-9FC2-656B0895AF0F}" dt="2025-07-16T08:12:50.396" v="164" actId="5793"/>
@@ -1926,22 +1872,6 @@
           <pc:docMk/>
           <pc:sldMk cId="1427132372" sldId="479"/>
         </pc:sldMkLst>
-        <pc:spChg chg="mod">
-          <ac:chgData name="Mohammed Fasha" userId="cc64f42d-a1a6-4f08-b97b-0c37f877119f" providerId="ADAL" clId="{161A7FAA-B398-4429-9FC2-656B0895AF0F}" dt="2025-07-16T08:12:50.396" v="164" actId="5793"/>
-          <ac:spMkLst>
-            <pc:docMk/>
-            <pc:sldMk cId="1427132372" sldId="479"/>
-            <ac:spMk id="2" creationId="{E56CB444-3023-BA2B-502A-E63C438605D8}"/>
-          </ac:spMkLst>
-        </pc:spChg>
-        <pc:spChg chg="mod">
-          <ac:chgData name="Mohammed Fasha" userId="cc64f42d-a1a6-4f08-b97b-0c37f877119f" providerId="ADAL" clId="{161A7FAA-B398-4429-9FC2-656B0895AF0F}" dt="2025-07-16T08:12:34.428" v="155" actId="113"/>
-          <ac:spMkLst>
-            <pc:docMk/>
-            <pc:sldMk cId="1427132372" sldId="479"/>
-            <ac:spMk id="3" creationId="{55B8EC88-FA32-80C6-9212-225795D1FE9E}"/>
-          </ac:spMkLst>
-        </pc:spChg>
       </pc:sldChg>
       <pc:sldChg chg="addSp delSp modSp new mod">
         <pc:chgData name="Mohammed Fasha" userId="cc64f42d-a1a6-4f08-b97b-0c37f877119f" providerId="ADAL" clId="{161A7FAA-B398-4429-9FC2-656B0895AF0F}" dt="2025-07-16T08:15:31.546" v="209" actId="1076"/>
@@ -1949,38 +1879,6 @@
           <pc:docMk/>
           <pc:sldMk cId="3075052158" sldId="480"/>
         </pc:sldMkLst>
-        <pc:spChg chg="add del mod">
-          <ac:chgData name="Mohammed Fasha" userId="cc64f42d-a1a6-4f08-b97b-0c37f877119f" providerId="ADAL" clId="{161A7FAA-B398-4429-9FC2-656B0895AF0F}" dt="2025-07-16T08:15:23.436" v="205" actId="14100"/>
-          <ac:spMkLst>
-            <pc:docMk/>
-            <pc:sldMk cId="3075052158" sldId="480"/>
-            <ac:spMk id="2" creationId="{D7723A21-97D0-9266-6B42-28CBEDC236D9}"/>
-          </ac:spMkLst>
-        </pc:spChg>
-        <pc:spChg chg="mod">
-          <ac:chgData name="Mohammed Fasha" userId="cc64f42d-a1a6-4f08-b97b-0c37f877119f" providerId="ADAL" clId="{161A7FAA-B398-4429-9FC2-656B0895AF0F}" dt="2025-07-16T08:13:33.725" v="185" actId="6549"/>
-          <ac:spMkLst>
-            <pc:docMk/>
-            <pc:sldMk cId="3075052158" sldId="480"/>
-            <ac:spMk id="3" creationId="{E520913F-E7B6-47CD-911A-B7E553D5285A}"/>
-          </ac:spMkLst>
-        </pc:spChg>
-        <pc:spChg chg="add mod">
-          <ac:chgData name="Mohammed Fasha" userId="cc64f42d-a1a6-4f08-b97b-0c37f877119f" providerId="ADAL" clId="{161A7FAA-B398-4429-9FC2-656B0895AF0F}" dt="2025-07-16T08:13:08.318" v="167"/>
-          <ac:spMkLst>
-            <pc:docMk/>
-            <pc:sldMk cId="3075052158" sldId="480"/>
-            <ac:spMk id="4" creationId="{5B28E922-3593-82D7-6A03-F52CCB4BFE39}"/>
-          </ac:spMkLst>
-        </pc:spChg>
-        <pc:picChg chg="add mod">
-          <ac:chgData name="Mohammed Fasha" userId="cc64f42d-a1a6-4f08-b97b-0c37f877119f" providerId="ADAL" clId="{161A7FAA-B398-4429-9FC2-656B0895AF0F}" dt="2025-07-16T08:15:31.546" v="209" actId="1076"/>
-          <ac:picMkLst>
-            <pc:docMk/>
-            <pc:sldMk cId="3075052158" sldId="480"/>
-            <ac:picMk id="5123" creationId="{7227A453-5C80-EF05-DBFF-BB24669D733C}"/>
-          </ac:picMkLst>
-        </pc:picChg>
       </pc:sldChg>
       <pc:sldChg chg="addSp modSp new mod">
         <pc:chgData name="Mohammed Fasha" userId="cc64f42d-a1a6-4f08-b97b-0c37f877119f" providerId="ADAL" clId="{161A7FAA-B398-4429-9FC2-656B0895AF0F}" dt="2025-07-16T08:26:24.604" v="351" actId="1076"/>
@@ -1988,46 +1886,6 @@
           <pc:docMk/>
           <pc:sldMk cId="3717947773" sldId="481"/>
         </pc:sldMkLst>
-        <pc:spChg chg="mod">
-          <ac:chgData name="Mohammed Fasha" userId="cc64f42d-a1a6-4f08-b97b-0c37f877119f" providerId="ADAL" clId="{161A7FAA-B398-4429-9FC2-656B0895AF0F}" dt="2025-07-16T08:20:53.969" v="256" actId="404"/>
-          <ac:spMkLst>
-            <pc:docMk/>
-            <pc:sldMk cId="3717947773" sldId="481"/>
-            <ac:spMk id="2" creationId="{ECC626B6-A902-6BF5-9290-D13B2FC57543}"/>
-          </ac:spMkLst>
-        </pc:spChg>
-        <pc:spChg chg="mod">
-          <ac:chgData name="Mohammed Fasha" userId="cc64f42d-a1a6-4f08-b97b-0c37f877119f" providerId="ADAL" clId="{161A7FAA-B398-4429-9FC2-656B0895AF0F}" dt="2025-07-16T08:19:58.582" v="247" actId="113"/>
-          <ac:spMkLst>
-            <pc:docMk/>
-            <pc:sldMk cId="3717947773" sldId="481"/>
-            <ac:spMk id="3" creationId="{E11FBCEE-3920-1390-A5A2-B8102DBEF6F8}"/>
-          </ac:spMkLst>
-        </pc:spChg>
-        <pc:spChg chg="add mod">
-          <ac:chgData name="Mohammed Fasha" userId="cc64f42d-a1a6-4f08-b97b-0c37f877119f" providerId="ADAL" clId="{161A7FAA-B398-4429-9FC2-656B0895AF0F}" dt="2025-07-16T08:23:56.687" v="348" actId="27636"/>
-          <ac:spMkLst>
-            <pc:docMk/>
-            <pc:sldMk cId="3717947773" sldId="481"/>
-            <ac:spMk id="5" creationId="{A8F843FB-6888-4116-3CF1-CFF8977AD640}"/>
-          </ac:spMkLst>
-        </pc:spChg>
-        <pc:picChg chg="add mod ord">
-          <ac:chgData name="Mohammed Fasha" userId="cc64f42d-a1a6-4f08-b97b-0c37f877119f" providerId="ADAL" clId="{161A7FAA-B398-4429-9FC2-656B0895AF0F}" dt="2025-07-16T08:21:27.138" v="339" actId="1076"/>
-          <ac:picMkLst>
-            <pc:docMk/>
-            <pc:sldMk cId="3717947773" sldId="481"/>
-            <ac:picMk id="4" creationId="{159964DC-0CDA-4C8C-1325-DEC0B312A24B}"/>
-          </ac:picMkLst>
-        </pc:picChg>
-        <pc:picChg chg="add mod">
-          <ac:chgData name="Mohammed Fasha" userId="cc64f42d-a1a6-4f08-b97b-0c37f877119f" providerId="ADAL" clId="{161A7FAA-B398-4429-9FC2-656B0895AF0F}" dt="2025-07-16T08:26:24.604" v="351" actId="1076"/>
-          <ac:picMkLst>
-            <pc:docMk/>
-            <pc:sldMk cId="3717947773" sldId="481"/>
-            <ac:picMk id="6146" creationId="{1E7C1A24-99FD-05FD-C2A7-F0B29742FF62}"/>
-          </ac:picMkLst>
-        </pc:picChg>
       </pc:sldChg>
       <pc:sldChg chg="new">
         <pc:chgData name="Mohammed Fasha" userId="cc64f42d-a1a6-4f08-b97b-0c37f877119f" providerId="ADAL" clId="{161A7FAA-B398-4429-9FC2-656B0895AF0F}" dt="2025-07-16T08:15:43.528" v="211" actId="680"/>
@@ -2048,277 +1906,6 @@
         <pc:sldMkLst>
           <pc:docMk/>
           <pc:sldMk cId="1949621639" sldId="484"/>
-        </pc:sldMkLst>
-        <pc:spChg chg="mod">
-          <ac:chgData name="Mohammed Fasha" userId="cc64f42d-a1a6-4f08-b97b-0c37f877119f" providerId="ADAL" clId="{161A7FAA-B398-4429-9FC2-656B0895AF0F}" dt="2025-07-16T08:17:24.427" v="231" actId="14100"/>
-          <ac:spMkLst>
-            <pc:docMk/>
-            <pc:sldMk cId="1949621639" sldId="484"/>
-            <ac:spMk id="2" creationId="{00E50F6B-D0D0-409C-B437-2D7A32D8857A}"/>
-          </ac:spMkLst>
-        </pc:spChg>
-        <pc:spChg chg="mod">
-          <ac:chgData name="Mohammed Fasha" userId="cc64f42d-a1a6-4f08-b97b-0c37f877119f" providerId="ADAL" clId="{161A7FAA-B398-4429-9FC2-656B0895AF0F}" dt="2025-07-16T08:16:40.937" v="221" actId="113"/>
-          <ac:spMkLst>
-            <pc:docMk/>
-            <pc:sldMk cId="1949621639" sldId="484"/>
-            <ac:spMk id="3" creationId="{8AEB1D58-5352-F4F3-2A11-C6F2225E69D6}"/>
-          </ac:spMkLst>
-        </pc:spChg>
-        <pc:picChg chg="add mod">
-          <ac:chgData name="Mohammed Fasha" userId="cc64f42d-a1a6-4f08-b97b-0c37f877119f" providerId="ADAL" clId="{161A7FAA-B398-4429-9FC2-656B0895AF0F}" dt="2025-07-16T08:19:01.838" v="236" actId="1076"/>
-          <ac:picMkLst>
-            <pc:docMk/>
-            <pc:sldMk cId="1949621639" sldId="484"/>
-            <ac:picMk id="12" creationId="{ED72E220-66E3-C895-AA2B-7821BAB0B80F}"/>
-          </ac:picMkLst>
-        </pc:picChg>
-        <pc:picChg chg="add mod">
-          <ac:chgData name="Mohammed Fasha" userId="cc64f42d-a1a6-4f08-b97b-0c37f877119f" providerId="ADAL" clId="{161A7FAA-B398-4429-9FC2-656B0895AF0F}" dt="2025-07-16T08:19:15.788" v="238"/>
-          <ac:picMkLst>
-            <pc:docMk/>
-            <pc:sldMk cId="1949621639" sldId="484"/>
-            <ac:picMk id="13" creationId="{923AB4FC-8803-B130-E7FF-D6F9B65D8759}"/>
-          </ac:picMkLst>
-        </pc:picChg>
-      </pc:sldChg>
-    </pc:docChg>
-  </pc:docChgLst>
-  <pc:docChgLst>
-    <pc:chgData name="Mohammed Fasha" userId="cc64f42d-a1a6-4f08-b97b-0c37f877119f" providerId="ADAL" clId="{F585A28F-34F7-4D28-B641-78252DAB29E0}"/>
-    <pc:docChg chg="undo custSel modSld sldOrd">
-      <pc:chgData name="Mohammed Fasha" userId="cc64f42d-a1a6-4f08-b97b-0c37f877119f" providerId="ADAL" clId="{F585A28F-34F7-4D28-B641-78252DAB29E0}" dt="2025-07-16T09:17:57.509" v="81" actId="114"/>
-      <pc:docMkLst>
-        <pc:docMk/>
-      </pc:docMkLst>
-      <pc:sldChg chg="modSp mod">
-        <pc:chgData name="Mohammed Fasha" userId="cc64f42d-a1a6-4f08-b97b-0c37f877119f" providerId="ADAL" clId="{F585A28F-34F7-4D28-B641-78252DAB29E0}" dt="2025-07-16T09:14:06.583" v="24" actId="27636"/>
-        <pc:sldMkLst>
-          <pc:docMk/>
-          <pc:sldMk cId="1162554463" sldId="257"/>
-        </pc:sldMkLst>
-        <pc:spChg chg="mod">
-          <ac:chgData name="Mohammed Fasha" userId="cc64f42d-a1a6-4f08-b97b-0c37f877119f" providerId="ADAL" clId="{F585A28F-34F7-4D28-B641-78252DAB29E0}" dt="2025-07-16T09:14:06.583" v="24" actId="27636"/>
-          <ac:spMkLst>
-            <pc:docMk/>
-            <pc:sldMk cId="1162554463" sldId="257"/>
-            <ac:spMk id="3" creationId="{1A647627-019E-4599-BFE9-83A7DEA04B6D}"/>
-          </ac:spMkLst>
-        </pc:spChg>
-        <pc:spChg chg="mod">
-          <ac:chgData name="Mohammed Fasha" userId="cc64f42d-a1a6-4f08-b97b-0c37f877119f" providerId="ADAL" clId="{F585A28F-34F7-4D28-B641-78252DAB29E0}" dt="2025-07-16T09:14:03.934" v="22" actId="403"/>
-          <ac:spMkLst>
-            <pc:docMk/>
-            <pc:sldMk cId="1162554463" sldId="257"/>
-            <ac:spMk id="4" creationId="{929A5FA8-1320-61F3-BC79-488C9BA93D9F}"/>
-          </ac:spMkLst>
-        </pc:spChg>
-      </pc:sldChg>
-      <pc:sldChg chg="modSp mod">
-        <pc:chgData name="Mohammed Fasha" userId="cc64f42d-a1a6-4f08-b97b-0c37f877119f" providerId="ADAL" clId="{F585A28F-34F7-4D28-B641-78252DAB29E0}" dt="2025-07-16T09:14:22.611" v="25" actId="20577"/>
-        <pc:sldMkLst>
-          <pc:docMk/>
-          <pc:sldMk cId="2881282849" sldId="459"/>
-        </pc:sldMkLst>
-        <pc:spChg chg="mod">
-          <ac:chgData name="Mohammed Fasha" userId="cc64f42d-a1a6-4f08-b97b-0c37f877119f" providerId="ADAL" clId="{F585A28F-34F7-4D28-B641-78252DAB29E0}" dt="2025-07-16T09:14:22.611" v="25" actId="20577"/>
-          <ac:spMkLst>
-            <pc:docMk/>
-            <pc:sldMk cId="2881282849" sldId="459"/>
-            <ac:spMk id="10" creationId="{997C4077-274B-FAF4-67DA-B0DEA55B5FEA}"/>
-          </ac:spMkLst>
-        </pc:spChg>
-      </pc:sldChg>
-      <pc:sldChg chg="modSp mod ord">
-        <pc:chgData name="Mohammed Fasha" userId="cc64f42d-a1a6-4f08-b97b-0c37f877119f" providerId="ADAL" clId="{F585A28F-34F7-4D28-B641-78252DAB29E0}" dt="2025-07-16T09:17:57.509" v="81" actId="114"/>
-        <pc:sldMkLst>
-          <pc:docMk/>
-          <pc:sldMk cId="1427723282" sldId="462"/>
-        </pc:sldMkLst>
-        <pc:spChg chg="mod">
-          <ac:chgData name="Mohammed Fasha" userId="cc64f42d-a1a6-4f08-b97b-0c37f877119f" providerId="ADAL" clId="{F585A28F-34F7-4D28-B641-78252DAB29E0}" dt="2025-07-16T09:17:57.509" v="81" actId="114"/>
-          <ac:spMkLst>
-            <pc:docMk/>
-            <pc:sldMk cId="1427723282" sldId="462"/>
-            <ac:spMk id="2" creationId="{5161A592-C95D-5F4C-D812-FDE1F8B67D98}"/>
-          </ac:spMkLst>
-        </pc:spChg>
-      </pc:sldChg>
-      <pc:sldChg chg="modSp mod">
-        <pc:chgData name="Mohammed Fasha" userId="cc64f42d-a1a6-4f08-b97b-0c37f877119f" providerId="ADAL" clId="{F585A28F-34F7-4D28-B641-78252DAB29E0}" dt="2025-07-16T09:12:22.563" v="0" actId="404"/>
-        <pc:sldMkLst>
-          <pc:docMk/>
-          <pc:sldMk cId="2145969539" sldId="478"/>
-        </pc:sldMkLst>
-        <pc:spChg chg="mod">
-          <ac:chgData name="Mohammed Fasha" userId="cc64f42d-a1a6-4f08-b97b-0c37f877119f" providerId="ADAL" clId="{F585A28F-34F7-4D28-B641-78252DAB29E0}" dt="2025-07-16T09:12:22.563" v="0" actId="404"/>
-          <ac:spMkLst>
-            <pc:docMk/>
-            <pc:sldMk cId="2145969539" sldId="478"/>
-            <ac:spMk id="2" creationId="{595313C8-76FF-2F07-3ED5-814AD3EC72DC}"/>
-          </ac:spMkLst>
-        </pc:spChg>
-      </pc:sldChg>
-      <pc:sldChg chg="modSp mod">
-        <pc:chgData name="Mohammed Fasha" userId="cc64f42d-a1a6-4f08-b97b-0c37f877119f" providerId="ADAL" clId="{F585A28F-34F7-4D28-B641-78252DAB29E0}" dt="2025-07-16T09:14:47.069" v="29" actId="255"/>
-        <pc:sldMkLst>
-          <pc:docMk/>
-          <pc:sldMk cId="1427132372" sldId="479"/>
-        </pc:sldMkLst>
-        <pc:spChg chg="mod">
-          <ac:chgData name="Mohammed Fasha" userId="cc64f42d-a1a6-4f08-b97b-0c37f877119f" providerId="ADAL" clId="{F585A28F-34F7-4D28-B641-78252DAB29E0}" dt="2025-07-16T09:14:47.069" v="29" actId="255"/>
-          <ac:spMkLst>
-            <pc:docMk/>
-            <pc:sldMk cId="1427132372" sldId="479"/>
-            <ac:spMk id="2" creationId="{E56CB444-3023-BA2B-502A-E63C438605D8}"/>
-          </ac:spMkLst>
-        </pc:spChg>
-      </pc:sldChg>
-      <pc:sldChg chg="modSp mod">
-        <pc:chgData name="Mohammed Fasha" userId="cc64f42d-a1a6-4f08-b97b-0c37f877119f" providerId="ADAL" clId="{F585A28F-34F7-4D28-B641-78252DAB29E0}" dt="2025-07-16T09:16:07.771" v="68" actId="1076"/>
-        <pc:sldMkLst>
-          <pc:docMk/>
-          <pc:sldMk cId="3075052158" sldId="480"/>
-        </pc:sldMkLst>
-        <pc:spChg chg="mod">
-          <ac:chgData name="Mohammed Fasha" userId="cc64f42d-a1a6-4f08-b97b-0c37f877119f" providerId="ADAL" clId="{F585A28F-34F7-4D28-B641-78252DAB29E0}" dt="2025-07-16T09:16:02.732" v="67" actId="179"/>
-          <ac:spMkLst>
-            <pc:docMk/>
-            <pc:sldMk cId="3075052158" sldId="480"/>
-            <ac:spMk id="2" creationId="{D7723A21-97D0-9266-6B42-28CBEDC236D9}"/>
-          </ac:spMkLst>
-        </pc:spChg>
-        <pc:picChg chg="mod">
-          <ac:chgData name="Mohammed Fasha" userId="cc64f42d-a1a6-4f08-b97b-0c37f877119f" providerId="ADAL" clId="{F585A28F-34F7-4D28-B641-78252DAB29E0}" dt="2025-07-16T09:16:07.771" v="68" actId="1076"/>
-          <ac:picMkLst>
-            <pc:docMk/>
-            <pc:sldMk cId="3075052158" sldId="480"/>
-            <ac:picMk id="5123" creationId="{7227A453-5C80-EF05-DBFF-BB24669D733C}"/>
-          </ac:picMkLst>
-        </pc:picChg>
-      </pc:sldChg>
-      <pc:sldChg chg="modSp mod">
-        <pc:chgData name="Mohammed Fasha" userId="cc64f42d-a1a6-4f08-b97b-0c37f877119f" providerId="ADAL" clId="{F585A28F-34F7-4D28-B641-78252DAB29E0}" dt="2025-07-16T09:16:45.419" v="74" actId="1076"/>
-        <pc:sldMkLst>
-          <pc:docMk/>
-          <pc:sldMk cId="1949621639" sldId="484"/>
-        </pc:sldMkLst>
-        <pc:spChg chg="mod">
-          <ac:chgData name="Mohammed Fasha" userId="cc64f42d-a1a6-4f08-b97b-0c37f877119f" providerId="ADAL" clId="{F585A28F-34F7-4D28-B641-78252DAB29E0}" dt="2025-07-16T09:16:34.981" v="72" actId="5793"/>
-          <ac:spMkLst>
-            <pc:docMk/>
-            <pc:sldMk cId="1949621639" sldId="484"/>
-            <ac:spMk id="2" creationId="{00E50F6B-D0D0-409C-B437-2D7A32D8857A}"/>
-          </ac:spMkLst>
-        </pc:spChg>
-        <pc:picChg chg="mod">
-          <ac:chgData name="Mohammed Fasha" userId="cc64f42d-a1a6-4f08-b97b-0c37f877119f" providerId="ADAL" clId="{F585A28F-34F7-4D28-B641-78252DAB29E0}" dt="2025-07-16T09:16:42.296" v="73" actId="14100"/>
-          <ac:picMkLst>
-            <pc:docMk/>
-            <pc:sldMk cId="1949621639" sldId="484"/>
-            <ac:picMk id="12" creationId="{ED72E220-66E3-C895-AA2B-7821BAB0B80F}"/>
-          </ac:picMkLst>
-        </pc:picChg>
-        <pc:picChg chg="mod">
-          <ac:chgData name="Mohammed Fasha" userId="cc64f42d-a1a6-4f08-b97b-0c37f877119f" providerId="ADAL" clId="{F585A28F-34F7-4D28-B641-78252DAB29E0}" dt="2025-07-16T09:16:45.419" v="74" actId="1076"/>
-          <ac:picMkLst>
-            <pc:docMk/>
-            <pc:sldMk cId="1949621639" sldId="484"/>
-            <ac:picMk id="13" creationId="{923AB4FC-8803-B130-E7FF-D6F9B65D8759}"/>
-          </ac:picMkLst>
-        </pc:picChg>
-      </pc:sldChg>
-    </pc:docChg>
-  </pc:docChgLst>
-  <pc:docChgLst>
-    <pc:chgData name="Mohammed Fasha" userId="cc64f42d-a1a6-4f08-b97b-0c37f877119f" providerId="ADAL" clId="{30B40AC3-5669-44FB-A9B9-80E8E88C9E32}"/>
-    <pc:docChg chg="undo custSel addSld delSld modSld">
-      <pc:chgData name="Mohammed Fasha" userId="cc64f42d-a1a6-4f08-b97b-0c37f877119f" providerId="ADAL" clId="{30B40AC3-5669-44FB-A9B9-80E8E88C9E32}" dt="2024-10-21T08:00:22.594" v="429" actId="207"/>
-      <pc:docMkLst>
-        <pc:docMk/>
-      </pc:docMkLst>
-      <pc:sldChg chg="modSp">
-        <pc:chgData name="Mohammed Fasha" userId="cc64f42d-a1a6-4f08-b97b-0c37f877119f" providerId="ADAL" clId="{30B40AC3-5669-44FB-A9B9-80E8E88C9E32}" dt="2024-10-21T07:01:55.743" v="0" actId="207"/>
-        <pc:sldMkLst>
-          <pc:docMk/>
-          <pc:sldMk cId="4051642265" sldId="268"/>
-        </pc:sldMkLst>
-      </pc:sldChg>
-      <pc:sldChg chg="modSp">
-        <pc:chgData name="Mohammed Fasha" userId="cc64f42d-a1a6-4f08-b97b-0c37f877119f" providerId="ADAL" clId="{30B40AC3-5669-44FB-A9B9-80E8E88C9E32}" dt="2024-10-21T07:23:44.619" v="11"/>
-        <pc:sldMkLst>
-          <pc:docMk/>
-          <pc:sldMk cId="1260131707" sldId="277"/>
-        </pc:sldMkLst>
-      </pc:sldChg>
-      <pc:sldChg chg="addSp delSp modSp add del">
-        <pc:chgData name="Mohammed Fasha" userId="cc64f42d-a1a6-4f08-b97b-0c37f877119f" providerId="ADAL" clId="{30B40AC3-5669-44FB-A9B9-80E8E88C9E32}" dt="2024-10-21T07:42:04.586" v="230" actId="2696"/>
-        <pc:sldMkLst>
-          <pc:docMk/>
-          <pc:sldMk cId="3743348053" sldId="456"/>
-        </pc:sldMkLst>
-      </pc:sldChg>
-      <pc:sldChg chg="addSp delSp modSp add del">
-        <pc:chgData name="Mohammed Fasha" userId="cc64f42d-a1a6-4f08-b97b-0c37f877119f" providerId="ADAL" clId="{30B40AC3-5669-44FB-A9B9-80E8E88C9E32}" dt="2024-10-21T07:43:37.674" v="248" actId="2696"/>
-        <pc:sldMkLst>
-          <pc:docMk/>
-          <pc:sldMk cId="1914310957" sldId="457"/>
-        </pc:sldMkLst>
-      </pc:sldChg>
-      <pc:sldChg chg="addSp delSp modSp add del">
-        <pc:chgData name="Mohammed Fasha" userId="cc64f42d-a1a6-4f08-b97b-0c37f877119f" providerId="ADAL" clId="{30B40AC3-5669-44FB-A9B9-80E8E88C9E32}" dt="2024-10-21T07:43:44.968" v="251" actId="2696"/>
-        <pc:sldMkLst>
-          <pc:docMk/>
-          <pc:sldMk cId="1563484610" sldId="458"/>
-        </pc:sldMkLst>
-      </pc:sldChg>
-      <pc:sldChg chg="addSp delSp modSp add del">
-        <pc:chgData name="Mohammed Fasha" userId="cc64f42d-a1a6-4f08-b97b-0c37f877119f" providerId="ADAL" clId="{30B40AC3-5669-44FB-A9B9-80E8E88C9E32}" dt="2024-10-21T07:43:48.926" v="253" actId="2696"/>
-        <pc:sldMkLst>
-          <pc:docMk/>
-          <pc:sldMk cId="3782395966" sldId="459"/>
-        </pc:sldMkLst>
-      </pc:sldChg>
-      <pc:sldChg chg="addSp delSp modSp add">
-        <pc:chgData name="Mohammed Fasha" userId="cc64f42d-a1a6-4f08-b97b-0c37f877119f" providerId="ADAL" clId="{30B40AC3-5669-44FB-A9B9-80E8E88C9E32}" dt="2024-10-21T07:58:46.456" v="410" actId="207"/>
-        <pc:sldMkLst>
-          <pc:docMk/>
-          <pc:sldMk cId="713799975" sldId="460"/>
-        </pc:sldMkLst>
-      </pc:sldChg>
-      <pc:sldChg chg="addSp delSp modSp add">
-        <pc:chgData name="Mohammed Fasha" userId="cc64f42d-a1a6-4f08-b97b-0c37f877119f" providerId="ADAL" clId="{30B40AC3-5669-44FB-A9B9-80E8E88C9E32}" dt="2024-10-21T08:00:22.594" v="429" actId="207"/>
-        <pc:sldMkLst>
-          <pc:docMk/>
-          <pc:sldMk cId="1559487564" sldId="461"/>
-        </pc:sldMkLst>
-      </pc:sldChg>
-      <pc:sldChg chg="addSp delSp modSp add">
-        <pc:chgData name="Mohammed Fasha" userId="cc64f42d-a1a6-4f08-b97b-0c37f877119f" providerId="ADAL" clId="{30B40AC3-5669-44FB-A9B9-80E8E88C9E32}" dt="2024-10-21T07:54:42.825" v="379" actId="207"/>
-        <pc:sldMkLst>
-          <pc:docMk/>
-          <pc:sldMk cId="3087456825" sldId="462"/>
-        </pc:sldMkLst>
-      </pc:sldChg>
-      <pc:sldChg chg="addSp delSp modSp add">
-        <pc:chgData name="Mohammed Fasha" userId="cc64f42d-a1a6-4f08-b97b-0c37f877119f" providerId="ADAL" clId="{30B40AC3-5669-44FB-A9B9-80E8E88C9E32}" dt="2024-10-21T07:56:10.314" v="392" actId="14100"/>
-        <pc:sldMkLst>
-          <pc:docMk/>
-          <pc:sldMk cId="1869085755" sldId="463"/>
-        </pc:sldMkLst>
-      </pc:sldChg>
-      <pc:sldChg chg="addSp modSp add">
-        <pc:chgData name="Mohammed Fasha" userId="cc64f42d-a1a6-4f08-b97b-0c37f877119f" providerId="ADAL" clId="{30B40AC3-5669-44FB-A9B9-80E8E88C9E32}" dt="2024-10-21T07:56:43.392" v="396" actId="5793"/>
-        <pc:sldMkLst>
-          <pc:docMk/>
-          <pc:sldMk cId="4139560" sldId="464"/>
-        </pc:sldMkLst>
-      </pc:sldChg>
-      <pc:sldChg chg="addSp modSp add">
-        <pc:chgData name="Mohammed Fasha" userId="cc64f42d-a1a6-4f08-b97b-0c37f877119f" providerId="ADAL" clId="{30B40AC3-5669-44FB-A9B9-80E8E88C9E32}" dt="2024-10-21T07:57:39.264" v="404" actId="207"/>
-        <pc:sldMkLst>
-          <pc:docMk/>
-          <pc:sldMk cId="277181267" sldId="465"/>
         </pc:sldMkLst>
       </pc:sldChg>
     </pc:docChg>
@@ -2473,7 +2060,7 @@
           <a:p>
             <a:fld id="{D83FB9BE-DA6C-46CF-8E77-0CE63E601AD4}" type="datetimeFigureOut">
               <a:rPr lang="en-US" smtClean="0"/>
-              <a:t>7/17/2025</a:t>
+              <a:t>7/26/2025</a:t>
             </a:fld>
             <a:endParaRPr lang="en-US"/>
           </a:p>
@@ -2671,7 +2258,7 @@
           <a:p>
             <a:fld id="{D83FB9BE-DA6C-46CF-8E77-0CE63E601AD4}" type="datetimeFigureOut">
               <a:rPr lang="en-US" smtClean="0"/>
-              <a:t>7/17/2025</a:t>
+              <a:t>7/26/2025</a:t>
             </a:fld>
             <a:endParaRPr lang="en-US"/>
           </a:p>
@@ -2879,7 +2466,7 @@
           <a:p>
             <a:fld id="{D83FB9BE-DA6C-46CF-8E77-0CE63E601AD4}" type="datetimeFigureOut">
               <a:rPr lang="en-US" smtClean="0"/>
-              <a:t>7/17/2025</a:t>
+              <a:t>7/26/2025</a:t>
             </a:fld>
             <a:endParaRPr lang="en-US"/>
           </a:p>
@@ -3292,7 +2879,7 @@
           <a:p>
             <a:fld id="{D83FB9BE-DA6C-46CF-8E77-0CE63E601AD4}" type="datetimeFigureOut">
               <a:rPr lang="en-US" smtClean="0"/>
-              <a:t>7/17/2025</a:t>
+              <a:t>7/26/2025</a:t>
             </a:fld>
             <a:endParaRPr lang="en-US"/>
           </a:p>
@@ -3557,7 +3144,7 @@
           <a:p>
             <a:fld id="{D83FB9BE-DA6C-46CF-8E77-0CE63E601AD4}" type="datetimeFigureOut">
               <a:rPr lang="en-US" smtClean="0"/>
-              <a:t>7/17/2025</a:t>
+              <a:t>7/26/2025</a:t>
             </a:fld>
             <a:endParaRPr lang="en-US"/>
           </a:p>
@@ -3969,7 +3556,7 @@
           <a:p>
             <a:fld id="{D83FB9BE-DA6C-46CF-8E77-0CE63E601AD4}" type="datetimeFigureOut">
               <a:rPr lang="en-US" smtClean="0"/>
-              <a:t>7/17/2025</a:t>
+              <a:t>7/26/2025</a:t>
             </a:fld>
             <a:endParaRPr lang="en-US"/>
           </a:p>
@@ -4110,7 +3697,7 @@
           <a:p>
             <a:fld id="{D83FB9BE-DA6C-46CF-8E77-0CE63E601AD4}" type="datetimeFigureOut">
               <a:rPr lang="en-US" smtClean="0"/>
-              <a:t>7/17/2025</a:t>
+              <a:t>7/26/2025</a:t>
             </a:fld>
             <a:endParaRPr lang="en-US"/>
           </a:p>
@@ -4223,7 +3810,7 @@
           <a:p>
             <a:fld id="{D83FB9BE-DA6C-46CF-8E77-0CE63E601AD4}" type="datetimeFigureOut">
               <a:rPr lang="en-US" smtClean="0"/>
-              <a:t>7/17/2025</a:t>
+              <a:t>7/26/2025</a:t>
             </a:fld>
             <a:endParaRPr lang="en-US"/>
           </a:p>
@@ -4534,7 +4121,7 @@
           <a:p>
             <a:fld id="{D83FB9BE-DA6C-46CF-8E77-0CE63E601AD4}" type="datetimeFigureOut">
               <a:rPr lang="en-US" smtClean="0"/>
-              <a:t>7/17/2025</a:t>
+              <a:t>7/26/2025</a:t>
             </a:fld>
             <a:endParaRPr lang="en-US"/>
           </a:p>
@@ -4822,7 +4409,7 @@
           <a:p>
             <a:fld id="{D83FB9BE-DA6C-46CF-8E77-0CE63E601AD4}" type="datetimeFigureOut">
               <a:rPr lang="en-US" smtClean="0"/>
-              <a:t>7/17/2025</a:t>
+              <a:t>7/26/2025</a:t>
             </a:fld>
             <a:endParaRPr lang="en-US"/>
           </a:p>
@@ -5063,7 +4650,7 @@
           <a:p>
             <a:fld id="{D83FB9BE-DA6C-46CF-8E77-0CE63E601AD4}" type="datetimeFigureOut">
               <a:rPr lang="en-US" smtClean="0"/>
-              <a:t>7/17/2025</a:t>
+              <a:t>7/26/2025</a:t>
             </a:fld>
             <a:endParaRPr lang="en-US"/>
           </a:p>
@@ -5755,16 +5342,18 @@
           </a:xfrm>
         </p:spPr>
         <p:txBody>
-          <a:bodyPr/>
+          <a:bodyPr>
+            <a:normAutofit/>
+          </a:bodyPr>
           <a:lstStyle/>
           <a:p>
             <a:r>
-              <a:rPr lang="en-US" b="1" dirty="0"/>
+              <a:rPr lang="en-US" sz="2000" b="1" dirty="0"/>
               <a:t>Predictions:</a:t>
             </a:r>
           </a:p>
           <a:p>
-            <a:endParaRPr lang="en-US" dirty="0"/>
+            <a:endParaRPr lang="en-US" sz="2000" dirty="0"/>
           </a:p>
         </p:txBody>
       </p:sp>
@@ -5789,7 +5378,10 @@
           <a:bodyPr/>
           <a:lstStyle/>
           <a:p>
-            <a:endParaRPr lang="en-US"/>
+            <a:r>
+              <a:rPr lang="en-US" dirty="0"/>
+              <a:t>Output</a:t>
+            </a:r>
           </a:p>
         </p:txBody>
       </p:sp>
@@ -5809,7 +5401,7 @@
         </p:nvSpPr>
         <p:spPr>
           <a:xfrm>
-            <a:off x="743465" y="4199138"/>
+            <a:off x="838200" y="3643083"/>
             <a:ext cx="10515600" cy="2152235"/>
           </a:xfrm>
           <a:prstGeom prst="rect">
@@ -5989,31 +5581,31 @@
               <a:buNone/>
             </a:pPr>
             <a:r>
-              <a:rPr lang="en-US" b="1" dirty="0"/>
+              <a:rPr lang="en-US" sz="2000" b="1" dirty="0"/>
               <a:t>Interpretation:</a:t>
             </a:r>
-            <a:endParaRPr lang="en-US" dirty="0"/>
-          </a:p>
-          <a:p>
-            <a:r>
-              <a:rPr lang="en-US" dirty="0"/>
+            <a:endParaRPr lang="en-US" sz="2000" dirty="0"/>
+          </a:p>
+          <a:p>
+            <a:r>
+              <a:rPr lang="en-US" sz="2000" dirty="0"/>
               <a:t>0 = No Diabetes predicted</a:t>
             </a:r>
           </a:p>
           <a:p>
             <a:r>
-              <a:rPr lang="en-US" dirty="0"/>
+              <a:rPr lang="en-US" sz="2000" dirty="0"/>
               <a:t>1 = Diabetes predicted</a:t>
             </a:r>
           </a:p>
           <a:p>
             <a:r>
-              <a:rPr lang="en-US" dirty="0"/>
+              <a:rPr lang="en-US" sz="2000" dirty="0"/>
               <a:t>Model provides binary classification for each patient</a:t>
             </a:r>
           </a:p>
           <a:p>
-            <a:endParaRPr lang="en-US" dirty="0"/>
+            <a:endParaRPr lang="en-US" sz="2000" dirty="0"/>
           </a:p>
         </p:txBody>
       </p:sp>
@@ -6031,7 +5623,7 @@
         </p:nvSpPr>
         <p:spPr>
           <a:xfrm>
-            <a:off x="838200" y="2485370"/>
+            <a:off x="838200" y="2018611"/>
             <a:ext cx="7650892" cy="1477328"/>
           </a:xfrm>
           <a:prstGeom prst="rect">
@@ -6538,10 +6130,10 @@
                         <a:buNone/>
                       </a:pPr>
                       <a:r>
-                        <a:rPr lang="en-US" b="1"/>
+                        <a:rPr lang="en-US" b="1" dirty="0"/>
                         <a:t>Actual Non-Diabetic</a:t>
                       </a:r>
-                      <a:endParaRPr lang="en-US"/>
+                      <a:endParaRPr lang="en-US" dirty="0"/>
                     </a:p>
                   </a:txBody>
                   <a:tcPr anchor="ctr"/>
@@ -6648,344 +6240,6 @@
     <p:extLst>
       <p:ext uri="{BB962C8B-B14F-4D97-AF65-F5344CB8AC3E}">
         <p14:creationId xmlns:p14="http://schemas.microsoft.com/office/powerpoint/2010/main" val="2379583142"/>
-      </p:ext>
-    </p:extLst>
-  </p:cSld>
-  <p:clrMapOvr>
-    <a:masterClrMapping/>
-  </p:clrMapOvr>
-</p:sld>
-</file>
-
-<file path=ppt/slides/slide12.xml><?xml version="1.0" encoding="utf-8"?>
-<p:sld xmlns:a="http://schemas.openxmlformats.org/drawingml/2006/main" xmlns:r="http://schemas.openxmlformats.org/officeDocument/2006/relationships" xmlns:p="http://schemas.openxmlformats.org/presentationml/2006/main">
-  <p:cSld>
-    <p:spTree>
-      <p:nvGrpSpPr>
-        <p:cNvPr id="1" name=""/>
-        <p:cNvGrpSpPr/>
-        <p:nvPr/>
-      </p:nvGrpSpPr>
-      <p:grpSpPr>
-        <a:xfrm>
-          <a:off x="0" y="0"/>
-          <a:ext cx="0" cy="0"/>
-          <a:chOff x="0" y="0"/>
-          <a:chExt cx="0" cy="0"/>
-        </a:xfrm>
-      </p:grpSpPr>
-      <p:sp>
-        <p:nvSpPr>
-          <p:cNvPr id="2" name="Content Placeholder 1">
-            <a:extLst>
-              <a:ext uri="{FF2B5EF4-FFF2-40B4-BE49-F238E27FC236}">
-                <a16:creationId xmlns:a16="http://schemas.microsoft.com/office/drawing/2014/main" id="{09692B02-3D1C-B5B4-2F50-35F81605CB91}"/>
-              </a:ext>
-            </a:extLst>
-          </p:cNvPr>
-          <p:cNvSpPr>
-            <a:spLocks noGrp="1"/>
-          </p:cNvSpPr>
-          <p:nvPr>
-            <p:ph idx="1"/>
-          </p:nvPr>
-        </p:nvSpPr>
-        <p:spPr/>
-        <p:txBody>
-          <a:bodyPr/>
-          <a:lstStyle/>
-          <a:p>
-            <a:endParaRPr lang="en-US"/>
-          </a:p>
-        </p:txBody>
-      </p:sp>
-      <p:sp>
-        <p:nvSpPr>
-          <p:cNvPr id="3" name="Title 2">
-            <a:extLst>
-              <a:ext uri="{FF2B5EF4-FFF2-40B4-BE49-F238E27FC236}">
-                <a16:creationId xmlns:a16="http://schemas.microsoft.com/office/drawing/2014/main" id="{F9DDC50F-8882-41AE-FEC5-89A6CB20165D}"/>
-              </a:ext>
-            </a:extLst>
-          </p:cNvPr>
-          <p:cNvSpPr>
-            <a:spLocks noGrp="1"/>
-          </p:cNvSpPr>
-          <p:nvPr>
-            <p:ph type="title"/>
-          </p:nvPr>
-        </p:nvSpPr>
-        <p:spPr/>
-        <p:txBody>
-          <a:bodyPr/>
-          <a:lstStyle/>
-          <a:p>
-            <a:endParaRPr lang="en-US"/>
-          </a:p>
-        </p:txBody>
-      </p:sp>
-    </p:spTree>
-    <p:extLst>
-      <p:ext uri="{BB962C8B-B14F-4D97-AF65-F5344CB8AC3E}">
-        <p14:creationId xmlns:p14="http://schemas.microsoft.com/office/powerpoint/2010/main" val="732047524"/>
-      </p:ext>
-    </p:extLst>
-  </p:cSld>
-  <p:clrMapOvr>
-    <a:masterClrMapping/>
-  </p:clrMapOvr>
-</p:sld>
-</file>
-
-<file path=ppt/slides/slide13.xml><?xml version="1.0" encoding="utf-8"?>
-<p:sld xmlns:a="http://schemas.openxmlformats.org/drawingml/2006/main" xmlns:r="http://schemas.openxmlformats.org/officeDocument/2006/relationships" xmlns:p="http://schemas.openxmlformats.org/presentationml/2006/main">
-  <p:cSld>
-    <p:spTree>
-      <p:nvGrpSpPr>
-        <p:cNvPr id="1" name="">
-          <a:extLst>
-            <a:ext uri="{FF2B5EF4-FFF2-40B4-BE49-F238E27FC236}">
-              <a16:creationId xmlns:a16="http://schemas.microsoft.com/office/drawing/2014/main" id="{1E303FB7-F1B8-C668-87BE-1CD653D2DB5F}"/>
-            </a:ext>
-          </a:extLst>
-        </p:cNvPr>
-        <p:cNvGrpSpPr/>
-        <p:nvPr/>
-      </p:nvGrpSpPr>
-      <p:grpSpPr>
-        <a:xfrm>
-          <a:off x="0" y="0"/>
-          <a:ext cx="0" cy="0"/>
-          <a:chOff x="0" y="0"/>
-          <a:chExt cx="0" cy="0"/>
-        </a:xfrm>
-      </p:grpSpPr>
-      <p:sp>
-        <p:nvSpPr>
-          <p:cNvPr id="2" name="Content Placeholder 1">
-            <a:extLst>
-              <a:ext uri="{FF2B5EF4-FFF2-40B4-BE49-F238E27FC236}">
-                <a16:creationId xmlns:a16="http://schemas.microsoft.com/office/drawing/2014/main" id="{631B8FED-1AE0-BFEB-7D92-0C7E5076CED2}"/>
-              </a:ext>
-            </a:extLst>
-          </p:cNvPr>
-          <p:cNvSpPr>
-            <a:spLocks noGrp="1"/>
-          </p:cNvSpPr>
-          <p:nvPr>
-            <p:ph idx="1"/>
-          </p:nvPr>
-        </p:nvSpPr>
-        <p:spPr/>
-        <p:txBody>
-          <a:bodyPr/>
-          <a:lstStyle/>
-          <a:p>
-            <a:endParaRPr lang="en-US"/>
-          </a:p>
-        </p:txBody>
-      </p:sp>
-      <p:sp>
-        <p:nvSpPr>
-          <p:cNvPr id="3" name="Title 2">
-            <a:extLst>
-              <a:ext uri="{FF2B5EF4-FFF2-40B4-BE49-F238E27FC236}">
-                <a16:creationId xmlns:a16="http://schemas.microsoft.com/office/drawing/2014/main" id="{EC634DAE-B2E2-F4AA-619B-6B5D4030908B}"/>
-              </a:ext>
-            </a:extLst>
-          </p:cNvPr>
-          <p:cNvSpPr>
-            <a:spLocks noGrp="1"/>
-          </p:cNvSpPr>
-          <p:nvPr>
-            <p:ph type="title"/>
-          </p:nvPr>
-        </p:nvSpPr>
-        <p:spPr/>
-        <p:txBody>
-          <a:bodyPr/>
-          <a:lstStyle/>
-          <a:p>
-            <a:endParaRPr lang="en-US"/>
-          </a:p>
-        </p:txBody>
-      </p:sp>
-    </p:spTree>
-    <p:extLst>
-      <p:ext uri="{BB962C8B-B14F-4D97-AF65-F5344CB8AC3E}">
-        <p14:creationId xmlns:p14="http://schemas.microsoft.com/office/powerpoint/2010/main" val="1671393962"/>
-      </p:ext>
-    </p:extLst>
-  </p:cSld>
-  <p:clrMapOvr>
-    <a:masterClrMapping/>
-  </p:clrMapOvr>
-</p:sld>
-</file>
-
-<file path=ppt/slides/slide14.xml><?xml version="1.0" encoding="utf-8"?>
-<p:sld xmlns:a="http://schemas.openxmlformats.org/drawingml/2006/main" xmlns:r="http://schemas.openxmlformats.org/officeDocument/2006/relationships" xmlns:p="http://schemas.openxmlformats.org/presentationml/2006/main">
-  <p:cSld>
-    <p:spTree>
-      <p:nvGrpSpPr>
-        <p:cNvPr id="1" name="">
-          <a:extLst>
-            <a:ext uri="{FF2B5EF4-FFF2-40B4-BE49-F238E27FC236}">
-              <a16:creationId xmlns:a16="http://schemas.microsoft.com/office/drawing/2014/main" id="{AE3E1D2A-4F1D-C3D4-643A-900AEA1BBB86}"/>
-            </a:ext>
-          </a:extLst>
-        </p:cNvPr>
-        <p:cNvGrpSpPr/>
-        <p:nvPr/>
-      </p:nvGrpSpPr>
-      <p:grpSpPr>
-        <a:xfrm>
-          <a:off x="0" y="0"/>
-          <a:ext cx="0" cy="0"/>
-          <a:chOff x="0" y="0"/>
-          <a:chExt cx="0" cy="0"/>
-        </a:xfrm>
-      </p:grpSpPr>
-      <p:sp>
-        <p:nvSpPr>
-          <p:cNvPr id="2" name="Content Placeholder 1">
-            <a:extLst>
-              <a:ext uri="{FF2B5EF4-FFF2-40B4-BE49-F238E27FC236}">
-                <a16:creationId xmlns:a16="http://schemas.microsoft.com/office/drawing/2014/main" id="{31F43DD0-9A44-1F2A-1853-5467AEDD3CC4}"/>
-              </a:ext>
-            </a:extLst>
-          </p:cNvPr>
-          <p:cNvSpPr>
-            <a:spLocks noGrp="1"/>
-          </p:cNvSpPr>
-          <p:nvPr>
-            <p:ph idx="1"/>
-          </p:nvPr>
-        </p:nvSpPr>
-        <p:spPr/>
-        <p:txBody>
-          <a:bodyPr/>
-          <a:lstStyle/>
-          <a:p>
-            <a:endParaRPr lang="en-US"/>
-          </a:p>
-        </p:txBody>
-      </p:sp>
-      <p:sp>
-        <p:nvSpPr>
-          <p:cNvPr id="3" name="Title 2">
-            <a:extLst>
-              <a:ext uri="{FF2B5EF4-FFF2-40B4-BE49-F238E27FC236}">
-                <a16:creationId xmlns:a16="http://schemas.microsoft.com/office/drawing/2014/main" id="{9A2AD2F3-297B-3276-766D-E9531728FDB2}"/>
-              </a:ext>
-            </a:extLst>
-          </p:cNvPr>
-          <p:cNvSpPr>
-            <a:spLocks noGrp="1"/>
-          </p:cNvSpPr>
-          <p:nvPr>
-            <p:ph type="title"/>
-          </p:nvPr>
-        </p:nvSpPr>
-        <p:spPr/>
-        <p:txBody>
-          <a:bodyPr/>
-          <a:lstStyle/>
-          <a:p>
-            <a:endParaRPr lang="en-US"/>
-          </a:p>
-        </p:txBody>
-      </p:sp>
-    </p:spTree>
-    <p:extLst>
-      <p:ext uri="{BB962C8B-B14F-4D97-AF65-F5344CB8AC3E}">
-        <p14:creationId xmlns:p14="http://schemas.microsoft.com/office/powerpoint/2010/main" val="934545252"/>
-      </p:ext>
-    </p:extLst>
-  </p:cSld>
-  <p:clrMapOvr>
-    <a:masterClrMapping/>
-  </p:clrMapOvr>
-</p:sld>
-</file>
-
-<file path=ppt/slides/slide15.xml><?xml version="1.0" encoding="utf-8"?>
-<p:sld xmlns:a="http://schemas.openxmlformats.org/drawingml/2006/main" xmlns:r="http://schemas.openxmlformats.org/officeDocument/2006/relationships" xmlns:p="http://schemas.openxmlformats.org/presentationml/2006/main">
-  <p:cSld>
-    <p:spTree>
-      <p:nvGrpSpPr>
-        <p:cNvPr id="1" name="">
-          <a:extLst>
-            <a:ext uri="{FF2B5EF4-FFF2-40B4-BE49-F238E27FC236}">
-              <a16:creationId xmlns:a16="http://schemas.microsoft.com/office/drawing/2014/main" id="{1B7546DB-FABA-E193-DE19-4DCB78029F76}"/>
-            </a:ext>
-          </a:extLst>
-        </p:cNvPr>
-        <p:cNvGrpSpPr/>
-        <p:nvPr/>
-      </p:nvGrpSpPr>
-      <p:grpSpPr>
-        <a:xfrm>
-          <a:off x="0" y="0"/>
-          <a:ext cx="0" cy="0"/>
-          <a:chOff x="0" y="0"/>
-          <a:chExt cx="0" cy="0"/>
-        </a:xfrm>
-      </p:grpSpPr>
-      <p:sp>
-        <p:nvSpPr>
-          <p:cNvPr id="2" name="Content Placeholder 1">
-            <a:extLst>
-              <a:ext uri="{FF2B5EF4-FFF2-40B4-BE49-F238E27FC236}">
-                <a16:creationId xmlns:a16="http://schemas.microsoft.com/office/drawing/2014/main" id="{BFEB2F64-490F-F85B-8BC1-0437FE49A7D8}"/>
-              </a:ext>
-            </a:extLst>
-          </p:cNvPr>
-          <p:cNvSpPr>
-            <a:spLocks noGrp="1"/>
-          </p:cNvSpPr>
-          <p:nvPr>
-            <p:ph idx="1"/>
-          </p:nvPr>
-        </p:nvSpPr>
-        <p:spPr/>
-        <p:txBody>
-          <a:bodyPr/>
-          <a:lstStyle/>
-          <a:p>
-            <a:endParaRPr lang="en-US"/>
-          </a:p>
-        </p:txBody>
-      </p:sp>
-      <p:sp>
-        <p:nvSpPr>
-          <p:cNvPr id="3" name="Title 2">
-            <a:extLst>
-              <a:ext uri="{FF2B5EF4-FFF2-40B4-BE49-F238E27FC236}">
-                <a16:creationId xmlns:a16="http://schemas.microsoft.com/office/drawing/2014/main" id="{8684FA40-E33D-1FF2-9748-F22718805430}"/>
-              </a:ext>
-            </a:extLst>
-          </p:cNvPr>
-          <p:cNvSpPr>
-            <a:spLocks noGrp="1"/>
-          </p:cNvSpPr>
-          <p:nvPr>
-            <p:ph type="title"/>
-          </p:nvPr>
-        </p:nvSpPr>
-        <p:spPr/>
-        <p:txBody>
-          <a:bodyPr/>
-          <a:lstStyle/>
-          <a:p>
-            <a:endParaRPr lang="en-US"/>
-          </a:p>
-        </p:txBody>
-      </p:sp>
-    </p:spTree>
-    <p:extLst>
-      <p:ext uri="{BB962C8B-B14F-4D97-AF65-F5344CB8AC3E}">
-        <p14:creationId xmlns:p14="http://schemas.microsoft.com/office/powerpoint/2010/main" val="2026905861"/>
       </p:ext>
     </p:extLst>
   </p:cSld>
@@ -9387,7 +8641,7 @@
               <a:buNone/>
             </a:pPr>
             <a:r>
-              <a:rPr lang="en-US" b="1" noProof="1">
+              <a:rPr lang="en-US" sz="1400" b="1" noProof="1">
                 <a:solidFill>
                   <a:srgbClr val="9723B4"/>
                 </a:solidFill>
@@ -9397,7 +8651,7 @@
               <a:t>import</a:t>
             </a:r>
             <a:r>
-              <a:rPr lang="en-US" b="1" noProof="1">
+              <a:rPr lang="en-US" sz="1400" b="1" noProof="1">
                 <a:solidFill>
                   <a:srgbClr val="000000"/>
                 </a:solidFill>
@@ -9407,7 +8661,7 @@
               <a:t> pandas </a:t>
             </a:r>
             <a:r>
-              <a:rPr lang="en-US" b="1" noProof="1">
+              <a:rPr lang="en-US" sz="1400" b="1" noProof="1">
                 <a:solidFill>
                   <a:srgbClr val="9723B4"/>
                 </a:solidFill>
@@ -9417,7 +8671,7 @@
               <a:t>as</a:t>
             </a:r>
             <a:r>
-              <a:rPr lang="en-US" b="1" noProof="1">
+              <a:rPr lang="en-US" sz="1400" b="1" noProof="1">
                 <a:solidFill>
                   <a:srgbClr val="000000"/>
                 </a:solidFill>
@@ -9435,7 +8689,7 @@
               <a:buNone/>
             </a:pPr>
             <a:r>
-              <a:rPr lang="en-US" b="1" noProof="1">
+              <a:rPr lang="en-US" sz="1400" b="1" noProof="1">
                 <a:solidFill>
                   <a:srgbClr val="9723B4"/>
                 </a:solidFill>
@@ -9445,7 +8699,7 @@
               <a:t>from</a:t>
             </a:r>
             <a:r>
-              <a:rPr lang="en-US" b="1" noProof="1">
+              <a:rPr lang="en-US" sz="1400" b="1" noProof="1">
                 <a:solidFill>
                   <a:srgbClr val="000000"/>
                 </a:solidFill>
@@ -9455,7 +8709,7 @@
               <a:t> sklearn.model_selection </a:t>
             </a:r>
             <a:r>
-              <a:rPr lang="en-US" b="1" noProof="1">
+              <a:rPr lang="en-US" sz="1400" b="1" noProof="1">
                 <a:solidFill>
                   <a:srgbClr val="9723B4"/>
                 </a:solidFill>
@@ -9465,7 +8719,7 @@
               <a:t>import</a:t>
             </a:r>
             <a:r>
-              <a:rPr lang="en-US" b="1" noProof="1">
+              <a:rPr lang="en-US" sz="1400" b="1" noProof="1">
                 <a:solidFill>
                   <a:srgbClr val="000000"/>
                 </a:solidFill>
@@ -9483,7 +8737,7 @@
               <a:buNone/>
             </a:pPr>
             <a:r>
-              <a:rPr lang="en-US" b="1" noProof="1">
+              <a:rPr lang="en-US" sz="1400" b="1" noProof="1">
                 <a:solidFill>
                   <a:srgbClr val="9723B4"/>
                 </a:solidFill>
@@ -9493,7 +8747,7 @@
               <a:t>from</a:t>
             </a:r>
             <a:r>
-              <a:rPr lang="en-US" b="1" noProof="1">
+              <a:rPr lang="en-US" sz="1400" b="1" noProof="1">
                 <a:solidFill>
                   <a:srgbClr val="000000"/>
                 </a:solidFill>
@@ -9503,7 +8757,7 @@
               <a:t> sklearn.linear_model </a:t>
             </a:r>
             <a:r>
-              <a:rPr lang="en-US" b="1" noProof="1">
+              <a:rPr lang="en-US" sz="1400" b="1" noProof="1">
                 <a:solidFill>
                   <a:srgbClr val="9723B4"/>
                 </a:solidFill>
@@ -9513,7 +8767,7 @@
               <a:t>import</a:t>
             </a:r>
             <a:r>
-              <a:rPr lang="en-US" b="1" noProof="1">
+              <a:rPr lang="en-US" sz="1400" b="1" noProof="1">
                 <a:solidFill>
                   <a:srgbClr val="000000"/>
                 </a:solidFill>
@@ -9531,7 +8785,7 @@
               <a:buNone/>
             </a:pPr>
             <a:br>
-              <a:rPr lang="en-US" b="1" noProof="1">
+              <a:rPr lang="en-US" sz="1400" b="1" noProof="1">
                 <a:solidFill>
                   <a:srgbClr val="000000"/>
                 </a:solidFill>
@@ -9540,7 +8794,7 @@
               </a:rPr>
             </a:br>
             <a:r>
-              <a:rPr lang="en-US" b="1" noProof="1">
+              <a:rPr lang="en-US" sz="1400" b="1" noProof="1">
                 <a:solidFill>
                   <a:srgbClr val="008000"/>
                 </a:solidFill>
@@ -9549,7 +8803,7 @@
               </a:rPr>
               <a:t># Load the dataset from the URL</a:t>
             </a:r>
-            <a:endParaRPr lang="en-US" b="1" noProof="1">
+            <a:endParaRPr lang="en-US" sz="1400" b="1" noProof="1">
               <a:solidFill>
                 <a:srgbClr val="000000"/>
               </a:solidFill>
@@ -9565,7 +8819,7 @@
               <a:buNone/>
             </a:pPr>
             <a:r>
-              <a:rPr lang="en-US" b="1" noProof="1">
+              <a:rPr lang="en-US" sz="1400" b="1" noProof="1">
                 <a:solidFill>
                   <a:srgbClr val="000000"/>
                 </a:solidFill>
@@ -9575,7 +8829,7 @@
               <a:t>url = </a:t>
             </a:r>
             <a:r>
-              <a:rPr lang="en-US" b="1" noProof="1">
+              <a:rPr lang="en-US" sz="1400" b="1" noProof="1">
                 <a:solidFill>
                   <a:srgbClr val="A31515"/>
                 </a:solidFill>
@@ -9584,7 +8838,7 @@
               </a:rPr>
               <a:t>"https://raw.githubusercontent.com/msfasha/307304-Data-Mining/main/20242/datasets/diabetes.csv"</a:t>
             </a:r>
-            <a:endParaRPr lang="en-US" b="1" noProof="1">
+            <a:endParaRPr lang="en-US" sz="1400" b="1" noProof="1">
               <a:solidFill>
                 <a:srgbClr val="000000"/>
               </a:solidFill>
@@ -9600,7 +8854,7 @@
               <a:buNone/>
             </a:pPr>
             <a:r>
-              <a:rPr lang="en-US" b="1" noProof="1">
+              <a:rPr lang="en-US" sz="1400" b="1" noProof="1">
                 <a:solidFill>
                   <a:srgbClr val="000000"/>
                 </a:solidFill>
@@ -9618,7 +8872,7 @@
               <a:buNone/>
             </a:pPr>
             <a:br>
-              <a:rPr lang="en-US" b="1" noProof="1">
+              <a:rPr lang="en-US" sz="1400" b="1" noProof="1">
                 <a:solidFill>
                   <a:srgbClr val="000000"/>
                 </a:solidFill>
@@ -9627,7 +8881,7 @@
               </a:rPr>
             </a:br>
             <a:r>
-              <a:rPr lang="en-US" b="1" noProof="1">
+              <a:rPr lang="en-US" sz="1400" b="1" noProof="1">
                 <a:solidFill>
                   <a:srgbClr val="008000"/>
                 </a:solidFill>
@@ -9636,7 +8890,7 @@
               </a:rPr>
               <a:t># Define features (X) and target (y)</a:t>
             </a:r>
-            <a:endParaRPr lang="en-US" b="1" noProof="1">
+            <a:endParaRPr lang="en-US" sz="1400" b="1" noProof="1">
               <a:solidFill>
                 <a:srgbClr val="000000"/>
               </a:solidFill>
@@ -9652,7 +8906,7 @@
               <a:buNone/>
             </a:pPr>
             <a:r>
-              <a:rPr lang="en-US" b="1" noProof="1">
+              <a:rPr lang="en-US" sz="1400" b="1" noProof="1">
                 <a:solidFill>
                   <a:srgbClr val="000000"/>
                 </a:solidFill>
@@ -9662,7 +8916,7 @@
               <a:t>X = data[[</a:t>
             </a:r>
             <a:r>
-              <a:rPr lang="en-US" b="1" noProof="1">
+              <a:rPr lang="en-US" sz="1400" b="1" noProof="1">
                 <a:solidFill>
                   <a:srgbClr val="A31515"/>
                 </a:solidFill>
@@ -9672,7 +8926,7 @@
               <a:t>'Pregnancies'</a:t>
             </a:r>
             <a:r>
-              <a:rPr lang="en-US" b="1" noProof="1">
+              <a:rPr lang="en-US" sz="1400" b="1" noProof="1">
                 <a:solidFill>
                   <a:srgbClr val="000000"/>
                 </a:solidFill>
@@ -9682,7 +8936,7 @@
               <a:t>, </a:t>
             </a:r>
             <a:r>
-              <a:rPr lang="en-US" b="1" noProof="1">
+              <a:rPr lang="en-US" sz="1400" b="1" noProof="1">
                 <a:solidFill>
                   <a:srgbClr val="A31515"/>
                 </a:solidFill>
@@ -9692,7 +8946,7 @@
               <a:t>'Glucose'</a:t>
             </a:r>
             <a:r>
-              <a:rPr lang="en-US" b="1" noProof="1">
+              <a:rPr lang="en-US" sz="1400" b="1" noProof="1">
                 <a:solidFill>
                   <a:srgbClr val="000000"/>
                 </a:solidFill>
@@ -9702,7 +8956,7 @@
               <a:t>, </a:t>
             </a:r>
             <a:r>
-              <a:rPr lang="en-US" b="1" noProof="1">
+              <a:rPr lang="en-US" sz="1400" b="1" noProof="1">
                 <a:solidFill>
                   <a:srgbClr val="A31515"/>
                 </a:solidFill>
@@ -9712,7 +8966,7 @@
               <a:t>'BloodPressure'</a:t>
             </a:r>
             <a:r>
-              <a:rPr lang="en-US" b="1" noProof="1">
+              <a:rPr lang="en-US" sz="1400" b="1" noProof="1">
                 <a:solidFill>
                   <a:srgbClr val="000000"/>
                 </a:solidFill>
@@ -9722,7 +8976,7 @@
               <a:t>, </a:t>
             </a:r>
             <a:r>
-              <a:rPr lang="en-US" b="1" noProof="1">
+              <a:rPr lang="en-US" sz="1400" b="1" noProof="1">
                 <a:solidFill>
                   <a:srgbClr val="A31515"/>
                 </a:solidFill>
@@ -9732,7 +8986,7 @@
               <a:t>'SkinThickness'</a:t>
             </a:r>
             <a:r>
-              <a:rPr lang="en-US" b="1" noProof="1">
+              <a:rPr lang="en-US" sz="1400" b="1" noProof="1">
                 <a:solidFill>
                   <a:srgbClr val="000000"/>
                 </a:solidFill>
@@ -9742,7 +8996,7 @@
               <a:t>, </a:t>
             </a:r>
             <a:r>
-              <a:rPr lang="en-US" b="1" noProof="1">
+              <a:rPr lang="en-US" sz="1400" b="1" noProof="1">
                 <a:solidFill>
                   <a:srgbClr val="A31515"/>
                 </a:solidFill>
@@ -9752,7 +9006,7 @@
               <a:t>'Insulin'</a:t>
             </a:r>
             <a:r>
-              <a:rPr lang="en-US" b="1" noProof="1">
+              <a:rPr lang="en-US" sz="1400" b="1" noProof="1">
                 <a:solidFill>
                   <a:srgbClr val="000000"/>
                 </a:solidFill>
@@ -9762,7 +9016,7 @@
               <a:t>, </a:t>
             </a:r>
             <a:r>
-              <a:rPr lang="en-US" b="1" noProof="1">
+              <a:rPr lang="en-US" sz="1400" b="1" noProof="1">
                 <a:solidFill>
                   <a:srgbClr val="A31515"/>
                 </a:solidFill>
@@ -9772,7 +9026,7 @@
               <a:t>'BMI'</a:t>
             </a:r>
             <a:r>
-              <a:rPr lang="en-US" b="1" noProof="1">
+              <a:rPr lang="en-US" sz="1400" b="1" noProof="1">
                 <a:solidFill>
                   <a:srgbClr val="000000"/>
                 </a:solidFill>
@@ -9782,7 +9036,7 @@
               <a:t>,</a:t>
             </a:r>
             <a:r>
-              <a:rPr lang="en-US" b="1" noProof="1">
+              <a:rPr lang="en-US" sz="1400" b="1" noProof="1">
                 <a:solidFill>
                   <a:srgbClr val="A31515"/>
                 </a:solidFill>
@@ -9792,7 +9046,7 @@
               <a:t>'DiabetesPedigreeFunction'</a:t>
             </a:r>
             <a:r>
-              <a:rPr lang="en-US" b="1" noProof="1">
+              <a:rPr lang="en-US" sz="1400" b="1" noProof="1">
                 <a:solidFill>
                   <a:srgbClr val="000000"/>
                 </a:solidFill>
@@ -9802,7 +9056,7 @@
               <a:t>,</a:t>
             </a:r>
             <a:r>
-              <a:rPr lang="en-US" b="1" noProof="1">
+              <a:rPr lang="en-US" sz="1400" b="1" noProof="1">
                 <a:solidFill>
                   <a:srgbClr val="A31515"/>
                 </a:solidFill>
@@ -9812,7 +9066,7 @@
               <a:t>'Age'</a:t>
             </a:r>
             <a:r>
-              <a:rPr lang="en-US" b="1" noProof="1">
+              <a:rPr lang="en-US" sz="1400" b="1" noProof="1">
                 <a:solidFill>
                   <a:srgbClr val="000000"/>
                 </a:solidFill>
@@ -9830,7 +9084,7 @@
               <a:buNone/>
             </a:pPr>
             <a:r>
-              <a:rPr lang="en-US" b="1" noProof="1">
+              <a:rPr lang="en-US" sz="1400" b="1" noProof="1">
                 <a:solidFill>
                   <a:srgbClr val="000000"/>
                 </a:solidFill>
@@ -9840,7 +9094,7 @@
               <a:t>y = data[</a:t>
             </a:r>
             <a:r>
-              <a:rPr lang="en-US" b="1" noProof="1">
+              <a:rPr lang="en-US" sz="1400" b="1" noProof="1">
                 <a:solidFill>
                   <a:srgbClr val="A31515"/>
                 </a:solidFill>
@@ -9850,7 +9104,7 @@
               <a:t>'Outcome'</a:t>
             </a:r>
             <a:r>
-              <a:rPr lang="en-US" b="1" noProof="1">
+              <a:rPr lang="en-US" sz="1400" b="1" noProof="1">
                 <a:solidFill>
                   <a:srgbClr val="000000"/>
                 </a:solidFill>
@@ -9868,7 +9122,7 @@
               <a:buNone/>
             </a:pPr>
             <a:br>
-              <a:rPr lang="en-US" b="1" noProof="1">
+              <a:rPr lang="en-US" sz="1400" b="1" noProof="1">
                 <a:solidFill>
                   <a:srgbClr val="000000"/>
                 </a:solidFill>
@@ -9877,7 +9131,7 @@
               </a:rPr>
             </a:br>
             <a:r>
-              <a:rPr lang="en-US" b="1" noProof="1">
+              <a:rPr lang="en-US" sz="1400" b="1" noProof="1">
                 <a:solidFill>
                   <a:srgbClr val="008000"/>
                 </a:solidFill>
@@ -9886,7 +9140,7 @@
               </a:rPr>
               <a:t># Split the data</a:t>
             </a:r>
-            <a:endParaRPr lang="en-US" b="1" noProof="1">
+            <a:endParaRPr lang="en-US" sz="1400" b="1" noProof="1">
               <a:solidFill>
                 <a:srgbClr val="000000"/>
               </a:solidFill>
@@ -9902,7 +9156,7 @@
               <a:buNone/>
             </a:pPr>
             <a:r>
-              <a:rPr lang="en-US" b="1" noProof="1">
+              <a:rPr lang="en-US" sz="1400" b="1" noProof="1">
                 <a:solidFill>
                   <a:srgbClr val="000000"/>
                 </a:solidFill>
@@ -9912,7 +9166,7 @@
               <a:t>X_train, X_test, y_train, y_test = train_test_split(X, y, test_size=</a:t>
             </a:r>
             <a:r>
-              <a:rPr lang="en-US" b="1" noProof="1">
+              <a:rPr lang="en-US" sz="1400" b="1" noProof="1">
                 <a:solidFill>
                   <a:srgbClr val="116644"/>
                 </a:solidFill>
@@ -9922,7 +9176,7 @@
               <a:t>0.2</a:t>
             </a:r>
             <a:r>
-              <a:rPr lang="en-US" b="1" noProof="1">
+              <a:rPr lang="en-US" sz="1400" b="1" noProof="1">
                 <a:solidFill>
                   <a:srgbClr val="000000"/>
                 </a:solidFill>
@@ -9940,7 +9194,7 @@
               <a:buNone/>
             </a:pPr>
             <a:br>
-              <a:rPr lang="en-US" b="1" noProof="1">
+              <a:rPr lang="en-US" sz="1400" b="1" noProof="1">
                 <a:solidFill>
                   <a:srgbClr val="000000"/>
                 </a:solidFill>
@@ -9949,7 +9203,7 @@
               </a:rPr>
             </a:br>
             <a:r>
-              <a:rPr lang="en-US" b="1" noProof="1">
+              <a:rPr lang="en-US" sz="1400" b="1" noProof="1">
                 <a:solidFill>
                   <a:srgbClr val="008000"/>
                 </a:solidFill>
@@ -9958,7 +9212,7 @@
               </a:rPr>
               <a:t># Train logistic regression model</a:t>
             </a:r>
-            <a:endParaRPr lang="en-US" b="1" noProof="1">
+            <a:endParaRPr lang="en-US" sz="1400" b="1" noProof="1">
               <a:solidFill>
                 <a:srgbClr val="000000"/>
               </a:solidFill>
@@ -9974,7 +9228,7 @@
               <a:buNone/>
             </a:pPr>
             <a:r>
-              <a:rPr lang="en-US" b="1" noProof="1">
+              <a:rPr lang="en-US" sz="1400" b="1" noProof="1">
                 <a:solidFill>
                   <a:srgbClr val="000000"/>
                 </a:solidFill>
@@ -9984,7 +9238,7 @@
               <a:t>model = LogisticRegression(max_iter=</a:t>
             </a:r>
             <a:r>
-              <a:rPr lang="en-US" b="1" noProof="1">
+              <a:rPr lang="en-US" sz="1400" b="1" noProof="1">
                 <a:solidFill>
                   <a:srgbClr val="116644"/>
                 </a:solidFill>
@@ -9994,7 +9248,7 @@
               <a:t>200</a:t>
             </a:r>
             <a:r>
-              <a:rPr lang="en-US" b="1" noProof="1">
+              <a:rPr lang="en-US" sz="1400" b="1" noProof="1">
                 <a:solidFill>
                   <a:srgbClr val="000000"/>
                 </a:solidFill>
@@ -10004,7 +9258,7 @@
               <a:t>)  </a:t>
             </a:r>
             <a:r>
-              <a:rPr lang="en-US" b="1" noProof="1">
+              <a:rPr lang="en-US" sz="1400" b="1" noProof="1">
                 <a:solidFill>
                   <a:srgbClr val="008000"/>
                 </a:solidFill>
@@ -10013,7 +9267,7 @@
               </a:rPr>
               <a:t># Increase iterations to 200</a:t>
             </a:r>
-            <a:endParaRPr lang="en-US" b="1" noProof="1">
+            <a:endParaRPr lang="en-US" sz="1400" b="1" noProof="1">
               <a:solidFill>
                 <a:srgbClr val="000000"/>
               </a:solidFill>
@@ -10029,7 +9283,7 @@
               <a:buNone/>
             </a:pPr>
             <a:r>
-              <a:rPr lang="en-US" b="1" noProof="1">
+              <a:rPr lang="en-US" sz="1400" b="1" noProof="1">
                 <a:solidFill>
                   <a:srgbClr val="000000"/>
                 </a:solidFill>
@@ -10047,7 +9301,7 @@
               <a:buNone/>
             </a:pPr>
             <a:br>
-              <a:rPr lang="en-US" b="1" noProof="1">
+              <a:rPr lang="en-US" sz="1400" b="1" noProof="1">
                 <a:solidFill>
                   <a:srgbClr val="000000"/>
                 </a:solidFill>
@@ -10056,7 +9310,7 @@
               </a:rPr>
             </a:br>
             <a:r>
-              <a:rPr lang="en-US" b="1" noProof="1">
+              <a:rPr lang="en-US" sz="1400" b="1" noProof="1">
                 <a:solidFill>
                   <a:srgbClr val="008000"/>
                 </a:solidFill>
@@ -10065,7 +9319,7 @@
               </a:rPr>
               <a:t># Predict on test data</a:t>
             </a:r>
-            <a:endParaRPr lang="en-US" b="1" noProof="1">
+            <a:endParaRPr lang="en-US" sz="1400" b="1" noProof="1">
               <a:solidFill>
                 <a:srgbClr val="000000"/>
               </a:solidFill>
@@ -10081,7 +9335,7 @@
               <a:buNone/>
             </a:pPr>
             <a:r>
-              <a:rPr lang="en-US" b="1" noProof="1">
+              <a:rPr lang="en-US" sz="1400" b="1" noProof="1">
                 <a:solidFill>
                   <a:srgbClr val="000000"/>
                 </a:solidFill>
@@ -10099,7 +9353,7 @@
               <a:buNone/>
             </a:pPr>
             <a:r>
-              <a:rPr lang="en-US" b="1" noProof="1">
+              <a:rPr lang="en-US" sz="1400" b="1" noProof="1">
                 <a:solidFill>
                   <a:srgbClr val="6A5221"/>
                 </a:solidFill>
@@ -10109,7 +9363,7 @@
               <a:t>print</a:t>
             </a:r>
             <a:r>
-              <a:rPr lang="en-US" b="1" noProof="1">
+              <a:rPr lang="en-US" sz="1400" b="1" noProof="1">
                 <a:solidFill>
                   <a:srgbClr val="000000"/>
                 </a:solidFill>
@@ -10119,7 +9373,7 @@
               <a:t>(</a:t>
             </a:r>
             <a:r>
-              <a:rPr lang="en-US" b="1" noProof="1">
+              <a:rPr lang="en-US" sz="1400" b="1" noProof="1">
                 <a:solidFill>
                   <a:srgbClr val="A31515"/>
                 </a:solidFill>
@@ -10129,7 +9383,7 @@
               <a:t>"Predictions:"</a:t>
             </a:r>
             <a:r>
-              <a:rPr lang="en-US" b="1" noProof="1">
+              <a:rPr lang="en-US" sz="1400" b="1" noProof="1">
                 <a:solidFill>
                   <a:srgbClr val="000000"/>
                 </a:solidFill>
@@ -10450,20 +9704,20 @@
 </file>
 
 <file path=customXml/item1.xml><?xml version="1.0" encoding="utf-8"?>
+<p:properties xmlns:p="http://schemas.microsoft.com/office/2006/metadata/properties" xmlns:xsi="http://www.w3.org/2001/XMLSchema-instance" xmlns:pc="http://schemas.microsoft.com/office/infopath/2007/PartnerControls">
+  <documentManagement>
+    <_activity xmlns="5d9e8ea6-d7cf-4c00-b931-0c0027af1451" xsi:nil="true"/>
+  </documentManagement>
+</p:properties>
+</file>
+
+<file path=customXml/item2.xml><?xml version="1.0" encoding="utf-8"?>
 <?mso-contentType ?>
 <FormTemplates xmlns="http://schemas.microsoft.com/sharepoint/v3/contenttype/forms">
   <Display>DocumentLibraryForm</Display>
   <Edit>DocumentLibraryForm</Edit>
   <New>DocumentLibraryForm</New>
 </FormTemplates>
-</file>
-
-<file path=customXml/item2.xml><?xml version="1.0" encoding="utf-8"?>
-<p:properties xmlns:p="http://schemas.microsoft.com/office/2006/metadata/properties" xmlns:xsi="http://www.w3.org/2001/XMLSchema-instance" xmlns:pc="http://schemas.microsoft.com/office/infopath/2007/PartnerControls">
-  <documentManagement>
-    <_activity xmlns="5d9e8ea6-d7cf-4c00-b931-0c0027af1451" xsi:nil="true"/>
-  </documentManagement>
-</p:properties>
 </file>
 
 <file path=customXml/item3.xml><?xml version="1.0" encoding="utf-8"?>
@@ -10714,14 +9968,6 @@
 </file>
 
 <file path=customXml/itemProps1.xml><?xml version="1.0" encoding="utf-8"?>
-<ds:datastoreItem xmlns:ds="http://schemas.openxmlformats.org/officeDocument/2006/customXml" ds:itemID="{45A00539-F935-4DAE-994B-29A86868AB4E}">
-  <ds:schemaRefs>
-    <ds:schemaRef ds:uri="http://schemas.microsoft.com/sharepoint/v3/contenttype/forms"/>
-  </ds:schemaRefs>
-</ds:datastoreItem>
-</file>
-
-<file path=customXml/itemProps2.xml><?xml version="1.0" encoding="utf-8"?>
 <ds:datastoreItem xmlns:ds="http://schemas.openxmlformats.org/officeDocument/2006/customXml" ds:itemID="{68AC1CE2-5BE4-4AD4-8A18-FE1BD98D2BAF}">
   <ds:schemaRefs>
     <ds:schemaRef ds:uri="http://purl.org/dc/elements/1.1/"/>
@@ -10734,6 +9980,14 @@
     <ds:schemaRef ds:uri="24b8453d-154c-4c63-97d1-80f7846f6991"/>
     <ds:schemaRef ds:uri="5d9e8ea6-d7cf-4c00-b931-0c0027af1451"/>
     <ds:schemaRef ds:uri="http://purl.org/dc/terms/"/>
+  </ds:schemaRefs>
+</ds:datastoreItem>
+</file>
+
+<file path=customXml/itemProps2.xml><?xml version="1.0" encoding="utf-8"?>
+<ds:datastoreItem xmlns:ds="http://schemas.openxmlformats.org/officeDocument/2006/customXml" ds:itemID="{45A00539-F935-4DAE-994B-29A86868AB4E}">
+  <ds:schemaRefs>
+    <ds:schemaRef ds:uri="http://schemas.microsoft.com/sharepoint/v3/contenttype/forms"/>
   </ds:schemaRefs>
 </ds:datastoreItem>
 </file>

</xml_diff>